<commit_message>
Add categorized triplet atlas and OOS replay
</commit_message>
<xml_diff>
--- a/presentations/gen5_lit_mr_03_1_johansen_triplets_evidence.pptx
+++ b/presentations/gen5_lit_mr_03_1_johansen_triplets_evidence.pptx
@@ -2,29 +2,37 @@
 <file path=ppt/presentation.xml><?xml version="1.0" encoding="utf-8"?>
 <p:presentation xmlns:p="http://schemas.openxmlformats.org/presentationml/2006/main">
   <p:sldMasterIdLst>
-    <p:sldMasterId xmlns:r="http://schemas.openxmlformats.org/officeDocument/2006/relationships" id="2147483648" r:id="R735cadacbb084fe7"/>
+    <p:sldMasterId xmlns:r="http://schemas.openxmlformats.org/officeDocument/2006/relationships" id="2147483648" r:id="R48e1ec13e5534184"/>
   </p:sldMasterIdLst>
   <p:notesMasterIdLst>
-    <p:notesMasterId xmlns:r="http://schemas.openxmlformats.org/officeDocument/2006/relationships" r:id="R1578da46e450415a"/>
+    <p:notesMasterId xmlns:r="http://schemas.openxmlformats.org/officeDocument/2006/relationships" r:id="R2be9852c73394b39"/>
   </p:notesMasterIdLst>
   <p:sldIdLst>
-    <p:sldId xmlns:r="http://schemas.openxmlformats.org/officeDocument/2006/relationships" id="256" r:id="R03524df5aef84667"/>
-    <p:sldId xmlns:r="http://schemas.openxmlformats.org/officeDocument/2006/relationships" id="257" r:id="Rdab53e84176147b5"/>
-    <p:sldId xmlns:r="http://schemas.openxmlformats.org/officeDocument/2006/relationships" id="258" r:id="Rc5a2b377d59d441b"/>
-    <p:sldId xmlns:r="http://schemas.openxmlformats.org/officeDocument/2006/relationships" id="259" r:id="R5022d94273774918"/>
-    <p:sldId xmlns:r="http://schemas.openxmlformats.org/officeDocument/2006/relationships" id="260" r:id="R0c2eafb802144c7d"/>
-    <p:sldId xmlns:r="http://schemas.openxmlformats.org/officeDocument/2006/relationships" id="261" r:id="R3ef8f1b5a525482a"/>
-    <p:sldId xmlns:r="http://schemas.openxmlformats.org/officeDocument/2006/relationships" id="262" r:id="R2b0eb3ad66914c70"/>
-    <p:sldId xmlns:r="http://schemas.openxmlformats.org/officeDocument/2006/relationships" id="263" r:id="Rc3a6be65762f46ed"/>
-    <p:sldId xmlns:r="http://schemas.openxmlformats.org/officeDocument/2006/relationships" id="264" r:id="Rf2ccf79eb06a446a"/>
-    <p:sldId xmlns:r="http://schemas.openxmlformats.org/officeDocument/2006/relationships" id="265" r:id="R88fc48ad418f4bae"/>
-    <p:sldId xmlns:r="http://schemas.openxmlformats.org/officeDocument/2006/relationships" id="266" r:id="R3c1d2708e8e4430c"/>
-    <p:sldId xmlns:r="http://schemas.openxmlformats.org/officeDocument/2006/relationships" id="267" r:id="Rf1aa577df71b4371"/>
-    <p:sldId xmlns:r="http://schemas.openxmlformats.org/officeDocument/2006/relationships" id="268" r:id="Rd62b989eab744351"/>
-    <p:sldId xmlns:r="http://schemas.openxmlformats.org/officeDocument/2006/relationships" id="269" r:id="Rbbc485ec0b404dc9"/>
-    <p:sldId xmlns:r="http://schemas.openxmlformats.org/officeDocument/2006/relationships" id="270" r:id="R6c14ff785bb14119"/>
-    <p:sldId xmlns:r="http://schemas.openxmlformats.org/officeDocument/2006/relationships" id="271" r:id="Rf1a899fda132434d"/>
-    <p:sldId xmlns:r="http://schemas.openxmlformats.org/officeDocument/2006/relationships" id="272" r:id="Rf095f381d52649aa"/>
+    <p:sldId xmlns:r="http://schemas.openxmlformats.org/officeDocument/2006/relationships" id="256" r:id="R39a0f08efb634006"/>
+    <p:sldId xmlns:r="http://schemas.openxmlformats.org/officeDocument/2006/relationships" id="257" r:id="R2aa7ca89242c4910"/>
+    <p:sldId xmlns:r="http://schemas.openxmlformats.org/officeDocument/2006/relationships" id="258" r:id="R41b651b24e07453c"/>
+    <p:sldId xmlns:r="http://schemas.openxmlformats.org/officeDocument/2006/relationships" id="259" r:id="Rff97b2f021774c19"/>
+    <p:sldId xmlns:r="http://schemas.openxmlformats.org/officeDocument/2006/relationships" id="260" r:id="R82b57bb2e2d54126"/>
+    <p:sldId xmlns:r="http://schemas.openxmlformats.org/officeDocument/2006/relationships" id="261" r:id="R2174c0bce4b3438d"/>
+    <p:sldId xmlns:r="http://schemas.openxmlformats.org/officeDocument/2006/relationships" id="262" r:id="Rf9f684e77d384baf"/>
+    <p:sldId xmlns:r="http://schemas.openxmlformats.org/officeDocument/2006/relationships" id="263" r:id="R814712e2e6874098"/>
+    <p:sldId xmlns:r="http://schemas.openxmlformats.org/officeDocument/2006/relationships" id="264" r:id="Rfee149d5e5624306"/>
+    <p:sldId xmlns:r="http://schemas.openxmlformats.org/officeDocument/2006/relationships" id="265" r:id="R020597701add4f7d"/>
+    <p:sldId xmlns:r="http://schemas.openxmlformats.org/officeDocument/2006/relationships" id="266" r:id="R64f78be6caf94aae"/>
+    <p:sldId xmlns:r="http://schemas.openxmlformats.org/officeDocument/2006/relationships" id="267" r:id="R833c5d27549d4e98"/>
+    <p:sldId xmlns:r="http://schemas.openxmlformats.org/officeDocument/2006/relationships" id="268" r:id="R1ae3d4f1cbc84267"/>
+    <p:sldId xmlns:r="http://schemas.openxmlformats.org/officeDocument/2006/relationships" id="269" r:id="Rce49a2ca05a74f8a"/>
+    <p:sldId xmlns:r="http://schemas.openxmlformats.org/officeDocument/2006/relationships" id="270" r:id="R453c78f7de3842fa"/>
+    <p:sldId xmlns:r="http://schemas.openxmlformats.org/officeDocument/2006/relationships" id="271" r:id="R22e56223d2044dc8"/>
+    <p:sldId xmlns:r="http://schemas.openxmlformats.org/officeDocument/2006/relationships" id="272" r:id="R7363ecfdb0ee4a61"/>
+    <p:sldId xmlns:r="http://schemas.openxmlformats.org/officeDocument/2006/relationships" id="273" r:id="Refd17a69009b4bbd"/>
+    <p:sldId xmlns:r="http://schemas.openxmlformats.org/officeDocument/2006/relationships" id="274" r:id="Rfe44d7e5cc8d4377"/>
+    <p:sldId xmlns:r="http://schemas.openxmlformats.org/officeDocument/2006/relationships" id="275" r:id="Rdc680931f53e400e"/>
+    <p:sldId xmlns:r="http://schemas.openxmlformats.org/officeDocument/2006/relationships" id="276" r:id="R5766863343db4c0d"/>
+    <p:sldId xmlns:r="http://schemas.openxmlformats.org/officeDocument/2006/relationships" id="277" r:id="R2e682a1ae46a49fb"/>
+    <p:sldId xmlns:r="http://schemas.openxmlformats.org/officeDocument/2006/relationships" id="278" r:id="R01fefd989f994812"/>
+    <p:sldId xmlns:r="http://schemas.openxmlformats.org/officeDocument/2006/relationships" id="279" r:id="Rae143c20d7a14e82"/>
+    <p:sldId xmlns:r="http://schemas.openxmlformats.org/officeDocument/2006/relationships" id="280" r:id="Rf4e75419f8d04d6f"/>
   </p:sldIdLst>
   <p:sldSz cx="12192000" cy="6858000"/>
   <p:notesSz cx="6858000" cy="9144000"/>
@@ -1268,6 +1276,196 @@
 </p:notes>
 </file>
 
+<file path=ppt/notesSlides/notesSlide18.xml><?xml version="1.0" encoding="utf-8"?>
+<p:notes xmlns:p="http://schemas.openxmlformats.org/presentationml/2006/main">
+  <p:cSld>
+    <p:spTree>
+      <p:nvGrpSpPr>
+        <p:cNvPr id="1" name=""/>
+        <p:cNvGrpSpPr/>
+        <p:nvPr/>
+      </p:nvGrpSpPr>
+      <p:grpSpPr>
+        <a:xfrm xmlns:a="http://schemas.openxmlformats.org/drawingml/2006/main"/>
+      </p:grpSpPr>
+      <p:sp>
+        <p:nvSpPr>
+          <p:cNvPr id="2" name="Slide Image Placeholder 1"/>
+          <p:cNvSpPr>
+            <a:spLocks xmlns:a="http://schemas.openxmlformats.org/drawingml/2006/main" noGrp="1"/>
+          </p:cNvSpPr>
+          <p:nvPr>
+            <p:ph type="sldImg" idx="0"/>
+          </p:nvPr>
+        </p:nvSpPr>
+        <p:spPr/>
+      </p:sp>
+      <p:sp>
+        <p:nvSpPr>
+          <p:cNvPr id="3" name="Notes Placeholder 2"/>
+          <p:cNvSpPr>
+            <a:spLocks xmlns:a="http://schemas.openxmlformats.org/drawingml/2006/main" noGrp="1"/>
+          </p:cNvSpPr>
+          <p:nvPr>
+            <p:ph type="body" idx="1"/>
+          </p:nvPr>
+        </p:nvSpPr>
+        <p:spPr/>
+        <p:txBody>
+          <a:bodyPr xmlns:a="http://schemas.openxmlformats.org/drawingml/2006/main"/>
+          <a:lstStyle xmlns:a="http://schemas.openxmlformats.org/drawingml/2006/main"/>
+          <a:p xmlns:a="http://schemas.openxmlformats.org/drawingml/2006/main">
+            <a:r>
+              <a:t>This section extends the original eight-triplet POC without changing its mechanics or reversing its STOP. The atlas is a separately frozen breadth batch.</a:t>
+            </a:r>
+          </a:p>
+          <a:p xmlns:a="http://schemas.openxmlformats.org/drawingml/2006/main">
+            <a:r>
+              <a:t/>
+            </a:r>
+          </a:p>
+          <a:p xmlns:a="http://schemas.openxmlformats.org/drawingml/2006/main">
+            <a:r>
+              <a:t>[Sources]</a:t>
+            </a:r>
+          </a:p>
+          <a:p xmlns:a="http://schemas.openxmlformats.org/drawingml/2006/main">
+            <a:r>
+              <a:t>- C:/Users/Franc/OneDrive/Documents/Francis/Peltata Project/Time-Series-Modeling-Gen5/docs/GEN5_LIT_MR_03_1_TRIPLET_ATLAS_01_CONTRACT.md</a:t>
+            </a:r>
+          </a:p>
+          <a:p xmlns:a="http://schemas.openxmlformats.org/drawingml/2006/main">
+            <a:r>
+              <a:t>- C:/Users/Franc/OneDrive/Documents/Francis/Peltata Project/Time-Series-Modeling-Gen5/runs/research_workbench/literature_grounded/lit_mr_03_1_triplet_atlas_01_20260729/mr03_triplet_registry.csv</a:t>
+            </a:r>
+          </a:p>
+          <a:p xmlns:a="http://schemas.openxmlformats.org/drawingml/2006/main">
+            <a:r>
+              <a:t>- C:/Users/Franc/OneDrive/Documents/Francis/Peltata Project/Time-Series-Modeling-Gen5/docs/GEN5_4_DECISION_DIALOGUE_INDEX.md — D78</a:t>
+            </a:r>
+          </a:p>
+        </p:txBody>
+      </p:sp>
+      <p:sp>
+        <p:nvSpPr>
+          <p:cNvPr id="4" name="Slide Number Placeholder 3"/>
+          <p:cNvSpPr>
+            <a:spLocks xmlns:a="http://schemas.openxmlformats.org/drawingml/2006/main" noGrp="1"/>
+          </p:cNvSpPr>
+          <p:nvPr>
+            <p:ph type="sldNum" idx="5"/>
+          </p:nvPr>
+        </p:nvSpPr>
+        <p:spPr/>
+        <p:txBody>
+          <a:bodyPr xmlns:a="http://schemas.openxmlformats.org/drawingml/2006/main"/>
+          <a:lstStyle xmlns:a="http://schemas.openxmlformats.org/drawingml/2006/main"/>
+          <a:p xmlns:a="http://schemas.openxmlformats.org/drawingml/2006/main"/>
+        </p:txBody>
+      </p:sp>
+    </p:spTree>
+  </p:cSld>
+  <p:clrMapOvr>
+    <a:masterClrMapping xmlns:a="http://schemas.openxmlformats.org/drawingml/2006/main"/>
+  </p:clrMapOvr>
+</p:notes>
+</file>
+
+<file path=ppt/notesSlides/notesSlide19.xml><?xml version="1.0" encoding="utf-8"?>
+<p:notes xmlns:p="http://schemas.openxmlformats.org/presentationml/2006/main">
+  <p:cSld>
+    <p:spTree>
+      <p:nvGrpSpPr>
+        <p:cNvPr id="1" name=""/>
+        <p:cNvGrpSpPr/>
+        <p:nvPr/>
+      </p:nvGrpSpPr>
+      <p:grpSpPr>
+        <a:xfrm xmlns:a="http://schemas.openxmlformats.org/drawingml/2006/main"/>
+      </p:grpSpPr>
+      <p:sp>
+        <p:nvSpPr>
+          <p:cNvPr id="2" name="Slide Image Placeholder 1"/>
+          <p:cNvSpPr>
+            <a:spLocks xmlns:a="http://schemas.openxmlformats.org/drawingml/2006/main" noGrp="1"/>
+          </p:cNvSpPr>
+          <p:nvPr>
+            <p:ph type="sldImg" idx="0"/>
+          </p:nvPr>
+        </p:nvSpPr>
+        <p:spPr/>
+      </p:sp>
+      <p:sp>
+        <p:nvSpPr>
+          <p:cNvPr id="3" name="Notes Placeholder 2"/>
+          <p:cNvSpPr>
+            <a:spLocks xmlns:a="http://schemas.openxmlformats.org/drawingml/2006/main" noGrp="1"/>
+          </p:cNvSpPr>
+          <p:nvPr>
+            <p:ph type="body" idx="1"/>
+          </p:nvPr>
+        </p:nvSpPr>
+        <p:spPr/>
+        <p:txBody>
+          <a:bodyPr xmlns:a="http://schemas.openxmlformats.org/drawingml/2006/main"/>
+          <a:lstStyle xmlns:a="http://schemas.openxmlformats.org/drawingml/2006/main"/>
+          <a:p xmlns:a="http://schemas.openxmlformats.org/drawingml/2006/main">
+            <a:r>
+              <a:t>The country/macro category is explicitly softer than duplicate-claim or term-structure hypotheses. The registry is finite and frozen in contract order.</a:t>
+            </a:r>
+          </a:p>
+          <a:p xmlns:a="http://schemas.openxmlformats.org/drawingml/2006/main">
+            <a:r>
+              <a:t/>
+            </a:r>
+          </a:p>
+          <a:p xmlns:a="http://schemas.openxmlformats.org/drawingml/2006/main">
+            <a:r>
+              <a:t>[Sources]</a:t>
+            </a:r>
+          </a:p>
+          <a:p xmlns:a="http://schemas.openxmlformats.org/drawingml/2006/main">
+            <a:r>
+              <a:t>- C:/Users/Franc/OneDrive/Documents/Francis/Peltata Project/Time-Series-Modeling-Gen5/docs/GEN5_LIT_MR_03_1_TRIPLET_ATLAS_01_CONTRACT.md</a:t>
+            </a:r>
+          </a:p>
+          <a:p xmlns:a="http://schemas.openxmlformats.org/drawingml/2006/main">
+            <a:r>
+              <a:t>- C:/Users/Franc/OneDrive/Documents/Francis/Peltata Project/Time-Series-Modeling-Gen5/runs/research_workbench/literature_grounded/lit_mr_03_1_triplet_atlas_01_20260729/mr03_triplet_registry.csv</a:t>
+            </a:r>
+          </a:p>
+          <a:p xmlns:a="http://schemas.openxmlformats.org/drawingml/2006/main">
+            <a:r>
+              <a:t>- C:/Users/Franc/OneDrive/Documents/Francis/Peltata Project/Time-Series-Modeling-Gen5/docs/GEN5_4_DECISION_DIALOGUE_INDEX.md — D78</a:t>
+            </a:r>
+          </a:p>
+        </p:txBody>
+      </p:sp>
+      <p:sp>
+        <p:nvSpPr>
+          <p:cNvPr id="4" name="Slide Number Placeholder 3"/>
+          <p:cNvSpPr>
+            <a:spLocks xmlns:a="http://schemas.openxmlformats.org/drawingml/2006/main" noGrp="1"/>
+          </p:cNvSpPr>
+          <p:nvPr>
+            <p:ph type="sldNum" idx="5"/>
+          </p:nvPr>
+        </p:nvSpPr>
+        <p:spPr/>
+        <p:txBody>
+          <a:bodyPr xmlns:a="http://schemas.openxmlformats.org/drawingml/2006/main"/>
+          <a:lstStyle xmlns:a="http://schemas.openxmlformats.org/drawingml/2006/main"/>
+          <a:p xmlns:a="http://schemas.openxmlformats.org/drawingml/2006/main"/>
+        </p:txBody>
+      </p:sp>
+    </p:spTree>
+  </p:cSld>
+  <p:clrMapOvr>
+    <a:masterClrMapping xmlns:a="http://schemas.openxmlformats.org/drawingml/2006/main"/>
+  </p:clrMapOvr>
+</p:notes>
+</file>
+
 <file path=ppt/notesSlides/notesSlide2.xml><?xml version="1.0" encoding="utf-8"?>
 <p:notes xmlns:p="http://schemas.openxmlformats.org/presentationml/2006/main">
   <p:cSld>
@@ -1334,6 +1532,601 @@
           <a:p xmlns:a="http://schemas.openxmlformats.org/drawingml/2006/main">
             <a:r>
               <a:t>- C:/Users/Franc/OneDrive/Documents/Francis/Peltata Project/Time-Series-Modeling-Gen5/docs/GEN5_4_DECISION_DIALOGUE_INDEX.md — D74</a:t>
+            </a:r>
+          </a:p>
+        </p:txBody>
+      </p:sp>
+      <p:sp>
+        <p:nvSpPr>
+          <p:cNvPr id="4" name="Slide Number Placeholder 3"/>
+          <p:cNvSpPr>
+            <a:spLocks xmlns:a="http://schemas.openxmlformats.org/drawingml/2006/main" noGrp="1"/>
+          </p:cNvSpPr>
+          <p:nvPr>
+            <p:ph type="sldNum" idx="5"/>
+          </p:nvPr>
+        </p:nvSpPr>
+        <p:spPr/>
+        <p:txBody>
+          <a:bodyPr xmlns:a="http://schemas.openxmlformats.org/drawingml/2006/main"/>
+          <a:lstStyle xmlns:a="http://schemas.openxmlformats.org/drawingml/2006/main"/>
+          <a:p xmlns:a="http://schemas.openxmlformats.org/drawingml/2006/main"/>
+        </p:txBody>
+      </p:sp>
+    </p:spTree>
+  </p:cSld>
+  <p:clrMapOvr>
+    <a:masterClrMapping xmlns:a="http://schemas.openxmlformats.org/drawingml/2006/main"/>
+  </p:clrMapOvr>
+</p:notes>
+</file>
+
+<file path=ppt/notesSlides/notesSlide20.xml><?xml version="1.0" encoding="utf-8"?>
+<p:notes xmlns:p="http://schemas.openxmlformats.org/presentationml/2006/main">
+  <p:cSld>
+    <p:spTree>
+      <p:nvGrpSpPr>
+        <p:cNvPr id="1" name=""/>
+        <p:cNvGrpSpPr/>
+        <p:nvPr/>
+      </p:nvGrpSpPr>
+      <p:grpSpPr>
+        <a:xfrm xmlns:a="http://schemas.openxmlformats.org/drawingml/2006/main"/>
+      </p:grpSpPr>
+      <p:sp>
+        <p:nvSpPr>
+          <p:cNvPr id="2" name="Slide Image Placeholder 1"/>
+          <p:cNvSpPr>
+            <a:spLocks xmlns:a="http://schemas.openxmlformats.org/drawingml/2006/main" noGrp="1"/>
+          </p:cNvSpPr>
+          <p:nvPr>
+            <p:ph type="sldImg" idx="0"/>
+          </p:nvPr>
+        </p:nvSpPr>
+        <p:spPr/>
+      </p:sp>
+      <p:sp>
+        <p:nvSpPr>
+          <p:cNvPr id="3" name="Notes Placeholder 2"/>
+          <p:cNvSpPr>
+            <a:spLocks xmlns:a="http://schemas.openxmlformats.org/drawingml/2006/main" noGrp="1"/>
+          </p:cNvSpPr>
+          <p:nvPr>
+            <p:ph type="body" idx="1"/>
+          </p:nvPr>
+        </p:nvSpPr>
+        <p:spPr/>
+        <p:txBody>
+          <a:bodyPr xmlns:a="http://schemas.openxmlformats.org/drawingml/2006/main"/>
+          <a:lstStyle xmlns:a="http://schemas.openxmlformats.org/drawingml/2006/main"/>
+          <a:p xmlns:a="http://schemas.openxmlformats.org/drawingml/2006/main">
+            <a:r>
+              <a:t>The eight-gate conjunction is not a formal family-wise-error correction. A TRAIN pass authorizes one OOS test; it is not validation.</a:t>
+            </a:r>
+          </a:p>
+          <a:p xmlns:a="http://schemas.openxmlformats.org/drawingml/2006/main">
+            <a:r>
+              <a:t/>
+            </a:r>
+          </a:p>
+          <a:p xmlns:a="http://schemas.openxmlformats.org/drawingml/2006/main">
+            <a:r>
+              <a:t>[Sources]</a:t>
+            </a:r>
+          </a:p>
+          <a:p xmlns:a="http://schemas.openxmlformats.org/drawingml/2006/main">
+            <a:r>
+              <a:t>- C:/Users/Franc/OneDrive/Documents/Francis/Peltata Project/Time-Series-Modeling-Gen5/docs/GEN5_LIT_MR_03_1_TRIPLET_ATLAS_01_CONTRACT.md</a:t>
+            </a:r>
+          </a:p>
+          <a:p xmlns:a="http://schemas.openxmlformats.org/drawingml/2006/main">
+            <a:r>
+              <a:t>- C:/Users/Franc/OneDrive/Documents/Francis/Peltata Project/Time-Series-Modeling-Gen5/runs/research_workbench/literature_grounded/lit_mr_03_1_triplet_atlas_01_20260729/mr03_run_spec.csv</a:t>
+            </a:r>
+          </a:p>
+          <a:p xmlns:a="http://schemas.openxmlformats.org/drawingml/2006/main">
+            <a:r>
+              <a:t>- C:/Users/Franc/OneDrive/Documents/Francis/Peltata Project/Time-Series-Modeling-Gen5/docs/GEN5_4_DECISION_DIALOGUE_INDEX.md — D78 and D80</a:t>
+            </a:r>
+          </a:p>
+        </p:txBody>
+      </p:sp>
+      <p:sp>
+        <p:nvSpPr>
+          <p:cNvPr id="4" name="Slide Number Placeholder 3"/>
+          <p:cNvSpPr>
+            <a:spLocks xmlns:a="http://schemas.openxmlformats.org/drawingml/2006/main" noGrp="1"/>
+          </p:cNvSpPr>
+          <p:nvPr>
+            <p:ph type="sldNum" idx="5"/>
+          </p:nvPr>
+        </p:nvSpPr>
+        <p:spPr/>
+        <p:txBody>
+          <a:bodyPr xmlns:a="http://schemas.openxmlformats.org/drawingml/2006/main"/>
+          <a:lstStyle xmlns:a="http://schemas.openxmlformats.org/drawingml/2006/main"/>
+          <a:p xmlns:a="http://schemas.openxmlformats.org/drawingml/2006/main"/>
+        </p:txBody>
+      </p:sp>
+    </p:spTree>
+  </p:cSld>
+  <p:clrMapOvr>
+    <a:masterClrMapping xmlns:a="http://schemas.openxmlformats.org/drawingml/2006/main"/>
+  </p:clrMapOvr>
+</p:notes>
+</file>
+
+<file path=ppt/notesSlides/notesSlide21.xml><?xml version="1.0" encoding="utf-8"?>
+<p:notes xmlns:p="http://schemas.openxmlformats.org/presentationml/2006/main">
+  <p:cSld>
+    <p:spTree>
+      <p:nvGrpSpPr>
+        <p:cNvPr id="1" name=""/>
+        <p:cNvGrpSpPr/>
+        <p:nvPr/>
+      </p:nvGrpSpPr>
+      <p:grpSpPr>
+        <a:xfrm xmlns:a="http://schemas.openxmlformats.org/drawingml/2006/main"/>
+      </p:grpSpPr>
+      <p:sp>
+        <p:nvSpPr>
+          <p:cNvPr id="2" name="Slide Image Placeholder 1"/>
+          <p:cNvSpPr>
+            <a:spLocks xmlns:a="http://schemas.openxmlformats.org/drawingml/2006/main" noGrp="1"/>
+          </p:cNvSpPr>
+          <p:nvPr>
+            <p:ph type="sldImg" idx="0"/>
+          </p:nvPr>
+        </p:nvSpPr>
+        <p:spPr/>
+      </p:sp>
+      <p:sp>
+        <p:nvSpPr>
+          <p:cNvPr id="3" name="Notes Placeholder 2"/>
+          <p:cNvSpPr>
+            <a:spLocks xmlns:a="http://schemas.openxmlformats.org/drawingml/2006/main" noGrp="1"/>
+          </p:cNvSpPr>
+          <p:nvPr>
+            <p:ph type="body" idx="1"/>
+          </p:nvPr>
+        </p:nvSpPr>
+        <p:spPr/>
+        <p:txBody>
+          <a:bodyPr xmlns:a="http://schemas.openxmlformats.org/drawingml/2006/main"/>
+          <a:lstStyle xmlns:a="http://schemas.openxmlformats.org/drawingml/2006/main"/>
+          <a:p xmlns:a="http://schemas.openxmlformats.org/drawingml/2006/main">
+            <a:r>
+              <a:t>Ten of 28 candidates passed exact rank one. Positive mean returns were concentrated outside near-substitute and curve cells. Only the country/macro cell produced a full eight-gate nomination.</a:t>
+            </a:r>
+          </a:p>
+          <a:p xmlns:a="http://schemas.openxmlformats.org/drawingml/2006/main">
+            <a:r>
+              <a:t/>
+            </a:r>
+          </a:p>
+          <a:p xmlns:a="http://schemas.openxmlformats.org/drawingml/2006/main">
+            <a:r>
+              <a:t>[Sources]</a:t>
+            </a:r>
+          </a:p>
+          <a:p xmlns:a="http://schemas.openxmlformats.org/drawingml/2006/main">
+            <a:r>
+              <a:t>- C:/Users/Franc/OneDrive/Documents/Francis/Peltata Project/Time-Series-Modeling-Gen5/runs/research_workbench/literature_grounded/lit_mr_03_1_triplet_atlas_01_20260729/mr03_category_summary.csv</a:t>
+            </a:r>
+          </a:p>
+          <a:p xmlns:a="http://schemas.openxmlformats.org/drawingml/2006/main">
+            <a:r>
+              <a:t>- C:/Users/Franc/OneDrive/Documents/Francis/Peltata Project/Time-Series-Modeling-Gen5/runs/research_workbench/literature_grounded/lit_mr_03_1_triplet_atlas_01_20260729/visuals/mr03_category_summary.png</a:t>
+            </a:r>
+          </a:p>
+          <a:p xmlns:a="http://schemas.openxmlformats.org/drawingml/2006/main">
+            <a:r>
+              <a:t>- C:/Users/Franc/OneDrive/Documents/Francis/Peltata Project/Time-Series-Modeling-Gen5/docs/GEN5_LIT_MR_03_1_TRIPLET_ATLAS_01_CONTRACT.md</a:t>
+            </a:r>
+          </a:p>
+        </p:txBody>
+      </p:sp>
+      <p:sp>
+        <p:nvSpPr>
+          <p:cNvPr id="4" name="Slide Number Placeholder 3"/>
+          <p:cNvSpPr>
+            <a:spLocks xmlns:a="http://schemas.openxmlformats.org/drawingml/2006/main" noGrp="1"/>
+          </p:cNvSpPr>
+          <p:nvPr>
+            <p:ph type="sldNum" idx="5"/>
+          </p:nvPr>
+        </p:nvSpPr>
+        <p:spPr/>
+        <p:txBody>
+          <a:bodyPr xmlns:a="http://schemas.openxmlformats.org/drawingml/2006/main"/>
+          <a:lstStyle xmlns:a="http://schemas.openxmlformats.org/drawingml/2006/main"/>
+          <a:p xmlns:a="http://schemas.openxmlformats.org/drawingml/2006/main"/>
+        </p:txBody>
+      </p:sp>
+    </p:spTree>
+  </p:cSld>
+  <p:clrMapOvr>
+    <a:masterClrMapping xmlns:a="http://schemas.openxmlformats.org/drawingml/2006/main"/>
+  </p:clrMapOvr>
+</p:notes>
+</file>
+
+<file path=ppt/notesSlides/notesSlide22.xml><?xml version="1.0" encoding="utf-8"?>
+<p:notes xmlns:p="http://schemas.openxmlformats.org/presentationml/2006/main">
+  <p:cSld>
+    <p:spTree>
+      <p:nvGrpSpPr>
+        <p:cNvPr id="1" name=""/>
+        <p:cNvGrpSpPr/>
+        <p:nvPr/>
+      </p:nvGrpSpPr>
+      <p:grpSpPr>
+        <a:xfrm xmlns:a="http://schemas.openxmlformats.org/drawingml/2006/main"/>
+      </p:grpSpPr>
+      <p:sp>
+        <p:nvSpPr>
+          <p:cNvPr id="2" name="Slide Image Placeholder 1"/>
+          <p:cNvSpPr>
+            <a:spLocks xmlns:a="http://schemas.openxmlformats.org/drawingml/2006/main" noGrp="1"/>
+          </p:cNvSpPr>
+          <p:nvPr>
+            <p:ph type="sldImg" idx="0"/>
+          </p:nvPr>
+        </p:nvSpPr>
+        <p:spPr/>
+      </p:sp>
+      <p:sp>
+        <p:nvSpPr>
+          <p:cNvPr id="3" name="Notes Placeholder 2"/>
+          <p:cNvSpPr>
+            <a:spLocks xmlns:a="http://schemas.openxmlformats.org/drawingml/2006/main" noGrp="1"/>
+          </p:cNvSpPr>
+          <p:nvPr>
+            <p:ph type="body" idx="1"/>
+          </p:nvPr>
+        </p:nvSpPr>
+        <p:spPr/>
+        <p:txBody>
+          <a:bodyPr xmlns:a="http://schemas.openxmlformats.org/drawingml/2006/main"/>
+          <a:lstStyle xmlns:a="http://schemas.openxmlformats.org/drawingml/2006/main"/>
+          <a:p xmlns:a="http://schemas.openxmlformats.org/drawingml/2006/main">
+            <a:r>
+              <a:t>The data-health WARN reflects bounded 2020 history being stale relative to the explicit 2026 as-of timestamp. All 78 required symbols covered the requested TRAIN interval after refresh.</a:t>
+            </a:r>
+          </a:p>
+          <a:p xmlns:a="http://schemas.openxmlformats.org/drawingml/2006/main">
+            <a:r>
+              <a:t/>
+            </a:r>
+          </a:p>
+          <a:p xmlns:a="http://schemas.openxmlformats.org/drawingml/2006/main">
+            <a:r>
+              <a:t>[Sources]</a:t>
+            </a:r>
+          </a:p>
+          <a:p xmlns:a="http://schemas.openxmlformats.org/drawingml/2006/main">
+            <a:r>
+              <a:t>- C:/Users/Franc/OneDrive/Documents/Francis/Peltata Project/Time-Series-Modeling-Gen5/runs/research_workbench/literature_grounded/lit_mr_03_1_triplet_atlas_01_20260729/mr03_train_gate_detail.csv</a:t>
+            </a:r>
+          </a:p>
+          <a:p xmlns:a="http://schemas.openxmlformats.org/drawingml/2006/main">
+            <a:r>
+              <a:t>- C:/Users/Franc/OneDrive/Documents/Francis/Peltata Project/Time-Series-Modeling-Gen5/runs/research_workbench/literature_grounded/lit_mr_03_1_triplet_atlas_01_20260729/mr03_train_coverage.csv</a:t>
+            </a:r>
+          </a:p>
+          <a:p xmlns:a="http://schemas.openxmlformats.org/drawingml/2006/main">
+            <a:r>
+              <a:t>- C:/Users/Franc/OneDrive/Documents/Francis/Peltata Project/Time-Series-Modeling-Gen5/runs/research_workbench/literature_grounded/lit_mr_03_1_triplet_atlas_01_20260729/mr03_train_workbench_query_health.csv</a:t>
+            </a:r>
+          </a:p>
+          <a:p xmlns:a="http://schemas.openxmlformats.org/drawingml/2006/main">
+            <a:r>
+              <a:t>- C:/Users/Franc/OneDrive/Documents/Francis/Peltata Project/Time-Series-Modeling-Gen5/docs/GEN5_4_DECISION_DIALOGUE_INDEX.md — D79 and D80</a:t>
+            </a:r>
+          </a:p>
+        </p:txBody>
+      </p:sp>
+      <p:sp>
+        <p:nvSpPr>
+          <p:cNvPr id="4" name="Slide Number Placeholder 3"/>
+          <p:cNvSpPr>
+            <a:spLocks xmlns:a="http://schemas.openxmlformats.org/drawingml/2006/main" noGrp="1"/>
+          </p:cNvSpPr>
+          <p:nvPr>
+            <p:ph type="sldNum" idx="5"/>
+          </p:nvPr>
+        </p:nvSpPr>
+        <p:spPr/>
+        <p:txBody>
+          <a:bodyPr xmlns:a="http://schemas.openxmlformats.org/drawingml/2006/main"/>
+          <a:lstStyle xmlns:a="http://schemas.openxmlformats.org/drawingml/2006/main"/>
+          <a:p xmlns:a="http://schemas.openxmlformats.org/drawingml/2006/main"/>
+        </p:txBody>
+      </p:sp>
+    </p:spTree>
+  </p:cSld>
+  <p:clrMapOvr>
+    <a:masterClrMapping xmlns:a="http://schemas.openxmlformats.org/drawingml/2006/main"/>
+  </p:clrMapOvr>
+</p:notes>
+</file>
+
+<file path=ppt/notesSlides/notesSlide23.xml><?xml version="1.0" encoding="utf-8"?>
+<p:notes xmlns:p="http://schemas.openxmlformats.org/presentationml/2006/main">
+  <p:cSld>
+    <p:spTree>
+      <p:nvGrpSpPr>
+        <p:cNvPr id="1" name=""/>
+        <p:cNvGrpSpPr/>
+        <p:nvPr/>
+      </p:nvGrpSpPr>
+      <p:grpSpPr>
+        <a:xfrm xmlns:a="http://schemas.openxmlformats.org/drawingml/2006/main"/>
+      </p:grpSpPr>
+      <p:sp>
+        <p:nvSpPr>
+          <p:cNvPr id="2" name="Slide Image Placeholder 1"/>
+          <p:cNvSpPr>
+            <a:spLocks xmlns:a="http://schemas.openxmlformats.org/drawingml/2006/main" noGrp="1"/>
+          </p:cNvSpPr>
+          <p:nvPr>
+            <p:ph type="sldImg" idx="0"/>
+          </p:nvPr>
+        </p:nvSpPr>
+        <p:spPr/>
+      </p:sp>
+      <p:sp>
+        <p:nvSpPr>
+          <p:cNvPr id="3" name="Notes Placeholder 2"/>
+          <p:cNvSpPr>
+            <a:spLocks xmlns:a="http://schemas.openxmlformats.org/drawingml/2006/main" noGrp="1"/>
+          </p:cNvSpPr>
+          <p:nvPr>
+            <p:ph type="body" idx="1"/>
+          </p:nvPr>
+        </p:nvSpPr>
+        <p:spPr/>
+        <p:txBody>
+          <a:bodyPr xmlns:a="http://schemas.openxmlformats.org/drawingml/2006/main"/>
+          <a:lstStyle xmlns:a="http://schemas.openxmlformats.org/drawingml/2006/main"/>
+          <a:p xmlns:a="http://schemas.openxmlformats.org/drawingml/2006/main">
+            <a:r>
+              <a:t>The TRAIN vector is [1, -0.6476169, -0.0628629]. It was estimated once on 2016–2020 and then held fixed throughout DEVELOPMENT.</a:t>
+            </a:r>
+          </a:p>
+          <a:p xmlns:a="http://schemas.openxmlformats.org/drawingml/2006/main">
+            <a:r>
+              <a:t/>
+            </a:r>
+          </a:p>
+          <a:p xmlns:a="http://schemas.openxmlformats.org/drawingml/2006/main">
+            <a:r>
+              <a:t>[Sources]</a:t>
+            </a:r>
+          </a:p>
+          <a:p xmlns:a="http://schemas.openxmlformats.org/drawingml/2006/main">
+            <a:r>
+              <a:t>- C:/Users/Franc/OneDrive/Documents/Francis/Peltata Project/Time-Series-Modeling-Gen5/runs/research_workbench/literature_grounded/lit_mr_03_1_triplet_atlas_01_20260729/mr03_cointegrating_vectors.csv</a:t>
+            </a:r>
+          </a:p>
+          <a:p xmlns:a="http://schemas.openxmlformats.org/drawingml/2006/main">
+            <a:r>
+              <a:t>- C:/Users/Franc/OneDrive/Documents/Francis/Peltata Project/Time-Series-Modeling-Gen5/runs/research_workbench/literature_grounded/lit_mr_03_1_triplet_atlas_01_20260729/mr03_train_summary.csv</a:t>
+            </a:r>
+          </a:p>
+          <a:p xmlns:a="http://schemas.openxmlformats.org/drawingml/2006/main">
+            <a:r>
+              <a:t>- C:/Users/Franc/OneDrive/Documents/Francis/Peltata Project/Time-Series-Modeling-Gen5/runs/research_workbench/literature_grounded/lit_mr_03_1_triplet_atlas_01_20260729/mr03_train_gate_detail.csv</a:t>
+            </a:r>
+          </a:p>
+          <a:p xmlns:a="http://schemas.openxmlformats.org/drawingml/2006/main">
+            <a:r>
+              <a:t>- C:/Users/Franc/OneDrive/Documents/Francis/Peltata Project/Time-Series-Modeling-Gen5/docs/GEN5_4_DECISION_DIALOGUE_INDEX.md — D80</a:t>
+            </a:r>
+          </a:p>
+        </p:txBody>
+      </p:sp>
+      <p:sp>
+        <p:nvSpPr>
+          <p:cNvPr id="4" name="Slide Number Placeholder 3"/>
+          <p:cNvSpPr>
+            <a:spLocks xmlns:a="http://schemas.openxmlformats.org/drawingml/2006/main" noGrp="1"/>
+          </p:cNvSpPr>
+          <p:nvPr>
+            <p:ph type="sldNum" idx="5"/>
+          </p:nvPr>
+        </p:nvSpPr>
+        <p:spPr/>
+        <p:txBody>
+          <a:bodyPr xmlns:a="http://schemas.openxmlformats.org/drawingml/2006/main"/>
+          <a:lstStyle xmlns:a="http://schemas.openxmlformats.org/drawingml/2006/main"/>
+          <a:p xmlns:a="http://schemas.openxmlformats.org/drawingml/2006/main"/>
+        </p:txBody>
+      </p:sp>
+    </p:spTree>
+  </p:cSld>
+  <p:clrMapOvr>
+    <a:masterClrMapping xmlns:a="http://schemas.openxmlformats.org/drawingml/2006/main"/>
+  </p:clrMapOvr>
+</p:notes>
+</file>
+
+<file path=ppt/notesSlides/notesSlide24.xml><?xml version="1.0" encoding="utf-8"?>
+<p:notes xmlns:p="http://schemas.openxmlformats.org/presentationml/2006/main">
+  <p:cSld>
+    <p:spTree>
+      <p:nvGrpSpPr>
+        <p:cNvPr id="1" name=""/>
+        <p:cNvGrpSpPr/>
+        <p:nvPr/>
+      </p:nvGrpSpPr>
+      <p:grpSpPr>
+        <a:xfrm xmlns:a="http://schemas.openxmlformats.org/drawingml/2006/main"/>
+      </p:grpSpPr>
+      <p:sp>
+        <p:nvSpPr>
+          <p:cNvPr id="2" name="Slide Image Placeholder 1"/>
+          <p:cNvSpPr>
+            <a:spLocks xmlns:a="http://schemas.openxmlformats.org/drawingml/2006/main" noGrp="1"/>
+          </p:cNvSpPr>
+          <p:nvPr>
+            <p:ph type="sldImg" idx="0"/>
+          </p:nvPr>
+        </p:nvSpPr>
+        <p:spPr/>
+      </p:sp>
+      <p:sp>
+        <p:nvSpPr>
+          <p:cNvPr id="3" name="Notes Placeholder 2"/>
+          <p:cNvSpPr>
+            <a:spLocks xmlns:a="http://schemas.openxmlformats.org/drawingml/2006/main" noGrp="1"/>
+          </p:cNvSpPr>
+          <p:nvPr>
+            <p:ph type="body" idx="1"/>
+          </p:nvPr>
+        </p:nvSpPr>
+        <p:spPr/>
+        <p:txBody>
+          <a:bodyPr xmlns:a="http://schemas.openxmlformats.org/drawingml/2006/main"/>
+          <a:lstStyle xmlns:a="http://schemas.openxmlformats.org/drawingml/2006/main"/>
+          <a:p xmlns:a="http://schemas.openxmlformats.org/drawingml/2006/main">
+            <a:r>
+              <a:t>The sole 2021–2023 OOS replay produced 57 completed trades, +8.50 bp mean net return, 71.9% hit rate, +3.73% cumulative return, 0.283 naive Sharpe, 0.317 autocorrelation-adjusted Sharpe, and -5.88% maximum drawdown.</a:t>
+            </a:r>
+          </a:p>
+          <a:p xmlns:a="http://schemas.openxmlformats.org/drawingml/2006/main">
+            <a:r>
+              <a:t>At the 10 bp stress cost, cumulative return was -3.23%. That cost sensitivity is the central limitation.</a:t>
+            </a:r>
+          </a:p>
+          <a:p xmlns:a="http://schemas.openxmlformats.org/drawingml/2006/main">
+            <a:r>
+              <a:t/>
+            </a:r>
+          </a:p>
+          <a:p xmlns:a="http://schemas.openxmlformats.org/drawingml/2006/main">
+            <a:r>
+              <a:t>[Sources]</a:t>
+            </a:r>
+          </a:p>
+          <a:p xmlns:a="http://schemas.openxmlformats.org/drawingml/2006/main">
+            <a:r>
+              <a:t>- C:/Users/Franc/OneDrive/Documents/Francis/Peltata Project/Time-Series-Modeling-Gen5/runs/research_workbench/literature_grounded/lit_mr_03_1_triplet_atlas_01_20260729/mr03_development_summary.csv</a:t>
+            </a:r>
+          </a:p>
+          <a:p xmlns:a="http://schemas.openxmlformats.org/drawingml/2006/main">
+            <a:r>
+              <a:t>- C:/Users/Franc/OneDrive/Documents/Francis/Peltata Project/Time-Series-Modeling-Gen5/runs/research_workbench/literature_grounded/lit_mr_03_1_triplet_atlas_01_20260729/mr03_development_trades.csv</a:t>
+            </a:r>
+          </a:p>
+          <a:p xmlns:a="http://schemas.openxmlformats.org/drawingml/2006/main">
+            <a:r>
+              <a:t>- C:/Users/Franc/OneDrive/Documents/Francis/Peltata Project/Time-Series-Modeling-Gen5/runs/research_workbench/literature_grounded/lit_mr_03_1_triplet_atlas_01_20260729/visuals/mr03_development_strategy_anatomy.png</a:t>
+            </a:r>
+          </a:p>
+          <a:p xmlns:a="http://schemas.openxmlformats.org/drawingml/2006/main">
+            <a:r>
+              <a:t>- C:/Users/Franc/OneDrive/Documents/Francis/Peltata Project/Time-Series-Modeling-Gen5/docs/GEN5_4_DECISION_DIALOGUE_INDEX.md — D80</a:t>
+            </a:r>
+          </a:p>
+        </p:txBody>
+      </p:sp>
+      <p:sp>
+        <p:nvSpPr>
+          <p:cNvPr id="4" name="Slide Number Placeholder 3"/>
+          <p:cNvSpPr>
+            <a:spLocks xmlns:a="http://schemas.openxmlformats.org/drawingml/2006/main" noGrp="1"/>
+          </p:cNvSpPr>
+          <p:nvPr>
+            <p:ph type="sldNum" idx="5"/>
+          </p:nvPr>
+        </p:nvSpPr>
+        <p:spPr/>
+        <p:txBody>
+          <a:bodyPr xmlns:a="http://schemas.openxmlformats.org/drawingml/2006/main"/>
+          <a:lstStyle xmlns:a="http://schemas.openxmlformats.org/drawingml/2006/main"/>
+          <a:p xmlns:a="http://schemas.openxmlformats.org/drawingml/2006/main"/>
+        </p:txBody>
+      </p:sp>
+    </p:spTree>
+  </p:cSld>
+  <p:clrMapOvr>
+    <a:masterClrMapping xmlns:a="http://schemas.openxmlformats.org/drawingml/2006/main"/>
+  </p:clrMapOvr>
+</p:notes>
+</file>
+
+<file path=ppt/notesSlides/notesSlide25.xml><?xml version="1.0" encoding="utf-8"?>
+<p:notes xmlns:p="http://schemas.openxmlformats.org/presentationml/2006/main">
+  <p:cSld>
+    <p:spTree>
+      <p:nvGrpSpPr>
+        <p:cNvPr id="1" name=""/>
+        <p:cNvGrpSpPr/>
+        <p:nvPr/>
+      </p:nvGrpSpPr>
+      <p:grpSpPr>
+        <a:xfrm xmlns:a="http://schemas.openxmlformats.org/drawingml/2006/main"/>
+      </p:grpSpPr>
+      <p:sp>
+        <p:nvSpPr>
+          <p:cNvPr id="2" name="Slide Image Placeholder 1"/>
+          <p:cNvSpPr>
+            <a:spLocks xmlns:a="http://schemas.openxmlformats.org/drawingml/2006/main" noGrp="1"/>
+          </p:cNvSpPr>
+          <p:nvPr>
+            <p:ph type="sldImg" idx="0"/>
+          </p:nvPr>
+        </p:nvSpPr>
+        <p:spPr/>
+      </p:sp>
+      <p:sp>
+        <p:nvSpPr>
+          <p:cNvPr id="3" name="Notes Placeholder 2"/>
+          <p:cNvSpPr>
+            <a:spLocks xmlns:a="http://schemas.openxmlformats.org/drawingml/2006/main" noGrp="1"/>
+          </p:cNvSpPr>
+          <p:nvPr>
+            <p:ph type="body" idx="1"/>
+          </p:nvPr>
+        </p:nvSpPr>
+        <p:spPr/>
+        <p:txBody>
+          <a:bodyPr xmlns:a="http://schemas.openxmlformats.org/drawingml/2006/main"/>
+          <a:lstStyle xmlns:a="http://schemas.openxmlformats.org/drawingml/2006/main"/>
+          <a:p xmlns:a="http://schemas.openxmlformats.org/drawingml/2006/main">
+            <a:r>
+              <a:t>The atlas demonstrates that strict gating can produce a candidate and an honest OOS result. Its weakness is cost margin, not an inability to pass statistical screens. The current recommendation is DISCUSSION_ONLY_NO_GATE_CHANGE.</a:t>
+            </a:r>
+          </a:p>
+          <a:p xmlns:a="http://schemas.openxmlformats.org/drawingml/2006/main">
+            <a:r>
+              <a:t/>
+            </a:r>
+          </a:p>
+          <a:p xmlns:a="http://schemas.openxmlformats.org/drawingml/2006/main">
+            <a:r>
+              <a:t>[Sources]</a:t>
+            </a:r>
+          </a:p>
+          <a:p xmlns:a="http://schemas.openxmlformats.org/drawingml/2006/main">
+            <a:r>
+              <a:t>- C:/Users/Franc/OneDrive/Documents/Francis/Peltata Project/Time-Series-Modeling-Gen5/runs/research_workbench/literature_grounded/lit_mr_03_1_triplet_atlas_01_20260729/mr03_report.md</a:t>
+            </a:r>
+          </a:p>
+          <a:p xmlns:a="http://schemas.openxmlformats.org/drawingml/2006/main">
+            <a:r>
+              <a:t>- C:/Users/Franc/OneDrive/Documents/Francis/Peltata Project/Time-Series-Modeling-Gen5/docs/GEN5_LIT_MR_03_1_TRIPLET_ATLAS_01_CONTRACT.md</a:t>
+            </a:r>
+          </a:p>
+          <a:p xmlns:a="http://schemas.openxmlformats.org/drawingml/2006/main">
+            <a:r>
+              <a:t>- C:/Users/Franc/OneDrive/Documents/Francis/Peltata Project/Time-Series-Modeling-Gen5/docs/GEN5_LIT_MR_GATE_CALIBRATION_DISCUSSION_BRIEF.md</a:t>
+            </a:r>
+          </a:p>
+          <a:p xmlns:a="http://schemas.openxmlformats.org/drawingml/2006/main">
+            <a:r>
+              <a:t>- C:/Users/Franc/OneDrive/Documents/Francis/Peltata Project/Time-Series-Modeling-Gen5/docs/GEN5_4_DECISION_DIALOGUE_INDEX.md — D80 and D81</a:t>
             </a:r>
           </a:p>
         </p:txBody>
@@ -2061,7 +2854,7 @@
   </p:cSld>
   <p:clrMap bg1="lt1" tx1="dk1" bg2="lt2" tx2="dk2" accent1="accent1" accent2="accent2" accent3="accent3" accent4="accent4" accent5="accent5" accent6="accent6" hlink="hlink" folHlink="folHlink"/>
   <p:sldLayoutIdLst>
-    <p:sldLayoutId xmlns:r="http://schemas.openxmlformats.org/officeDocument/2006/relationships" id="2147483649" r:id="R8f0df389a1bc4d6b"/>
+    <p:sldLayoutId xmlns:r="http://schemas.openxmlformats.org/officeDocument/2006/relationships" id="2147483649" r:id="R6d90e611981546c7"/>
   </p:sldLayoutIdLst>
   <p:txStyles>
     <p:titleStyle>
@@ -4006,14 +4799,14 @@
       </p:sp>
       <p:pic>
         <p:nvPicPr>
-          <p:cNvPr id="12" name=""/>
+          <p:cNvPr id="13" name=""/>
           <p:cNvPicPr>
             <a:picLocks xmlns:a="http://schemas.openxmlformats.org/drawingml/2006/main" noChangeAspect="1"/>
           </p:cNvPicPr>
           <p:nvPr/>
         </p:nvPicPr>
         <p:blipFill>
-          <a:blip xmlns:r="http://schemas.openxmlformats.org/officeDocument/2006/relationships" xmlns:a="http://schemas.openxmlformats.org/drawingml/2006/main" r:embed="Rb89b61b6126d4c83"/>
+          <a:blip xmlns:r="http://schemas.openxmlformats.org/officeDocument/2006/relationships" xmlns:a="http://schemas.openxmlformats.org/drawingml/2006/main" r:embed="R78177d1008cf434e"/>
           <a:stretch xmlns:a="http://schemas.openxmlformats.org/drawingml/2006/main"/>
         </p:blipFill>
         <p:spPr>
@@ -4061,14 +4854,14 @@
       </p:sp>
       <p:pic>
         <p:nvPicPr>
-          <p:cNvPr id="14" name=""/>
+          <p:cNvPr id="15" name=""/>
           <p:cNvPicPr>
             <a:picLocks xmlns:a="http://schemas.openxmlformats.org/drawingml/2006/main" noChangeAspect="1"/>
           </p:cNvPicPr>
           <p:nvPr/>
         </p:nvPicPr>
         <p:blipFill>
-          <a:blip xmlns:r="http://schemas.openxmlformats.org/officeDocument/2006/relationships" xmlns:a="http://schemas.openxmlformats.org/drawingml/2006/main" r:embed="R9508d4c1c7474d48"/>
+          <a:blip xmlns:r="http://schemas.openxmlformats.org/officeDocument/2006/relationships" xmlns:a="http://schemas.openxmlformats.org/drawingml/2006/main" r:embed="Rc40a72e3d5bc43c4"/>
           <a:stretch xmlns:a="http://schemas.openxmlformats.org/drawingml/2006/main"/>
         </p:blipFill>
         <p:spPr>
@@ -4195,14 +4988,14 @@
       </p:sp>
       <p:pic>
         <p:nvPicPr>
-          <p:cNvPr id="12" name=""/>
+          <p:cNvPr id="13" name=""/>
           <p:cNvPicPr>
             <a:picLocks xmlns:a="http://schemas.openxmlformats.org/drawingml/2006/main" noChangeAspect="1"/>
           </p:cNvPicPr>
           <p:nvPr/>
         </p:nvPicPr>
         <p:blipFill>
-          <a:blip xmlns:r="http://schemas.openxmlformats.org/officeDocument/2006/relationships" xmlns:a="http://schemas.openxmlformats.org/drawingml/2006/main" r:embed="R0c31fc0628164f49"/>
+          <a:blip xmlns:r="http://schemas.openxmlformats.org/officeDocument/2006/relationships" xmlns:a="http://schemas.openxmlformats.org/drawingml/2006/main" r:embed="R1ed6d0f961bd4862"/>
           <a:stretch xmlns:a="http://schemas.openxmlformats.org/drawingml/2006/main"/>
         </p:blipFill>
         <p:spPr>
@@ -4250,14 +5043,14 @@
       </p:sp>
       <p:pic>
         <p:nvPicPr>
-          <p:cNvPr id="14" name=""/>
+          <p:cNvPr id="15" name=""/>
           <p:cNvPicPr>
             <a:picLocks xmlns:a="http://schemas.openxmlformats.org/drawingml/2006/main" noChangeAspect="1"/>
           </p:cNvPicPr>
           <p:nvPr/>
         </p:nvPicPr>
         <p:blipFill>
-          <a:blip xmlns:r="http://schemas.openxmlformats.org/officeDocument/2006/relationships" xmlns:a="http://schemas.openxmlformats.org/drawingml/2006/main" r:embed="R5aa1338256da41c6"/>
+          <a:blip xmlns:r="http://schemas.openxmlformats.org/officeDocument/2006/relationships" xmlns:a="http://schemas.openxmlformats.org/drawingml/2006/main" r:embed="R6cc5effb5d294141"/>
           <a:stretch xmlns:a="http://schemas.openxmlformats.org/drawingml/2006/main"/>
         </p:blipFill>
         <p:spPr>
@@ -4384,14 +5177,14 @@
       </p:sp>
       <p:pic>
         <p:nvPicPr>
-          <p:cNvPr id="12" name=""/>
+          <p:cNvPr id="13" name=""/>
           <p:cNvPicPr>
             <a:picLocks xmlns:a="http://schemas.openxmlformats.org/drawingml/2006/main" noChangeAspect="1"/>
           </p:cNvPicPr>
           <p:nvPr/>
         </p:nvPicPr>
         <p:blipFill>
-          <a:blip xmlns:r="http://schemas.openxmlformats.org/officeDocument/2006/relationships" xmlns:a="http://schemas.openxmlformats.org/drawingml/2006/main" r:embed="R7213b850c1164249"/>
+          <a:blip xmlns:r="http://schemas.openxmlformats.org/officeDocument/2006/relationships" xmlns:a="http://schemas.openxmlformats.org/drawingml/2006/main" r:embed="R2f51e7b9322c4fc1"/>
           <a:stretch xmlns:a="http://schemas.openxmlformats.org/drawingml/2006/main"/>
         </p:blipFill>
         <p:spPr>
@@ -4439,14 +5232,14 @@
       </p:sp>
       <p:pic>
         <p:nvPicPr>
-          <p:cNvPr id="14" name=""/>
+          <p:cNvPr id="15" name=""/>
           <p:cNvPicPr>
             <a:picLocks xmlns:a="http://schemas.openxmlformats.org/drawingml/2006/main" noChangeAspect="1"/>
           </p:cNvPicPr>
           <p:nvPr/>
         </p:nvPicPr>
         <p:blipFill>
-          <a:blip xmlns:r="http://schemas.openxmlformats.org/officeDocument/2006/relationships" xmlns:a="http://schemas.openxmlformats.org/drawingml/2006/main" r:embed="R7d7809c2f81a4bec"/>
+          <a:blip xmlns:r="http://schemas.openxmlformats.org/officeDocument/2006/relationships" xmlns:a="http://schemas.openxmlformats.org/drawingml/2006/main" r:embed="R98091105ad91406c"/>
           <a:stretch xmlns:a="http://schemas.openxmlformats.org/drawingml/2006/main"/>
         </p:blipFill>
         <p:spPr>
@@ -4750,14 +5543,14 @@
       </p:sp>
       <p:pic>
         <p:nvPicPr>
-          <p:cNvPr id="21" name=""/>
+          <p:cNvPr id="24" name=""/>
           <p:cNvPicPr>
             <a:picLocks xmlns:a="http://schemas.openxmlformats.org/drawingml/2006/main" noChangeAspect="1"/>
           </p:cNvPicPr>
           <p:nvPr/>
         </p:nvPicPr>
         <p:blipFill>
-          <a:blip xmlns:r="http://schemas.openxmlformats.org/officeDocument/2006/relationships" xmlns:a="http://schemas.openxmlformats.org/drawingml/2006/main" r:embed="R622e4d64fa3a4b41"/>
+          <a:blip xmlns:r="http://schemas.openxmlformats.org/officeDocument/2006/relationships" xmlns:a="http://schemas.openxmlformats.org/drawingml/2006/main" r:embed="Rd98e2294e95e4bdc"/>
           <a:stretch xmlns:a="http://schemas.openxmlformats.org/drawingml/2006/main"/>
         </p:blipFill>
         <p:spPr>
@@ -4805,14 +5598,14 @@
       </p:sp>
       <p:pic>
         <p:nvPicPr>
-          <p:cNvPr id="23" name=""/>
+          <p:cNvPr id="26" name=""/>
           <p:cNvPicPr>
             <a:picLocks xmlns:a="http://schemas.openxmlformats.org/drawingml/2006/main" noChangeAspect="1"/>
           </p:cNvPicPr>
           <p:nvPr/>
         </p:nvPicPr>
         <p:blipFill>
-          <a:blip xmlns:r="http://schemas.openxmlformats.org/officeDocument/2006/relationships" xmlns:a="http://schemas.openxmlformats.org/drawingml/2006/main" r:embed="R761b048578c74469"/>
+          <a:blip xmlns:r="http://schemas.openxmlformats.org/officeDocument/2006/relationships" xmlns:a="http://schemas.openxmlformats.org/drawingml/2006/main" r:embed="R6c8a3c3841674511"/>
           <a:stretch xmlns:a="http://schemas.openxmlformats.org/drawingml/2006/main"/>
         </p:blipFill>
         <p:spPr>
@@ -4860,14 +5653,14 @@
       </p:sp>
       <p:pic>
         <p:nvPicPr>
-          <p:cNvPr id="25" name=""/>
+          <p:cNvPr id="28" name=""/>
           <p:cNvPicPr>
             <a:picLocks xmlns:a="http://schemas.openxmlformats.org/drawingml/2006/main" noChangeAspect="1"/>
           </p:cNvPicPr>
           <p:nvPr/>
         </p:nvPicPr>
         <p:blipFill>
-          <a:blip xmlns:r="http://schemas.openxmlformats.org/officeDocument/2006/relationships" xmlns:a="http://schemas.openxmlformats.org/drawingml/2006/main" r:embed="Re0c607c4ef424f00"/>
+          <a:blip xmlns:r="http://schemas.openxmlformats.org/officeDocument/2006/relationships" xmlns:a="http://schemas.openxmlformats.org/drawingml/2006/main" r:embed="R3bb981178bd54b6a"/>
           <a:stretch xmlns:a="http://schemas.openxmlformats.org/drawingml/2006/main"/>
         </p:blipFill>
         <p:spPr>
@@ -4915,14 +5708,14 @@
       </p:sp>
       <p:pic>
         <p:nvPicPr>
-          <p:cNvPr id="27" name=""/>
+          <p:cNvPr id="30" name=""/>
           <p:cNvPicPr>
             <a:picLocks xmlns:a="http://schemas.openxmlformats.org/drawingml/2006/main" noChangeAspect="1"/>
           </p:cNvPicPr>
           <p:nvPr/>
         </p:nvPicPr>
         <p:blipFill>
-          <a:blip xmlns:r="http://schemas.openxmlformats.org/officeDocument/2006/relationships" xmlns:a="http://schemas.openxmlformats.org/drawingml/2006/main" r:embed="Re8e9a39f63904f5a"/>
+          <a:blip xmlns:r="http://schemas.openxmlformats.org/officeDocument/2006/relationships" xmlns:a="http://schemas.openxmlformats.org/drawingml/2006/main" r:embed="R11ca1dc73ab84136"/>
           <a:stretch xmlns:a="http://schemas.openxmlformats.org/drawingml/2006/main"/>
         </p:blipFill>
         <p:spPr>
@@ -5690,6 +6483,751 @@
 </p:sld>
 </file>
 
+<file path=ppt/slides/slide18.xml><?xml version="1.0" encoding="utf-8"?>
+<p:sld xmlns:p="http://schemas.openxmlformats.org/presentationml/2006/main">
+  <p:cSld>
+    <p:spTree>
+      <p:nvGrpSpPr>
+        <p:cNvPr id="1" name=""/>
+        <p:cNvGrpSpPr/>
+        <p:nvPr/>
+      </p:nvGrpSpPr>
+      <p:grpSpPr>
+        <a:xfrm xmlns:a="http://schemas.openxmlformats.org/drawingml/2006/main"/>
+      </p:grpSpPr>
+      <p:sp>
+        <p:nvSpPr>
+          <p:cNvPr id="4" name="cover-headline">
+            <a:extLst xmlns:a="http://schemas.openxmlformats.org/drawingml/2006/main">
+              <a:ext uri="{FF2B5EF4-FFF2-40B4-BE49-F238E27FC236}">
+                <a16:creationId xmlns:a16="http://schemas.microsoft.com/office/drawing/2014/main" id="{DA6318FA-2F99-4DF9-A744-06350F910925}"/>
+              </a:ext>
+            </a:extLst>
+          </p:cNvPr>
+          <p:cNvSpPr>
+            <a:spLocks xmlns:a="http://schemas.openxmlformats.org/drawingml/2006/main" noGrp="1"/>
+          </p:cNvSpPr>
+          <p:nvPr/>
+        </p:nvSpPr>
+        <p:spPr>
+          <a:xfrm xmlns:a="http://schemas.openxmlformats.org/drawingml/2006/main">
+            <a:off x="393668" y="1738789"/>
+            <a:ext cx="10287000" cy="2491454"/>
+          </a:xfrm>
+          <a:prstGeom xmlns:a="http://schemas.openxmlformats.org/drawingml/2006/main" prst="rect">
+            <a:avLst/>
+          </a:prstGeom>
+        </p:spPr>
+        <p:txBody>
+          <a:bodyPr xmlns:a="http://schemas.openxmlformats.org/drawingml/2006/main" lIns="0" tIns="0" rIns="0" bIns="0" anchor="b">
+            <a:normAutofit fontScale="100000"/>
+          </a:bodyPr>
+          <a:lstStyle xmlns:a="http://schemas.openxmlformats.org/drawingml/2006/main"/>
+          <a:p xmlns:a="http://schemas.openxmlformats.org/drawingml/2006/main">
+            <a:pPr algn="l">
+              <a:buNone/>
+              <a:defRPr sz="5700">
+                <a:solidFill>
+                  <a:srgbClr val="000000"/>
+                </a:solidFill>
+                <a:latin typeface="Helvetica Neue"/>
+                <a:ea typeface="Helvetica Neue"/>
+                <a:cs typeface="Helvetica Neue"/>
+              </a:defRPr>
+            </a:pPr>
+            <a:r>
+              <a:t>Triplet Atlas 01</a:t>
+            </a:r>
+          </a:p>
+          <a:p xmlns:a="http://schemas.openxmlformats.org/drawingml/2006/main">
+            <a:pPr algn="l">
+              <a:buNone/>
+              <a:defRPr sz="5700">
+                <a:solidFill>
+                  <a:srgbClr val="000000"/>
+                </a:solidFill>
+                <a:latin typeface="Helvetica Neue"/>
+                <a:ea typeface="Helvetica Neue"/>
+                <a:cs typeface="Helvetica Neue"/>
+              </a:defRPr>
+            </a:pPr>
+            <a:r>
+              <a:t>one strict pass, one OOS replay</a:t>
+            </a:r>
+          </a:p>
+        </p:txBody>
+      </p:sp>
+      <p:sp>
+        <p:nvSpPr>
+          <p:cNvPr id="2" name="cover-subtitle">
+            <a:extLst xmlns:a="http://schemas.openxmlformats.org/drawingml/2006/main">
+              <a:ext uri="{FF2B5EF4-FFF2-40B4-BE49-F238E27FC236}">
+                <a16:creationId xmlns:a16="http://schemas.microsoft.com/office/drawing/2014/main" id="{E169DF7F-9A3A-4AE2-8055-4ED350724D47}"/>
+              </a:ext>
+            </a:extLst>
+          </p:cNvPr>
+          <p:cNvSpPr>
+            <a:spLocks xmlns:a="http://schemas.openxmlformats.org/drawingml/2006/main" noGrp="1"/>
+          </p:cNvSpPr>
+          <p:nvPr/>
+        </p:nvSpPr>
+        <p:spPr>
+          <a:xfrm xmlns:a="http://schemas.openxmlformats.org/drawingml/2006/main">
+            <a:off x="393668" y="4762500"/>
+            <a:ext cx="8001000" cy="1238250"/>
+          </a:xfrm>
+          <a:prstGeom xmlns:a="http://schemas.openxmlformats.org/drawingml/2006/main" prst="rect">
+            <a:avLst/>
+          </a:prstGeom>
+        </p:spPr>
+        <p:txBody>
+          <a:bodyPr xmlns:a="http://schemas.openxmlformats.org/drawingml/2006/main" lIns="0" tIns="0" rIns="0" bIns="0">
+            <a:normAutofit fontScale="100000"/>
+          </a:bodyPr>
+          <a:lstStyle xmlns:a="http://schemas.openxmlformats.org/drawingml/2006/main"/>
+          <a:p xmlns:a="http://schemas.openxmlformats.org/drawingml/2006/main">
+            <a:pPr algn="l">
+              <a:buNone/>
+              <a:defRPr sz="2250">
+                <a:solidFill>
+                  <a:srgbClr val="000000"/>
+                </a:solidFill>
+                <a:latin typeface="Helvetica Neue"/>
+                <a:ea typeface="Helvetica Neue"/>
+                <a:cs typeface="Helvetica Neue"/>
+              </a:defRPr>
+            </a:pPr>
+            <a:r>
+              <a:t>Twenty-eight categorized hypotheses entered the unchanged TRAIN gate. EWA–EWC–EWZ alone earned a frozen-vector 2021–2023 replay.</a:t>
+            </a:r>
+          </a:p>
+        </p:txBody>
+      </p:sp>
+      <p:sp>
+        <p:nvSpPr>
+          <p:cNvPr id="3" name="cover-eyebrow">
+            <a:extLst xmlns:a="http://schemas.openxmlformats.org/drawingml/2006/main">
+              <a:ext uri="{FF2B5EF4-FFF2-40B4-BE49-F238E27FC236}">
+                <a16:creationId xmlns:a16="http://schemas.microsoft.com/office/drawing/2014/main" id="{D2399950-CA2D-41D2-BB2E-E681018A573E}"/>
+              </a:ext>
+            </a:extLst>
+          </p:cNvPr>
+          <p:cNvSpPr>
+            <a:spLocks xmlns:a="http://schemas.openxmlformats.org/drawingml/2006/main" noGrp="1"/>
+          </p:cNvSpPr>
+          <p:nvPr/>
+        </p:nvSpPr>
+        <p:spPr>
+          <a:xfrm xmlns:a="http://schemas.openxmlformats.org/drawingml/2006/main">
+            <a:off x="393668" y="392240"/>
+            <a:ext cx="7239000" cy="649129"/>
+          </a:xfrm>
+          <a:prstGeom xmlns:a="http://schemas.openxmlformats.org/drawingml/2006/main" prst="rect">
+            <a:avLst/>
+          </a:prstGeom>
+        </p:spPr>
+        <p:txBody>
+          <a:bodyPr xmlns:a="http://schemas.openxmlformats.org/drawingml/2006/main" lIns="0" tIns="0" rIns="0" bIns="0">
+            <a:normAutofit fontScale="100000"/>
+          </a:bodyPr>
+          <a:lstStyle xmlns:a="http://schemas.openxmlformats.org/drawingml/2006/main"/>
+          <a:p xmlns:a="http://schemas.openxmlformats.org/drawingml/2006/main">
+            <a:pPr algn="l">
+              <a:buNone/>
+              <a:defRPr sz="2250">
+                <a:solidFill>
+                  <a:srgbClr val="000000"/>
+                </a:solidFill>
+                <a:latin typeface="Helvetica Neue"/>
+                <a:ea typeface="Helvetica Neue"/>
+                <a:cs typeface="Helvetica Neue"/>
+              </a:defRPr>
+            </a:pPr>
+            <a:r>
+              <a:t>LIT-MR-03.1 INSTANCE BATCH | 29 JUL 2026</a:t>
+            </a:r>
+          </a:p>
+        </p:txBody>
+      </p:sp>
+    </p:spTree>
+    <p:extLst>
+      <p:ext uri="{BB962C8B-B14F-4D97-AF65-F5344CB8AC3E}">
+        <p14:creationId xmlns:p14="http://schemas.microsoft.com/office/powerpoint/2010/main" val="2092893396"/>
+      </p:ext>
+    </p:extLst>
+  </p:cSld>
+</p:sld>
+</file>
+
+<file path=ppt/slides/slide19.xml><?xml version="1.0" encoding="utf-8"?>
+<p:sld xmlns:p="http://schemas.openxmlformats.org/presentationml/2006/main">
+  <p:cSld>
+    <p:spTree>
+      <p:nvGrpSpPr>
+        <p:cNvPr id="1" name=""/>
+        <p:cNvGrpSpPr/>
+        <p:nvPr/>
+      </p:nvGrpSpPr>
+      <p:grpSpPr>
+        <a:xfrm xmlns:a="http://schemas.openxmlformats.org/drawingml/2006/main"/>
+      </p:grpSpPr>
+      <p:sp>
+        <p:nvSpPr>
+          <p:cNvPr id="13" name="stat-card-1">
+            <a:extLst xmlns:a="http://schemas.openxmlformats.org/drawingml/2006/main">
+              <a:ext uri="{FF2B5EF4-FFF2-40B4-BE49-F238E27FC236}">
+                <a16:creationId xmlns:a16="http://schemas.microsoft.com/office/drawing/2014/main" id="{8D249104-692F-481F-82EC-326C84E9007D}"/>
+              </a:ext>
+            </a:extLst>
+          </p:cNvPr>
+          <p:cNvSpPr>
+            <a:spLocks xmlns:a="http://schemas.openxmlformats.org/drawingml/2006/main" noGrp="1"/>
+          </p:cNvSpPr>
+          <p:nvPr/>
+        </p:nvSpPr>
+        <p:spPr>
+          <a:xfrm xmlns:a="http://schemas.openxmlformats.org/drawingml/2006/main">
+            <a:off x="393668" y="3022568"/>
+            <a:ext cx="3568732" cy="2971800"/>
+          </a:xfrm>
+          <a:prstGeom xmlns:a="http://schemas.openxmlformats.org/drawingml/2006/main" prst="roundRect">
+            <a:avLst>
+              <a:gd name="adj" fmla="val 2564"/>
+            </a:avLst>
+          </a:prstGeom>
+          <a:solidFill xmlns:a="http://schemas.openxmlformats.org/drawingml/2006/main">
+            <a:srgbClr val="F2F2F2"/>
+          </a:solidFill>
+        </p:spPr>
+      </p:sp>
+      <p:sp>
+        <p:nvSpPr>
+          <p:cNvPr id="2" name="stat-card-2">
+            <a:extLst xmlns:a="http://schemas.openxmlformats.org/drawingml/2006/main">
+              <a:ext uri="{FF2B5EF4-FFF2-40B4-BE49-F238E27FC236}">
+                <a16:creationId xmlns:a16="http://schemas.microsoft.com/office/drawing/2014/main" id="{02412AD9-1F13-493C-BF6C-FD8BDE750CD9}"/>
+              </a:ext>
+            </a:extLst>
+          </p:cNvPr>
+          <p:cNvSpPr>
+            <a:spLocks xmlns:a="http://schemas.openxmlformats.org/drawingml/2006/main" noGrp="1"/>
+          </p:cNvSpPr>
+          <p:nvPr/>
+        </p:nvSpPr>
+        <p:spPr>
+          <a:xfrm xmlns:a="http://schemas.openxmlformats.org/drawingml/2006/main">
+            <a:off x="4311682" y="3022568"/>
+            <a:ext cx="3568732" cy="2971800"/>
+          </a:xfrm>
+          <a:prstGeom xmlns:a="http://schemas.openxmlformats.org/drawingml/2006/main" prst="roundRect">
+            <a:avLst>
+              <a:gd name="adj" fmla="val 2564"/>
+            </a:avLst>
+          </a:prstGeom>
+          <a:solidFill xmlns:a="http://schemas.openxmlformats.org/drawingml/2006/main">
+            <a:srgbClr val="F2F2F2"/>
+          </a:solidFill>
+        </p:spPr>
+      </p:sp>
+      <p:sp>
+        <p:nvSpPr>
+          <p:cNvPr id="3" name="stat-card-3">
+            <a:extLst xmlns:a="http://schemas.openxmlformats.org/drawingml/2006/main">
+              <a:ext uri="{FF2B5EF4-FFF2-40B4-BE49-F238E27FC236}">
+                <a16:creationId xmlns:a16="http://schemas.microsoft.com/office/drawing/2014/main" id="{63597CCF-F233-4A0C-BCFA-192F852FDBEA}"/>
+              </a:ext>
+            </a:extLst>
+          </p:cNvPr>
+          <p:cNvSpPr>
+            <a:spLocks xmlns:a="http://schemas.openxmlformats.org/drawingml/2006/main" noGrp="1"/>
+          </p:cNvSpPr>
+          <p:nvPr/>
+        </p:nvSpPr>
+        <p:spPr>
+          <a:xfrm xmlns:a="http://schemas.openxmlformats.org/drawingml/2006/main">
+            <a:off x="8232267" y="3022568"/>
+            <a:ext cx="3568732" cy="2971800"/>
+          </a:xfrm>
+          <a:prstGeom xmlns:a="http://schemas.openxmlformats.org/drawingml/2006/main" prst="roundRect">
+            <a:avLst>
+              <a:gd name="adj" fmla="val 2564"/>
+            </a:avLst>
+          </a:prstGeom>
+          <a:solidFill xmlns:a="http://schemas.openxmlformats.org/drawingml/2006/main">
+            <a:srgbClr val="F2F2F2"/>
+          </a:solidFill>
+        </p:spPr>
+      </p:sp>
+      <p:sp>
+        <p:nvSpPr>
+          <p:cNvPr id="4" name="footer">
+            <a:extLst xmlns:a="http://schemas.openxmlformats.org/drawingml/2006/main">
+              <a:ext uri="{FF2B5EF4-FFF2-40B4-BE49-F238E27FC236}">
+                <a16:creationId xmlns:a16="http://schemas.microsoft.com/office/drawing/2014/main" id="{11E272E4-82E7-4287-91C5-21E6B629F553}"/>
+              </a:ext>
+            </a:extLst>
+          </p:cNvPr>
+          <p:cNvSpPr>
+            <a:spLocks xmlns:a="http://schemas.openxmlformats.org/drawingml/2006/main" noGrp="1"/>
+          </p:cNvSpPr>
+          <p:nvPr/>
+        </p:nvSpPr>
+        <p:spPr>
+          <a:xfrm xmlns:a="http://schemas.openxmlformats.org/drawingml/2006/main">
+            <a:off x="11279315" y="6279261"/>
+            <a:ext cx="518922" cy="241268"/>
+          </a:xfrm>
+          <a:prstGeom xmlns:a="http://schemas.openxmlformats.org/drawingml/2006/main" prst="rect">
+            <a:avLst/>
+          </a:prstGeom>
+        </p:spPr>
+        <p:txBody>
+          <a:bodyPr xmlns:a="http://schemas.openxmlformats.org/drawingml/2006/main" lIns="0" tIns="0" rIns="0" bIns="0" anchor="b"/>
+          <a:lstStyle xmlns:a="http://schemas.openxmlformats.org/drawingml/2006/main"/>
+          <a:p xmlns:a="http://schemas.openxmlformats.org/drawingml/2006/main">
+            <a:pPr algn="r">
+              <a:buNone/>
+              <a:defRPr sz="1000">
+                <a:solidFill>
+                  <a:srgbClr val="000000"/>
+                </a:solidFill>
+                <a:latin typeface="Helvetica Neue"/>
+                <a:ea typeface="Helvetica Neue"/>
+                <a:cs typeface="Helvetica Neue"/>
+              </a:defRPr>
+            </a:pPr>
+            <a:r>
+              <a:t>19</a:t>
+            </a:r>
+          </a:p>
+        </p:txBody>
+      </p:sp>
+      <p:sp>
+        <p:nvSpPr>
+          <p:cNvPr id="5" name="title">
+            <a:extLst xmlns:a="http://schemas.openxmlformats.org/drawingml/2006/main">
+              <a:ext uri="{FF2B5EF4-FFF2-40B4-BE49-F238E27FC236}">
+                <a16:creationId xmlns:a16="http://schemas.microsoft.com/office/drawing/2014/main" id="{A0ED332F-4F42-421E-99CF-097B6CBB5C19}"/>
+              </a:ext>
+            </a:extLst>
+          </p:cNvPr>
+          <p:cNvSpPr>
+            <a:spLocks xmlns:a="http://schemas.openxmlformats.org/drawingml/2006/main" noGrp="1"/>
+          </p:cNvSpPr>
+          <p:nvPr/>
+        </p:nvSpPr>
+        <p:spPr>
+          <a:xfrm xmlns:a="http://schemas.openxmlformats.org/drawingml/2006/main">
+            <a:off x="393668" y="344043"/>
+            <a:ext cx="11404568" cy="1047464"/>
+          </a:xfrm>
+          <a:prstGeom xmlns:a="http://schemas.openxmlformats.org/drawingml/2006/main" prst="rect">
+            <a:avLst/>
+          </a:prstGeom>
+        </p:spPr>
+        <p:txBody>
+          <a:bodyPr xmlns:a="http://schemas.openxmlformats.org/drawingml/2006/main" lIns="0" tIns="0" rIns="0" bIns="0" anchor="t">
+            <a:normAutofit fontScale="100000"/>
+          </a:bodyPr>
+          <a:lstStyle xmlns:a="http://schemas.openxmlformats.org/drawingml/2006/main"/>
+          <a:p xmlns:a="http://schemas.openxmlformats.org/drawingml/2006/main">
+            <a:pPr algn="l">
+              <a:buNone/>
+              <a:defRPr sz="2900">
+                <a:solidFill>
+                  <a:srgbClr val="000000"/>
+                </a:solidFill>
+                <a:latin typeface="Helvetica Neue"/>
+                <a:ea typeface="Helvetica Neue"/>
+                <a:cs typeface="Helvetica Neue"/>
+              </a:defRPr>
+            </a:pPr>
+            <a:r>
+              <a:t>The generator expands breadth without changing the strategy</a:t>
+            </a:r>
+          </a:p>
+        </p:txBody>
+      </p:sp>
+      <p:sp>
+        <p:nvSpPr>
+          <p:cNvPr id="6" name="intro">
+            <a:extLst xmlns:a="http://schemas.openxmlformats.org/drawingml/2006/main">
+              <a:ext uri="{FF2B5EF4-FFF2-40B4-BE49-F238E27FC236}">
+                <a16:creationId xmlns:a16="http://schemas.microsoft.com/office/drawing/2014/main" id="{E3D1AF2D-950D-495D-BB07-182C768AD88F}"/>
+              </a:ext>
+            </a:extLst>
+          </p:cNvPr>
+          <p:cNvSpPr>
+            <a:spLocks xmlns:a="http://schemas.openxmlformats.org/drawingml/2006/main" noGrp="1"/>
+          </p:cNvSpPr>
+          <p:nvPr/>
+        </p:nvSpPr>
+        <p:spPr>
+          <a:xfrm xmlns:a="http://schemas.openxmlformats.org/drawingml/2006/main">
+            <a:off x="393668" y="1219200"/>
+            <a:ext cx="11404568" cy="1428750"/>
+          </a:xfrm>
+          <a:prstGeom xmlns:a="http://schemas.openxmlformats.org/drawingml/2006/main" prst="rect">
+            <a:avLst/>
+          </a:prstGeom>
+        </p:spPr>
+        <p:txBody>
+          <a:bodyPr xmlns:a="http://schemas.openxmlformats.org/drawingml/2006/main" lIns="0" tIns="0" rIns="0" bIns="0" anchor="t">
+            <a:normAutofit fontScale="100000"/>
+          </a:bodyPr>
+          <a:lstStyle xmlns:a="http://schemas.openxmlformats.org/drawingml/2006/main"/>
+          <a:p xmlns:a="http://schemas.openxmlformats.org/drawingml/2006/main">
+            <a:pPr algn="l">
+              <a:buNone/>
+              <a:defRPr sz="1650">
+                <a:solidFill>
+                  <a:srgbClr val="000000"/>
+                </a:solidFill>
+                <a:latin typeface="Helvetica Neue"/>
+                <a:ea typeface="Helvetica Neue"/>
+                <a:cs typeface="Helvetica Neue"/>
+              </a:defRPr>
+            </a:pPr>
+            <a:r>
+              <a:t>Seven economic cells organize four predeclared triplets each. Categories make the hypothesis legible; they do not imply equal cointegration odds or authorize outcome-ranked selection.</a:t>
+            </a:r>
+          </a:p>
+        </p:txBody>
+      </p:sp>
+      <p:sp>
+        <p:nvSpPr>
+          <p:cNvPr id="7" name="stat-1">
+            <a:extLst xmlns:a="http://schemas.openxmlformats.org/drawingml/2006/main">
+              <a:ext uri="{FF2B5EF4-FFF2-40B4-BE49-F238E27FC236}">
+                <a16:creationId xmlns:a16="http://schemas.microsoft.com/office/drawing/2014/main" id="{447A29C0-2600-4241-BF6B-6797417FC507}"/>
+              </a:ext>
+            </a:extLst>
+          </p:cNvPr>
+          <p:cNvSpPr>
+            <a:spLocks xmlns:a="http://schemas.openxmlformats.org/drawingml/2006/main" noGrp="1"/>
+          </p:cNvSpPr>
+          <p:nvPr/>
+        </p:nvSpPr>
+        <p:spPr>
+          <a:xfrm xmlns:a="http://schemas.openxmlformats.org/drawingml/2006/main">
+            <a:off x="702374" y="3429000"/>
+            <a:ext cx="2940082" cy="1359313"/>
+          </a:xfrm>
+          <a:prstGeom xmlns:a="http://schemas.openxmlformats.org/drawingml/2006/main" prst="rect">
+            <a:avLst/>
+          </a:prstGeom>
+        </p:spPr>
+        <p:txBody>
+          <a:bodyPr xmlns:a="http://schemas.openxmlformats.org/drawingml/2006/main" lIns="0" tIns="0" rIns="0" bIns="0" anchor="b">
+            <a:normAutofit fontScale="100000"/>
+          </a:bodyPr>
+          <a:lstStyle xmlns:a="http://schemas.openxmlformats.org/drawingml/2006/main"/>
+          <a:p xmlns:a="http://schemas.openxmlformats.org/drawingml/2006/main">
+            <a:pPr algn="l">
+              <a:buNone/>
+              <a:defRPr sz="3225">
+                <a:solidFill>
+                  <a:srgbClr val="3D8DFF"/>
+                </a:solidFill>
+                <a:latin typeface="Helvetica Neue"/>
+                <a:ea typeface="Helvetica Neue"/>
+                <a:cs typeface="Helvetica Neue"/>
+              </a:defRPr>
+            </a:pPr>
+            <a:r>
+              <a:t>7 cells</a:t>
+            </a:r>
+          </a:p>
+        </p:txBody>
+      </p:sp>
+      <p:sp>
+        <p:nvSpPr>
+          <p:cNvPr id="8" name="stat-label-1">
+            <a:extLst xmlns:a="http://schemas.openxmlformats.org/drawingml/2006/main">
+              <a:ext uri="{FF2B5EF4-FFF2-40B4-BE49-F238E27FC236}">
+                <a16:creationId xmlns:a16="http://schemas.microsoft.com/office/drawing/2014/main" id="{1D2A853D-A304-477D-B8B8-F77F0101AC08}"/>
+              </a:ext>
+            </a:extLst>
+          </p:cNvPr>
+          <p:cNvSpPr>
+            <a:spLocks xmlns:a="http://schemas.openxmlformats.org/drawingml/2006/main" noGrp="1"/>
+          </p:cNvSpPr>
+          <p:nvPr/>
+        </p:nvSpPr>
+        <p:spPr>
+          <a:xfrm xmlns:a="http://schemas.openxmlformats.org/drawingml/2006/main">
+            <a:off x="702374" y="4900613"/>
+            <a:ext cx="2949607" cy="819150"/>
+          </a:xfrm>
+          <a:prstGeom xmlns:a="http://schemas.openxmlformats.org/drawingml/2006/main" prst="rect">
+            <a:avLst/>
+          </a:prstGeom>
+        </p:spPr>
+        <p:txBody>
+          <a:bodyPr xmlns:a="http://schemas.openxmlformats.org/drawingml/2006/main" lIns="0" tIns="45720" rIns="91440" bIns="45720" anchor="t">
+            <a:normAutofit fontScale="100000"/>
+          </a:bodyPr>
+          <a:lstStyle xmlns:a="http://schemas.openxmlformats.org/drawingml/2006/main"/>
+          <a:p xmlns:a="http://schemas.openxmlformats.org/drawingml/2006/main">
+            <a:pPr algn="l">
+              <a:buNone/>
+              <a:defRPr sz="1575">
+                <a:solidFill>
+                  <a:srgbClr val="000000"/>
+                </a:solidFill>
+                <a:latin typeface="Helvetica Neue"/>
+                <a:ea typeface="Helvetica Neue"/>
+                <a:cs typeface="Helvetica Neue"/>
+              </a:defRPr>
+            </a:pPr>
+            <a:r>
+              <a:t>Near substitutes · sector ETFs · curves</a:t>
+            </a:r>
+          </a:p>
+          <a:p xmlns:a="http://schemas.openxmlformats.org/drawingml/2006/main">
+            <a:pPr algn="l">
+              <a:buNone/>
+              <a:defRPr sz="1575">
+                <a:solidFill>
+                  <a:srgbClr val="000000"/>
+                </a:solidFill>
+                <a:latin typeface="Helvetica Neue"/>
+                <a:ea typeface="Helvetica Neue"/>
+                <a:cs typeface="Helvetica Neue"/>
+              </a:defRPr>
+            </a:pPr>
+            <a:r>
+              <a:t>Basket/components</a:t>
+            </a:r>
+          </a:p>
+        </p:txBody>
+      </p:sp>
+      <p:sp>
+        <p:nvSpPr>
+          <p:cNvPr id="9" name="stat-2">
+            <a:extLst xmlns:a="http://schemas.openxmlformats.org/drawingml/2006/main">
+              <a:ext uri="{FF2B5EF4-FFF2-40B4-BE49-F238E27FC236}">
+                <a16:creationId xmlns:a16="http://schemas.microsoft.com/office/drawing/2014/main" id="{342C60B8-5C35-4607-932D-DFD8E206B634}"/>
+              </a:ext>
+            </a:extLst>
+          </p:cNvPr>
+          <p:cNvSpPr>
+            <a:spLocks xmlns:a="http://schemas.openxmlformats.org/drawingml/2006/main" noGrp="1"/>
+          </p:cNvSpPr>
+          <p:nvPr/>
+        </p:nvSpPr>
+        <p:spPr>
+          <a:xfrm xmlns:a="http://schemas.openxmlformats.org/drawingml/2006/main">
+            <a:off x="4612958" y="3429000"/>
+            <a:ext cx="2940082" cy="1359313"/>
+          </a:xfrm>
+          <a:prstGeom xmlns:a="http://schemas.openxmlformats.org/drawingml/2006/main" prst="rect">
+            <a:avLst/>
+          </a:prstGeom>
+        </p:spPr>
+        <p:txBody>
+          <a:bodyPr xmlns:a="http://schemas.openxmlformats.org/drawingml/2006/main" lIns="0" tIns="0" rIns="0" bIns="0" anchor="b">
+            <a:normAutofit fontScale="100000"/>
+          </a:bodyPr>
+          <a:lstStyle xmlns:a="http://schemas.openxmlformats.org/drawingml/2006/main"/>
+          <a:p xmlns:a="http://schemas.openxmlformats.org/drawingml/2006/main">
+            <a:pPr algn="l">
+              <a:buNone/>
+              <a:defRPr sz="3225">
+                <a:solidFill>
+                  <a:srgbClr val="000000"/>
+                </a:solidFill>
+                <a:latin typeface="Helvetica Neue"/>
+                <a:ea typeface="Helvetica Neue"/>
+                <a:cs typeface="Helvetica Neue"/>
+              </a:defRPr>
+            </a:pPr>
+            <a:r>
+              <a:t>28 triplets</a:t>
+            </a:r>
+          </a:p>
+        </p:txBody>
+      </p:sp>
+      <p:sp>
+        <p:nvSpPr>
+          <p:cNvPr id="10" name="stat-label-2">
+            <a:extLst xmlns:a="http://schemas.openxmlformats.org/drawingml/2006/main">
+              <a:ext uri="{FF2B5EF4-FFF2-40B4-BE49-F238E27FC236}">
+                <a16:creationId xmlns:a16="http://schemas.microsoft.com/office/drawing/2014/main" id="{3123331A-6BB6-4FC3-B18C-EE98C6A8FF13}"/>
+              </a:ext>
+            </a:extLst>
+          </p:cNvPr>
+          <p:cNvSpPr>
+            <a:spLocks xmlns:a="http://schemas.openxmlformats.org/drawingml/2006/main" noGrp="1"/>
+          </p:cNvSpPr>
+          <p:nvPr/>
+        </p:nvSpPr>
+        <p:spPr>
+          <a:xfrm xmlns:a="http://schemas.openxmlformats.org/drawingml/2006/main">
+            <a:off x="4612958" y="4900613"/>
+            <a:ext cx="2949607" cy="819150"/>
+          </a:xfrm>
+          <a:prstGeom xmlns:a="http://schemas.openxmlformats.org/drawingml/2006/main" prst="rect">
+            <a:avLst/>
+          </a:prstGeom>
+        </p:spPr>
+        <p:txBody>
+          <a:bodyPr xmlns:a="http://schemas.openxmlformats.org/drawingml/2006/main" lIns="0" tIns="45720" rIns="91440" bIns="45720" anchor="t">
+            <a:normAutofit fontScale="100000"/>
+          </a:bodyPr>
+          <a:lstStyle xmlns:a="http://schemas.openxmlformats.org/drawingml/2006/main"/>
+          <a:p xmlns:a="http://schemas.openxmlformats.org/drawingml/2006/main">
+            <a:pPr algn="l">
+              <a:buNone/>
+              <a:defRPr sz="1575">
+                <a:solidFill>
+                  <a:srgbClr val="000000"/>
+                </a:solidFill>
+                <a:latin typeface="Helvetica Neue"/>
+                <a:ea typeface="Helvetica Neue"/>
+                <a:cs typeface="Helvetica Neue"/>
+              </a:defRPr>
+            </a:pPr>
+            <a:r>
+              <a:t>Commodity chains · stock peers</a:t>
+            </a:r>
+          </a:p>
+          <a:p xmlns:a="http://schemas.openxmlformats.org/drawingml/2006/main">
+            <a:pPr algn="l">
+              <a:buNone/>
+              <a:defRPr sz="1575">
+                <a:solidFill>
+                  <a:srgbClr val="000000"/>
+                </a:solidFill>
+                <a:latin typeface="Helvetica Neue"/>
+                <a:ea typeface="Helvetica Neue"/>
+                <a:cs typeface="Helvetica Neue"/>
+              </a:defRPr>
+            </a:pPr>
+            <a:r>
+              <a:t>Country/macro triangles</a:t>
+            </a:r>
+          </a:p>
+        </p:txBody>
+      </p:sp>
+      <p:sp>
+        <p:nvSpPr>
+          <p:cNvPr id="11" name="stat-3">
+            <a:extLst xmlns:a="http://schemas.openxmlformats.org/drawingml/2006/main">
+              <a:ext uri="{FF2B5EF4-FFF2-40B4-BE49-F238E27FC236}">
+                <a16:creationId xmlns:a16="http://schemas.microsoft.com/office/drawing/2014/main" id="{A0AD0C21-BC31-4957-B0CB-525311D4386F}"/>
+              </a:ext>
+            </a:extLst>
+          </p:cNvPr>
+          <p:cNvSpPr>
+            <a:spLocks xmlns:a="http://schemas.openxmlformats.org/drawingml/2006/main" noGrp="1"/>
+          </p:cNvSpPr>
+          <p:nvPr/>
+        </p:nvSpPr>
+        <p:spPr>
+          <a:xfrm xmlns:a="http://schemas.openxmlformats.org/drawingml/2006/main">
+            <a:off x="8562404" y="3429000"/>
+            <a:ext cx="2940082" cy="1359313"/>
+          </a:xfrm>
+          <a:prstGeom xmlns:a="http://schemas.openxmlformats.org/drawingml/2006/main" prst="rect">
+            <a:avLst/>
+          </a:prstGeom>
+        </p:spPr>
+        <p:txBody>
+          <a:bodyPr xmlns:a="http://schemas.openxmlformats.org/drawingml/2006/main" lIns="0" tIns="0" rIns="0" bIns="0" anchor="b">
+            <a:normAutofit fontScale="100000"/>
+          </a:bodyPr>
+          <a:lstStyle xmlns:a="http://schemas.openxmlformats.org/drawingml/2006/main"/>
+          <a:p xmlns:a="http://schemas.openxmlformats.org/drawingml/2006/main">
+            <a:pPr algn="l">
+              <a:buNone/>
+              <a:defRPr sz="3225">
+                <a:solidFill>
+                  <a:srgbClr val="000000"/>
+                </a:solidFill>
+                <a:latin typeface="Helvetica Neue"/>
+                <a:ea typeface="Helvetica Neue"/>
+                <a:cs typeface="Helvetica Neue"/>
+              </a:defRPr>
+            </a:pPr>
+            <a:r>
+              <a:t>1 rule</a:t>
+            </a:r>
+          </a:p>
+        </p:txBody>
+      </p:sp>
+      <p:sp>
+        <p:nvSpPr>
+          <p:cNvPr id="12" name="stat-label-3">
+            <a:extLst xmlns:a="http://schemas.openxmlformats.org/drawingml/2006/main">
+              <a:ext uri="{FF2B5EF4-FFF2-40B4-BE49-F238E27FC236}">
+                <a16:creationId xmlns:a16="http://schemas.microsoft.com/office/drawing/2014/main" id="{86C9D445-5711-4319-B967-D72E959CA06D}"/>
+              </a:ext>
+            </a:extLst>
+          </p:cNvPr>
+          <p:cNvSpPr>
+            <a:spLocks xmlns:a="http://schemas.openxmlformats.org/drawingml/2006/main" noGrp="1"/>
+          </p:cNvSpPr>
+          <p:nvPr/>
+        </p:nvSpPr>
+        <p:spPr>
+          <a:xfrm xmlns:a="http://schemas.openxmlformats.org/drawingml/2006/main">
+            <a:off x="8562404" y="4900613"/>
+            <a:ext cx="2949607" cy="819150"/>
+          </a:xfrm>
+          <a:prstGeom xmlns:a="http://schemas.openxmlformats.org/drawingml/2006/main" prst="rect">
+            <a:avLst/>
+          </a:prstGeom>
+        </p:spPr>
+        <p:txBody>
+          <a:bodyPr xmlns:a="http://schemas.openxmlformats.org/drawingml/2006/main" lIns="0" tIns="45720" rIns="91440" bIns="45720" anchor="t">
+            <a:normAutofit fontScale="99945"/>
+          </a:bodyPr>
+          <a:lstStyle xmlns:a="http://schemas.openxmlformats.org/drawingml/2006/main"/>
+          <a:p xmlns:a="http://schemas.openxmlformats.org/drawingml/2006/main">
+            <a:pPr algn="l">
+              <a:buNone/>
+              <a:defRPr sz="1575">
+                <a:solidFill>
+                  <a:srgbClr val="000000"/>
+                </a:solidFill>
+                <a:latin typeface="Helvetica Neue"/>
+                <a:ea typeface="Helvetica Neue"/>
+                <a:cs typeface="Helvetica Neue"/>
+              </a:defRPr>
+            </a:pPr>
+            <a:r>
+              <a:t>Same Johansen rank · frozen vector</a:t>
+            </a:r>
+          </a:p>
+          <a:p xmlns:a="http://schemas.openxmlformats.org/drawingml/2006/main">
+            <a:pPr algn="l">
+              <a:buNone/>
+              <a:defRPr sz="1575">
+                <a:solidFill>
+                  <a:srgbClr val="000000"/>
+                </a:solidFill>
+                <a:latin typeface="Helvetica Neue"/>
+                <a:ea typeface="Helvetica Neue"/>
+                <a:cs typeface="Helvetica Neue"/>
+              </a:defRPr>
+            </a:pPr>
+            <a:r>
+              <a:t>Same 20-session rule and eight gates</a:t>
+            </a:r>
+          </a:p>
+        </p:txBody>
+      </p:sp>
+    </p:spTree>
+    <p:extLst>
+      <p:ext uri="{BB962C8B-B14F-4D97-AF65-F5344CB8AC3E}">
+        <p14:creationId xmlns:p14="http://schemas.microsoft.com/office/powerpoint/2010/main" val="2098249639"/>
+      </p:ext>
+    </p:extLst>
+  </p:cSld>
+</p:sld>
+</file>
+
 <file path=ppt/slides/slide2.xml><?xml version="1.0" encoding="utf-8"?>
 <p:sld xmlns:p="http://schemas.openxmlformats.org/presentationml/2006/main">
   <p:cSld>
@@ -6253,6 +7791,2174 @@
     <p:extLst>
       <p:ext uri="{BB962C8B-B14F-4D97-AF65-F5344CB8AC3E}">
         <p14:creationId xmlns:p14="http://schemas.microsoft.com/office/powerpoint/2010/main" val="2098249639"/>
+      </p:ext>
+    </p:extLst>
+  </p:cSld>
+</p:sld>
+</file>
+
+<file path=ppt/slides/slide20.xml><?xml version="1.0" encoding="utf-8"?>
+<p:sld xmlns:p="http://schemas.openxmlformats.org/presentationml/2006/main">
+  <p:cSld>
+    <p:spTree>
+      <p:nvGrpSpPr>
+        <p:cNvPr id="1" name=""/>
+        <p:cNvGrpSpPr/>
+        <p:nvPr/>
+      </p:nvGrpSpPr>
+      <p:grpSpPr>
+        <a:xfrm xmlns:a="http://schemas.openxmlformats.org/drawingml/2006/main"/>
+      </p:grpSpPr>
+      <p:sp>
+        <p:nvSpPr>
+          <p:cNvPr id="13" name="stat-card-1">
+            <a:extLst xmlns:a="http://schemas.openxmlformats.org/drawingml/2006/main">
+              <a:ext uri="{FF2B5EF4-FFF2-40B4-BE49-F238E27FC236}">
+                <a16:creationId xmlns:a16="http://schemas.microsoft.com/office/drawing/2014/main" id="{8D249104-692F-481F-82EC-326C84E9007D}"/>
+              </a:ext>
+            </a:extLst>
+          </p:cNvPr>
+          <p:cNvSpPr>
+            <a:spLocks xmlns:a="http://schemas.openxmlformats.org/drawingml/2006/main" noGrp="1"/>
+          </p:cNvSpPr>
+          <p:nvPr/>
+        </p:nvSpPr>
+        <p:spPr>
+          <a:xfrm xmlns:a="http://schemas.openxmlformats.org/drawingml/2006/main">
+            <a:off x="393668" y="3022568"/>
+            <a:ext cx="3568732" cy="2971800"/>
+          </a:xfrm>
+          <a:prstGeom xmlns:a="http://schemas.openxmlformats.org/drawingml/2006/main" prst="roundRect">
+            <a:avLst>
+              <a:gd name="adj" fmla="val 2564"/>
+            </a:avLst>
+          </a:prstGeom>
+          <a:solidFill xmlns:a="http://schemas.openxmlformats.org/drawingml/2006/main">
+            <a:srgbClr val="F2F2F2"/>
+          </a:solidFill>
+        </p:spPr>
+      </p:sp>
+      <p:sp>
+        <p:nvSpPr>
+          <p:cNvPr id="2" name="stat-card-2">
+            <a:extLst xmlns:a="http://schemas.openxmlformats.org/drawingml/2006/main">
+              <a:ext uri="{FF2B5EF4-FFF2-40B4-BE49-F238E27FC236}">
+                <a16:creationId xmlns:a16="http://schemas.microsoft.com/office/drawing/2014/main" id="{02412AD9-1F13-493C-BF6C-FD8BDE750CD9}"/>
+              </a:ext>
+            </a:extLst>
+          </p:cNvPr>
+          <p:cNvSpPr>
+            <a:spLocks xmlns:a="http://schemas.openxmlformats.org/drawingml/2006/main" noGrp="1"/>
+          </p:cNvSpPr>
+          <p:nvPr/>
+        </p:nvSpPr>
+        <p:spPr>
+          <a:xfrm xmlns:a="http://schemas.openxmlformats.org/drawingml/2006/main">
+            <a:off x="4311682" y="3022568"/>
+            <a:ext cx="3568732" cy="2971800"/>
+          </a:xfrm>
+          <a:prstGeom xmlns:a="http://schemas.openxmlformats.org/drawingml/2006/main" prst="roundRect">
+            <a:avLst>
+              <a:gd name="adj" fmla="val 2564"/>
+            </a:avLst>
+          </a:prstGeom>
+          <a:solidFill xmlns:a="http://schemas.openxmlformats.org/drawingml/2006/main">
+            <a:srgbClr val="F2F2F2"/>
+          </a:solidFill>
+        </p:spPr>
+      </p:sp>
+      <p:sp>
+        <p:nvSpPr>
+          <p:cNvPr id="3" name="stat-card-3">
+            <a:extLst xmlns:a="http://schemas.openxmlformats.org/drawingml/2006/main">
+              <a:ext uri="{FF2B5EF4-FFF2-40B4-BE49-F238E27FC236}">
+                <a16:creationId xmlns:a16="http://schemas.microsoft.com/office/drawing/2014/main" id="{63597CCF-F233-4A0C-BCFA-192F852FDBEA}"/>
+              </a:ext>
+            </a:extLst>
+          </p:cNvPr>
+          <p:cNvSpPr>
+            <a:spLocks xmlns:a="http://schemas.openxmlformats.org/drawingml/2006/main" noGrp="1"/>
+          </p:cNvSpPr>
+          <p:nvPr/>
+        </p:nvSpPr>
+        <p:spPr>
+          <a:xfrm xmlns:a="http://schemas.openxmlformats.org/drawingml/2006/main">
+            <a:off x="8232267" y="3022568"/>
+            <a:ext cx="3568732" cy="2971800"/>
+          </a:xfrm>
+          <a:prstGeom xmlns:a="http://schemas.openxmlformats.org/drawingml/2006/main" prst="roundRect">
+            <a:avLst>
+              <a:gd name="adj" fmla="val 2564"/>
+            </a:avLst>
+          </a:prstGeom>
+          <a:solidFill xmlns:a="http://schemas.openxmlformats.org/drawingml/2006/main">
+            <a:srgbClr val="F2F2F2"/>
+          </a:solidFill>
+        </p:spPr>
+      </p:sp>
+      <p:sp>
+        <p:nvSpPr>
+          <p:cNvPr id="4" name="footer">
+            <a:extLst xmlns:a="http://schemas.openxmlformats.org/drawingml/2006/main">
+              <a:ext uri="{FF2B5EF4-FFF2-40B4-BE49-F238E27FC236}">
+                <a16:creationId xmlns:a16="http://schemas.microsoft.com/office/drawing/2014/main" id="{11E272E4-82E7-4287-91C5-21E6B629F553}"/>
+              </a:ext>
+            </a:extLst>
+          </p:cNvPr>
+          <p:cNvSpPr>
+            <a:spLocks xmlns:a="http://schemas.openxmlformats.org/drawingml/2006/main" noGrp="1"/>
+          </p:cNvSpPr>
+          <p:nvPr/>
+        </p:nvSpPr>
+        <p:spPr>
+          <a:xfrm xmlns:a="http://schemas.openxmlformats.org/drawingml/2006/main">
+            <a:off x="11279315" y="6279261"/>
+            <a:ext cx="518922" cy="241268"/>
+          </a:xfrm>
+          <a:prstGeom xmlns:a="http://schemas.openxmlformats.org/drawingml/2006/main" prst="rect">
+            <a:avLst/>
+          </a:prstGeom>
+        </p:spPr>
+        <p:txBody>
+          <a:bodyPr xmlns:a="http://schemas.openxmlformats.org/drawingml/2006/main" lIns="0" tIns="0" rIns="0" bIns="0" anchor="b"/>
+          <a:lstStyle xmlns:a="http://schemas.openxmlformats.org/drawingml/2006/main"/>
+          <a:p xmlns:a="http://schemas.openxmlformats.org/drawingml/2006/main">
+            <a:pPr algn="r">
+              <a:buNone/>
+              <a:defRPr sz="1000">
+                <a:solidFill>
+                  <a:srgbClr val="000000"/>
+                </a:solidFill>
+                <a:latin typeface="Helvetica Neue"/>
+                <a:ea typeface="Helvetica Neue"/>
+                <a:cs typeface="Helvetica Neue"/>
+              </a:defRPr>
+            </a:pPr>
+            <a:r>
+              <a:t>20</a:t>
+            </a:r>
+          </a:p>
+        </p:txBody>
+      </p:sp>
+      <p:sp>
+        <p:nvSpPr>
+          <p:cNvPr id="5" name="title">
+            <a:extLst xmlns:a="http://schemas.openxmlformats.org/drawingml/2006/main">
+              <a:ext uri="{FF2B5EF4-FFF2-40B4-BE49-F238E27FC236}">
+                <a16:creationId xmlns:a16="http://schemas.microsoft.com/office/drawing/2014/main" id="{A0ED332F-4F42-421E-99CF-097B6CBB5C19}"/>
+              </a:ext>
+            </a:extLst>
+          </p:cNvPr>
+          <p:cNvSpPr>
+            <a:spLocks xmlns:a="http://schemas.openxmlformats.org/drawingml/2006/main" noGrp="1"/>
+          </p:cNvSpPr>
+          <p:nvPr/>
+        </p:nvSpPr>
+        <p:spPr>
+          <a:xfrm xmlns:a="http://schemas.openxmlformats.org/drawingml/2006/main">
+            <a:off x="393668" y="344043"/>
+            <a:ext cx="11404568" cy="1047464"/>
+          </a:xfrm>
+          <a:prstGeom xmlns:a="http://schemas.openxmlformats.org/drawingml/2006/main" prst="rect">
+            <a:avLst/>
+          </a:prstGeom>
+        </p:spPr>
+        <p:txBody>
+          <a:bodyPr xmlns:a="http://schemas.openxmlformats.org/drawingml/2006/main" lIns="0" tIns="0" rIns="0" bIns="0" anchor="t">
+            <a:normAutofit fontScale="100000"/>
+          </a:bodyPr>
+          <a:lstStyle xmlns:a="http://schemas.openxmlformats.org/drawingml/2006/main"/>
+          <a:p xmlns:a="http://schemas.openxmlformats.org/drawingml/2006/main">
+            <a:pPr algn="l">
+              <a:buNone/>
+              <a:defRPr sz="2900">
+                <a:solidFill>
+                  <a:srgbClr val="000000"/>
+                </a:solidFill>
+                <a:latin typeface="Helvetica Neue"/>
+                <a:ea typeface="Helvetica Neue"/>
+                <a:cs typeface="Helvetica Neue"/>
+              </a:defRPr>
+            </a:pPr>
+            <a:r>
+              <a:t>Breadth increases multiplicity—but the leakage door stays one-way</a:t>
+            </a:r>
+          </a:p>
+        </p:txBody>
+      </p:sp>
+      <p:sp>
+        <p:nvSpPr>
+          <p:cNvPr id="6" name="intro">
+            <a:extLst xmlns:a="http://schemas.openxmlformats.org/drawingml/2006/main">
+              <a:ext uri="{FF2B5EF4-FFF2-40B4-BE49-F238E27FC236}">
+                <a16:creationId xmlns:a16="http://schemas.microsoft.com/office/drawing/2014/main" id="{E3D1AF2D-950D-495D-BB07-182C768AD88F}"/>
+              </a:ext>
+            </a:extLst>
+          </p:cNvPr>
+          <p:cNvSpPr>
+            <a:spLocks xmlns:a="http://schemas.openxmlformats.org/drawingml/2006/main" noGrp="1"/>
+          </p:cNvSpPr>
+          <p:nvPr/>
+        </p:nvSpPr>
+        <p:spPr>
+          <a:xfrm xmlns:a="http://schemas.openxmlformats.org/drawingml/2006/main">
+            <a:off x="393668" y="1219200"/>
+            <a:ext cx="11404568" cy="1428750"/>
+          </a:xfrm>
+          <a:prstGeom xmlns:a="http://schemas.openxmlformats.org/drawingml/2006/main" prst="rect">
+            <a:avLst/>
+          </a:prstGeom>
+        </p:spPr>
+        <p:txBody>
+          <a:bodyPr xmlns:a="http://schemas.openxmlformats.org/drawingml/2006/main" lIns="0" tIns="0" rIns="0" bIns="0" anchor="t">
+            <a:normAutofit fontScale="100000"/>
+          </a:bodyPr>
+          <a:lstStyle xmlns:a="http://schemas.openxmlformats.org/drawingml/2006/main"/>
+          <a:p xmlns:a="http://schemas.openxmlformats.org/drawingml/2006/main">
+            <a:pPr algn="l">
+              <a:buNone/>
+              <a:defRPr sz="1650">
+                <a:solidFill>
+                  <a:srgbClr val="000000"/>
+                </a:solidFill>
+                <a:latin typeface="Helvetica Neue"/>
+                <a:ea typeface="Helvetica Neue"/>
+                <a:cs typeface="Helvetica Neue"/>
+              </a:defRPr>
+            </a:pPr>
+            <a:r>
+              <a:t>Twenty-eight screens create more chances for an accidental TRAIN pass. The conjunction limits false nominations, while registry order and one-shot OOS prevent return ranking from choosing the winner.</a:t>
+            </a:r>
+          </a:p>
+        </p:txBody>
+      </p:sp>
+      <p:sp>
+        <p:nvSpPr>
+          <p:cNvPr id="7" name="stat-1">
+            <a:extLst xmlns:a="http://schemas.openxmlformats.org/drawingml/2006/main">
+              <a:ext uri="{FF2B5EF4-FFF2-40B4-BE49-F238E27FC236}">
+                <a16:creationId xmlns:a16="http://schemas.microsoft.com/office/drawing/2014/main" id="{447A29C0-2600-4241-BF6B-6797417FC507}"/>
+              </a:ext>
+            </a:extLst>
+          </p:cNvPr>
+          <p:cNvSpPr>
+            <a:spLocks xmlns:a="http://schemas.openxmlformats.org/drawingml/2006/main" noGrp="1"/>
+          </p:cNvSpPr>
+          <p:nvPr/>
+        </p:nvSpPr>
+        <p:spPr>
+          <a:xfrm xmlns:a="http://schemas.openxmlformats.org/drawingml/2006/main">
+            <a:off x="702374" y="3429000"/>
+            <a:ext cx="2940082" cy="1359313"/>
+          </a:xfrm>
+          <a:prstGeom xmlns:a="http://schemas.openxmlformats.org/drawingml/2006/main" prst="rect">
+            <a:avLst/>
+          </a:prstGeom>
+        </p:spPr>
+        <p:txBody>
+          <a:bodyPr xmlns:a="http://schemas.openxmlformats.org/drawingml/2006/main" lIns="0" tIns="0" rIns="0" bIns="0" anchor="b">
+            <a:normAutofit fontScale="100000"/>
+          </a:bodyPr>
+          <a:lstStyle xmlns:a="http://schemas.openxmlformats.org/drawingml/2006/main"/>
+          <a:p xmlns:a="http://schemas.openxmlformats.org/drawingml/2006/main">
+            <a:pPr algn="l">
+              <a:buNone/>
+              <a:defRPr sz="3225">
+                <a:solidFill>
+                  <a:srgbClr val="3D8DFF"/>
+                </a:solidFill>
+                <a:latin typeface="Helvetica Neue"/>
+                <a:ea typeface="Helvetica Neue"/>
+                <a:cs typeface="Helvetica Neue"/>
+              </a:defRPr>
+            </a:pPr>
+            <a:r>
+              <a:t>TRAIN</a:t>
+            </a:r>
+          </a:p>
+        </p:txBody>
+      </p:sp>
+      <p:sp>
+        <p:nvSpPr>
+          <p:cNvPr id="8" name="stat-label-1">
+            <a:extLst xmlns:a="http://schemas.openxmlformats.org/drawingml/2006/main">
+              <a:ext uri="{FF2B5EF4-FFF2-40B4-BE49-F238E27FC236}">
+                <a16:creationId xmlns:a16="http://schemas.microsoft.com/office/drawing/2014/main" id="{1D2A853D-A304-477D-B8B8-F77F0101AC08}"/>
+              </a:ext>
+            </a:extLst>
+          </p:cNvPr>
+          <p:cNvSpPr>
+            <a:spLocks xmlns:a="http://schemas.openxmlformats.org/drawingml/2006/main" noGrp="1"/>
+          </p:cNvSpPr>
+          <p:nvPr/>
+        </p:nvSpPr>
+        <p:spPr>
+          <a:xfrm xmlns:a="http://schemas.openxmlformats.org/drawingml/2006/main">
+            <a:off x="702374" y="4900613"/>
+            <a:ext cx="2949607" cy="819150"/>
+          </a:xfrm>
+          <a:prstGeom xmlns:a="http://schemas.openxmlformats.org/drawingml/2006/main" prst="rect">
+            <a:avLst/>
+          </a:prstGeom>
+        </p:spPr>
+        <p:txBody>
+          <a:bodyPr xmlns:a="http://schemas.openxmlformats.org/drawingml/2006/main" lIns="0" tIns="45720" rIns="91440" bIns="45720" anchor="t">
+            <a:normAutofit fontScale="100000"/>
+          </a:bodyPr>
+          <a:lstStyle xmlns:a="http://schemas.openxmlformats.org/drawingml/2006/main"/>
+          <a:p xmlns:a="http://schemas.openxmlformats.org/drawingml/2006/main">
+            <a:pPr algn="l">
+              <a:buNone/>
+              <a:defRPr sz="1575">
+                <a:solidFill>
+                  <a:srgbClr val="000000"/>
+                </a:solidFill>
+                <a:latin typeface="Helvetica Neue"/>
+                <a:ea typeface="Helvetica Neue"/>
+                <a:cs typeface="Helvetica Neue"/>
+              </a:defRPr>
+            </a:pPr>
+            <a:r>
+              <a:t>2016–2020 only</a:t>
+            </a:r>
+          </a:p>
+          <a:p xmlns:a="http://schemas.openxmlformats.org/drawingml/2006/main">
+            <a:pPr algn="l">
+              <a:buNone/>
+              <a:defRPr sz="1575">
+                <a:solidFill>
+                  <a:srgbClr val="000000"/>
+                </a:solidFill>
+                <a:latin typeface="Helvetica Neue"/>
+                <a:ea typeface="Helvetica Neue"/>
+                <a:cs typeface="Helvetica Neue"/>
+              </a:defRPr>
+            </a:pPr>
+            <a:r>
+              <a:t>Every candidate reported</a:t>
+            </a:r>
+          </a:p>
+        </p:txBody>
+      </p:sp>
+      <p:sp>
+        <p:nvSpPr>
+          <p:cNvPr id="9" name="stat-2">
+            <a:extLst xmlns:a="http://schemas.openxmlformats.org/drawingml/2006/main">
+              <a:ext uri="{FF2B5EF4-FFF2-40B4-BE49-F238E27FC236}">
+                <a16:creationId xmlns:a16="http://schemas.microsoft.com/office/drawing/2014/main" id="{342C60B8-5C35-4607-932D-DFD8E206B634}"/>
+              </a:ext>
+            </a:extLst>
+          </p:cNvPr>
+          <p:cNvSpPr>
+            <a:spLocks xmlns:a="http://schemas.openxmlformats.org/drawingml/2006/main" noGrp="1"/>
+          </p:cNvSpPr>
+          <p:nvPr/>
+        </p:nvSpPr>
+        <p:spPr>
+          <a:xfrm xmlns:a="http://schemas.openxmlformats.org/drawingml/2006/main">
+            <a:off x="4612958" y="3429000"/>
+            <a:ext cx="2940082" cy="1359313"/>
+          </a:xfrm>
+          <a:prstGeom xmlns:a="http://schemas.openxmlformats.org/drawingml/2006/main" prst="rect">
+            <a:avLst/>
+          </a:prstGeom>
+        </p:spPr>
+        <p:txBody>
+          <a:bodyPr xmlns:a="http://schemas.openxmlformats.org/drawingml/2006/main" lIns="0" tIns="0" rIns="0" bIns="0" anchor="b">
+            <a:normAutofit fontScale="100000"/>
+          </a:bodyPr>
+          <a:lstStyle xmlns:a="http://schemas.openxmlformats.org/drawingml/2006/main"/>
+          <a:p xmlns:a="http://schemas.openxmlformats.org/drawingml/2006/main">
+            <a:pPr algn="l">
+              <a:buNone/>
+              <a:defRPr sz="3225">
+                <a:solidFill>
+                  <a:srgbClr val="000000"/>
+                </a:solidFill>
+                <a:latin typeface="Helvetica Neue"/>
+                <a:ea typeface="Helvetica Neue"/>
+                <a:cs typeface="Helvetica Neue"/>
+              </a:defRPr>
+            </a:pPr>
+            <a:r>
+              <a:t>First pass</a:t>
+            </a:r>
+          </a:p>
+        </p:txBody>
+      </p:sp>
+      <p:sp>
+        <p:nvSpPr>
+          <p:cNvPr id="10" name="stat-label-2">
+            <a:extLst xmlns:a="http://schemas.openxmlformats.org/drawingml/2006/main">
+              <a:ext uri="{FF2B5EF4-FFF2-40B4-BE49-F238E27FC236}">
+                <a16:creationId xmlns:a16="http://schemas.microsoft.com/office/drawing/2014/main" id="{3123331A-6BB6-4FC3-B18C-EE98C6A8FF13}"/>
+              </a:ext>
+            </a:extLst>
+          </p:cNvPr>
+          <p:cNvSpPr>
+            <a:spLocks xmlns:a="http://schemas.openxmlformats.org/drawingml/2006/main" noGrp="1"/>
+          </p:cNvSpPr>
+          <p:nvPr/>
+        </p:nvSpPr>
+        <p:spPr>
+          <a:xfrm xmlns:a="http://schemas.openxmlformats.org/drawingml/2006/main">
+            <a:off x="4612958" y="4900613"/>
+            <a:ext cx="2949607" cy="819150"/>
+          </a:xfrm>
+          <a:prstGeom xmlns:a="http://schemas.openxmlformats.org/drawingml/2006/main" prst="rect">
+            <a:avLst/>
+          </a:prstGeom>
+        </p:spPr>
+        <p:txBody>
+          <a:bodyPr xmlns:a="http://schemas.openxmlformats.org/drawingml/2006/main" lIns="0" tIns="45720" rIns="91440" bIns="45720" anchor="t">
+            <a:normAutofit fontScale="100000"/>
+          </a:bodyPr>
+          <a:lstStyle xmlns:a="http://schemas.openxmlformats.org/drawingml/2006/main"/>
+          <a:p xmlns:a="http://schemas.openxmlformats.org/drawingml/2006/main">
+            <a:pPr algn="l">
+              <a:buNone/>
+              <a:defRPr sz="1575">
+                <a:solidFill>
+                  <a:srgbClr val="000000"/>
+                </a:solidFill>
+                <a:latin typeface="Helvetica Neue"/>
+                <a:ea typeface="Helvetica Neue"/>
+                <a:cs typeface="Helvetica Neue"/>
+              </a:defRPr>
+            </a:pPr>
+            <a:r>
+              <a:t>First 8/8 row in frozen order</a:t>
+            </a:r>
+          </a:p>
+          <a:p xmlns:a="http://schemas.openxmlformats.org/drawingml/2006/main">
+            <a:pPr algn="l">
+              <a:buNone/>
+              <a:defRPr sz="1575">
+                <a:solidFill>
+                  <a:srgbClr val="000000"/>
+                </a:solidFill>
+                <a:latin typeface="Helvetica Neue"/>
+                <a:ea typeface="Helvetica Neue"/>
+                <a:cs typeface="Helvetica Neue"/>
+              </a:defRPr>
+            </a:pPr>
+            <a:r>
+              <a:t>Identity and β̂ locked</a:t>
+            </a:r>
+          </a:p>
+        </p:txBody>
+      </p:sp>
+      <p:sp>
+        <p:nvSpPr>
+          <p:cNvPr id="11" name="stat-3">
+            <a:extLst xmlns:a="http://schemas.openxmlformats.org/drawingml/2006/main">
+              <a:ext uri="{FF2B5EF4-FFF2-40B4-BE49-F238E27FC236}">
+                <a16:creationId xmlns:a16="http://schemas.microsoft.com/office/drawing/2014/main" id="{A0AD0C21-BC31-4957-B0CB-525311D4386F}"/>
+              </a:ext>
+            </a:extLst>
+          </p:cNvPr>
+          <p:cNvSpPr>
+            <a:spLocks xmlns:a="http://schemas.openxmlformats.org/drawingml/2006/main" noGrp="1"/>
+          </p:cNvSpPr>
+          <p:nvPr/>
+        </p:nvSpPr>
+        <p:spPr>
+          <a:xfrm xmlns:a="http://schemas.openxmlformats.org/drawingml/2006/main">
+            <a:off x="8562404" y="3429000"/>
+            <a:ext cx="2940082" cy="1359313"/>
+          </a:xfrm>
+          <a:prstGeom xmlns:a="http://schemas.openxmlformats.org/drawingml/2006/main" prst="rect">
+            <a:avLst/>
+          </a:prstGeom>
+        </p:spPr>
+        <p:txBody>
+          <a:bodyPr xmlns:a="http://schemas.openxmlformats.org/drawingml/2006/main" lIns="0" tIns="0" rIns="0" bIns="0" anchor="b">
+            <a:normAutofit fontScale="100000"/>
+          </a:bodyPr>
+          <a:lstStyle xmlns:a="http://schemas.openxmlformats.org/drawingml/2006/main"/>
+          <a:p xmlns:a="http://schemas.openxmlformats.org/drawingml/2006/main">
+            <a:pPr algn="l">
+              <a:buNone/>
+              <a:defRPr sz="3225">
+                <a:solidFill>
+                  <a:srgbClr val="000000"/>
+                </a:solidFill>
+                <a:latin typeface="Helvetica Neue"/>
+                <a:ea typeface="Helvetica Neue"/>
+                <a:cs typeface="Helvetica Neue"/>
+              </a:defRPr>
+            </a:pPr>
+            <a:r>
+              <a:t>One OOS</a:t>
+            </a:r>
+          </a:p>
+        </p:txBody>
+      </p:sp>
+      <p:sp>
+        <p:nvSpPr>
+          <p:cNvPr id="12" name="stat-label-3">
+            <a:extLst xmlns:a="http://schemas.openxmlformats.org/drawingml/2006/main">
+              <a:ext uri="{FF2B5EF4-FFF2-40B4-BE49-F238E27FC236}">
+                <a16:creationId xmlns:a16="http://schemas.microsoft.com/office/drawing/2014/main" id="{86C9D445-5711-4319-B967-D72E959CA06D}"/>
+              </a:ext>
+            </a:extLst>
+          </p:cNvPr>
+          <p:cNvSpPr>
+            <a:spLocks xmlns:a="http://schemas.openxmlformats.org/drawingml/2006/main" noGrp="1"/>
+          </p:cNvSpPr>
+          <p:nvPr/>
+        </p:nvSpPr>
+        <p:spPr>
+          <a:xfrm xmlns:a="http://schemas.openxmlformats.org/drawingml/2006/main">
+            <a:off x="8562404" y="4900613"/>
+            <a:ext cx="2949607" cy="819150"/>
+          </a:xfrm>
+          <a:prstGeom xmlns:a="http://schemas.openxmlformats.org/drawingml/2006/main" prst="rect">
+            <a:avLst/>
+          </a:prstGeom>
+        </p:spPr>
+        <p:txBody>
+          <a:bodyPr xmlns:a="http://schemas.openxmlformats.org/drawingml/2006/main" lIns="0" tIns="45720" rIns="91440" bIns="45720" anchor="t">
+            <a:normAutofit fontScale="100000"/>
+          </a:bodyPr>
+          <a:lstStyle xmlns:a="http://schemas.openxmlformats.org/drawingml/2006/main"/>
+          <a:p xmlns:a="http://schemas.openxmlformats.org/drawingml/2006/main">
+            <a:pPr algn="l">
+              <a:buNone/>
+              <a:defRPr sz="1575">
+                <a:solidFill>
+                  <a:srgbClr val="000000"/>
+                </a:solidFill>
+                <a:latin typeface="Helvetica Neue"/>
+                <a:ea typeface="Helvetica Neue"/>
+                <a:cs typeface="Helvetica Neue"/>
+              </a:defRPr>
+            </a:pPr>
+            <a:r>
+              <a:t>2021–2023 for that identity only</a:t>
+            </a:r>
+          </a:p>
+          <a:p xmlns:a="http://schemas.openxmlformats.org/drawingml/2006/main">
+            <a:pPr algn="l">
+              <a:buNone/>
+              <a:defRPr sz="1575">
+                <a:solidFill>
+                  <a:srgbClr val="000000"/>
+                </a:solidFill>
+                <a:latin typeface="Helvetica Neue"/>
+                <a:ea typeface="Helvetica Neue"/>
+                <a:cs typeface="Helvetica Neue"/>
+              </a:defRPr>
+            </a:pPr>
+            <a:r>
+              <a:t>No replacement · 2024+ sealed</a:t>
+            </a:r>
+          </a:p>
+        </p:txBody>
+      </p:sp>
+    </p:spTree>
+    <p:extLst>
+      <p:ext uri="{BB962C8B-B14F-4D97-AF65-F5344CB8AC3E}">
+        <p14:creationId xmlns:p14="http://schemas.microsoft.com/office/powerpoint/2010/main" val="2098249639"/>
+      </p:ext>
+    </p:extLst>
+  </p:cSld>
+</p:sld>
+</file>
+
+<file path=ppt/slides/slide21.xml><?xml version="1.0" encoding="utf-8"?>
+<p:sld xmlns:p="http://schemas.openxmlformats.org/presentationml/2006/main">
+  <p:cSld>
+    <p:spTree>
+      <p:nvGrpSpPr>
+        <p:cNvPr id="1" name=""/>
+        <p:cNvGrpSpPr/>
+        <p:nvPr/>
+      </p:nvGrpSpPr>
+      <p:grpSpPr>
+        <a:xfrm xmlns:a="http://schemas.openxmlformats.org/drawingml/2006/main"/>
+      </p:grpSpPr>
+      <p:sp>
+        <p:nvSpPr>
+          <p:cNvPr id="6" name="footer">
+            <a:extLst xmlns:a="http://schemas.openxmlformats.org/drawingml/2006/main">
+              <a:ext uri="{FF2B5EF4-FFF2-40B4-BE49-F238E27FC236}">
+                <a16:creationId xmlns:a16="http://schemas.microsoft.com/office/drawing/2014/main" id="{5D1F4916-B18D-4F3F-8812-75A699D9A639}"/>
+              </a:ext>
+            </a:extLst>
+          </p:cNvPr>
+          <p:cNvSpPr>
+            <a:spLocks xmlns:a="http://schemas.openxmlformats.org/drawingml/2006/main" noGrp="1"/>
+          </p:cNvSpPr>
+          <p:nvPr/>
+        </p:nvSpPr>
+        <p:spPr>
+          <a:xfrm xmlns:a="http://schemas.openxmlformats.org/drawingml/2006/main">
+            <a:off x="11279315" y="6279261"/>
+            <a:ext cx="518922" cy="241268"/>
+          </a:xfrm>
+          <a:prstGeom xmlns:a="http://schemas.openxmlformats.org/drawingml/2006/main" prst="rect">
+            <a:avLst/>
+          </a:prstGeom>
+        </p:spPr>
+        <p:txBody>
+          <a:bodyPr xmlns:a="http://schemas.openxmlformats.org/drawingml/2006/main" lIns="0" tIns="0" rIns="0" bIns="0" anchor="b"/>
+          <a:lstStyle xmlns:a="http://schemas.openxmlformats.org/drawingml/2006/main"/>
+          <a:p xmlns:a="http://schemas.openxmlformats.org/drawingml/2006/main">
+            <a:pPr algn="r">
+              <a:buNone/>
+              <a:defRPr sz="1000">
+                <a:solidFill>
+                  <a:srgbClr val="000000"/>
+                </a:solidFill>
+                <a:latin typeface="Helvetica Neue"/>
+                <a:ea typeface="Helvetica Neue"/>
+                <a:cs typeface="Helvetica Neue"/>
+              </a:defRPr>
+            </a:pPr>
+            <a:r>
+              <a:t>21</a:t>
+            </a:r>
+          </a:p>
+        </p:txBody>
+      </p:sp>
+      <p:sp>
+        <p:nvSpPr>
+          <p:cNvPr id="2" name="title">
+            <a:extLst xmlns:a="http://schemas.openxmlformats.org/drawingml/2006/main">
+              <a:ext uri="{FF2B5EF4-FFF2-40B4-BE49-F238E27FC236}">
+                <a16:creationId xmlns:a16="http://schemas.microsoft.com/office/drawing/2014/main" id="{ECB77D9D-0CB0-4878-9A4A-2687A311CD30}"/>
+              </a:ext>
+            </a:extLst>
+          </p:cNvPr>
+          <p:cNvSpPr>
+            <a:spLocks xmlns:a="http://schemas.openxmlformats.org/drawingml/2006/main" noGrp="1"/>
+          </p:cNvSpPr>
+          <p:nvPr/>
+        </p:nvSpPr>
+        <p:spPr>
+          <a:xfrm xmlns:a="http://schemas.openxmlformats.org/drawingml/2006/main">
+            <a:off x="393668" y="295275"/>
+            <a:ext cx="11404568" cy="876300"/>
+          </a:xfrm>
+          <a:prstGeom xmlns:a="http://schemas.openxmlformats.org/drawingml/2006/main" prst="rect">
+            <a:avLst/>
+          </a:prstGeom>
+        </p:spPr>
+        <p:txBody>
+          <a:bodyPr xmlns:a="http://schemas.openxmlformats.org/drawingml/2006/main" lIns="0" tIns="0" rIns="0" bIns="0" anchor="t">
+            <a:normAutofit fontScale="100000"/>
+          </a:bodyPr>
+          <a:lstStyle xmlns:a="http://schemas.openxmlformats.org/drawingml/2006/main"/>
+          <a:p xmlns:a="http://schemas.openxmlformats.org/drawingml/2006/main">
+            <a:pPr algn="l">
+              <a:buNone/>
+              <a:defRPr sz="2900">
+                <a:solidFill>
+                  <a:srgbClr val="000000"/>
+                </a:solidFill>
+                <a:latin typeface="Helvetica Neue"/>
+                <a:ea typeface="Helvetica Neue"/>
+                <a:cs typeface="Helvetica Neue"/>
+              </a:defRPr>
+            </a:pPr>
+            <a:r>
+              <a:t>Categories separated common diagnostics from a full nomination</a:t>
+            </a:r>
+          </a:p>
+        </p:txBody>
+      </p:sp>
+      <p:pic>
+        <p:nvPicPr>
+          <p:cNvPr id="13" name=""/>
+          <p:cNvPicPr>
+            <a:picLocks xmlns:a="http://schemas.openxmlformats.org/drawingml/2006/main" noChangeAspect="1"/>
+          </p:cNvPicPr>
+          <p:nvPr/>
+        </p:nvPicPr>
+        <p:blipFill>
+          <a:blip xmlns:r="http://schemas.openxmlformats.org/officeDocument/2006/relationships" xmlns:a="http://schemas.openxmlformats.org/drawingml/2006/main" r:embed="R2aca023510dd42a4"/>
+          <a:stretch xmlns:a="http://schemas.openxmlformats.org/drawingml/2006/main"/>
+        </p:blipFill>
+        <p:spPr>
+          <a:xfrm xmlns:a="http://schemas.openxmlformats.org/drawingml/2006/main">
+            <a:off x="2662238" y="1162050"/>
+            <a:ext cx="6867525" cy="4905375"/>
+          </a:xfrm>
+          <a:prstGeom xmlns:a="http://schemas.openxmlformats.org/drawingml/2006/main" prst="rect">
+            <a:avLst/>
+          </a:prstGeom>
+        </p:spPr>
+      </p:pic>
+      <p:sp>
+        <p:nvSpPr>
+          <p:cNvPr id="8" name="">
+            <a:extLst xmlns:a="http://schemas.openxmlformats.org/drawingml/2006/main">
+              <a:ext uri="{FF2B5EF4-FFF2-40B4-BE49-F238E27FC236}">
+                <a16:creationId xmlns:a16="http://schemas.microsoft.com/office/drawing/2014/main" id="{8694B3C2-83ED-40A2-ACF7-D3B740A01244}"/>
+              </a:ext>
+            </a:extLst>
+          </p:cNvPr>
+          <p:cNvSpPr>
+            <a:spLocks xmlns:a="http://schemas.openxmlformats.org/drawingml/2006/main" noGrp="1"/>
+          </p:cNvSpPr>
+          <p:nvPr/>
+        </p:nvSpPr>
+        <p:spPr>
+          <a:xfrm xmlns:a="http://schemas.openxmlformats.org/drawingml/2006/main">
+            <a:off x="1891393" y="1162050"/>
+            <a:ext cx="8409214" cy="4905375"/>
+          </a:xfrm>
+          <a:prstGeom xmlns:a="http://schemas.openxmlformats.org/drawingml/2006/main" prst="rect">
+            <a:avLst/>
+          </a:prstGeom>
+          <a:solidFill xmlns:a="http://schemas.openxmlformats.org/drawingml/2006/main">
+            <a:srgbClr val="FFFFFF"/>
+          </a:solidFill>
+          <a:ln xmlns:a="http://schemas.openxmlformats.org/drawingml/2006/main" w="0">
+            <a:solidFill>
+              <a:srgbClr val="FFFFFF"/>
+            </a:solidFill>
+            <a:prstDash val="solid"/>
+          </a:ln>
+        </p:spPr>
+      </p:sp>
+      <p:pic>
+        <p:nvPicPr>
+          <p:cNvPr id="15" name=""/>
+          <p:cNvPicPr>
+            <a:picLocks xmlns:a="http://schemas.openxmlformats.org/drawingml/2006/main" noChangeAspect="1"/>
+          </p:cNvPicPr>
+          <p:nvPr/>
+        </p:nvPicPr>
+        <p:blipFill>
+          <a:blip xmlns:r="http://schemas.openxmlformats.org/officeDocument/2006/relationships" xmlns:a="http://schemas.openxmlformats.org/drawingml/2006/main" r:embed="Rb027e92231fa461f"/>
+          <a:stretch xmlns:a="http://schemas.openxmlformats.org/drawingml/2006/main"/>
+        </p:blipFill>
+        <p:spPr>
+          <a:xfrm xmlns:a="http://schemas.openxmlformats.org/drawingml/2006/main">
+            <a:off x="2367915" y="1162050"/>
+            <a:ext cx="7456170" cy="4905375"/>
+          </a:xfrm>
+          <a:prstGeom xmlns:a="http://schemas.openxmlformats.org/drawingml/2006/main" prst="rect">
+            <a:avLst/>
+          </a:prstGeom>
+        </p:spPr>
+      </p:pic>
+    </p:spTree>
+    <p:extLst>
+      <p:ext uri="{BB962C8B-B14F-4D97-AF65-F5344CB8AC3E}">
+        <p14:creationId xmlns:p14="http://schemas.microsoft.com/office/powerpoint/2010/main" val="463436756"/>
+      </p:ext>
+    </p:extLst>
+  </p:cSld>
+</p:sld>
+</file>
+
+<file path=ppt/slides/slide22.xml><?xml version="1.0" encoding="utf-8"?>
+<p:sld xmlns:p="http://schemas.openxmlformats.org/presentationml/2006/main">
+  <p:cSld>
+    <p:spTree>
+      <p:nvGrpSpPr>
+        <p:cNvPr id="1" name=""/>
+        <p:cNvGrpSpPr/>
+        <p:nvPr/>
+      </p:nvGrpSpPr>
+      <p:grpSpPr>
+        <a:xfrm xmlns:a="http://schemas.openxmlformats.org/drawingml/2006/main"/>
+      </p:grpSpPr>
+      <p:sp>
+        <p:nvSpPr>
+          <p:cNvPr id="6" name="footer">
+            <a:extLst xmlns:a="http://schemas.openxmlformats.org/drawingml/2006/main">
+              <a:ext uri="{FF2B5EF4-FFF2-40B4-BE49-F238E27FC236}">
+                <a16:creationId xmlns:a16="http://schemas.microsoft.com/office/drawing/2014/main" id="{5D1F4916-B18D-4F3F-8812-75A699D9A639}"/>
+              </a:ext>
+            </a:extLst>
+          </p:cNvPr>
+          <p:cNvSpPr>
+            <a:spLocks xmlns:a="http://schemas.openxmlformats.org/drawingml/2006/main" noGrp="1"/>
+          </p:cNvSpPr>
+          <p:nvPr/>
+        </p:nvSpPr>
+        <p:spPr>
+          <a:xfrm xmlns:a="http://schemas.openxmlformats.org/drawingml/2006/main">
+            <a:off x="11279315" y="6279261"/>
+            <a:ext cx="518922" cy="241268"/>
+          </a:xfrm>
+          <a:prstGeom xmlns:a="http://schemas.openxmlformats.org/drawingml/2006/main" prst="rect">
+            <a:avLst/>
+          </a:prstGeom>
+        </p:spPr>
+        <p:txBody>
+          <a:bodyPr xmlns:a="http://schemas.openxmlformats.org/drawingml/2006/main" lIns="0" tIns="0" rIns="0" bIns="0" anchor="b"/>
+          <a:lstStyle xmlns:a="http://schemas.openxmlformats.org/drawingml/2006/main"/>
+          <a:p xmlns:a="http://schemas.openxmlformats.org/drawingml/2006/main">
+            <a:pPr algn="r">
+              <a:buNone/>
+              <a:defRPr sz="1000">
+                <a:solidFill>
+                  <a:srgbClr val="000000"/>
+                </a:solidFill>
+                <a:latin typeface="Helvetica Neue"/>
+                <a:ea typeface="Helvetica Neue"/>
+                <a:cs typeface="Helvetica Neue"/>
+              </a:defRPr>
+            </a:pPr>
+            <a:r>
+              <a:t>22</a:t>
+            </a:r>
+          </a:p>
+        </p:txBody>
+      </p:sp>
+      <p:sp>
+        <p:nvSpPr>
+          <p:cNvPr id="2" name="title">
+            <a:extLst xmlns:a="http://schemas.openxmlformats.org/drawingml/2006/main">
+              <a:ext uri="{FF2B5EF4-FFF2-40B4-BE49-F238E27FC236}">
+                <a16:creationId xmlns:a16="http://schemas.microsoft.com/office/drawing/2014/main" id="{ECB77D9D-0CB0-4878-9A4A-2687A311CD30}"/>
+              </a:ext>
+            </a:extLst>
+          </p:cNvPr>
+          <p:cNvSpPr>
+            <a:spLocks xmlns:a="http://schemas.openxmlformats.org/drawingml/2006/main" noGrp="1"/>
+          </p:cNvSpPr>
+          <p:nvPr/>
+        </p:nvSpPr>
+        <p:spPr>
+          <a:xfrm xmlns:a="http://schemas.openxmlformats.org/drawingml/2006/main">
+            <a:off x="393668" y="344043"/>
+            <a:ext cx="5537168" cy="1143000"/>
+          </a:xfrm>
+          <a:prstGeom xmlns:a="http://schemas.openxmlformats.org/drawingml/2006/main" prst="rect">
+            <a:avLst/>
+          </a:prstGeom>
+        </p:spPr>
+        <p:txBody>
+          <a:bodyPr xmlns:a="http://schemas.openxmlformats.org/drawingml/2006/main" lIns="0" tIns="0" rIns="0" bIns="0" anchor="t">
+            <a:normAutofit fontScale="100000"/>
+          </a:bodyPr>
+          <a:lstStyle xmlns:a="http://schemas.openxmlformats.org/drawingml/2006/main"/>
+          <a:p xmlns:a="http://schemas.openxmlformats.org/drawingml/2006/main">
+            <a:pPr algn="l">
+              <a:buNone/>
+              <a:defRPr sz="2900">
+                <a:solidFill>
+                  <a:srgbClr val="000000"/>
+                </a:solidFill>
+                <a:latin typeface="Helvetica Neue"/>
+                <a:ea typeface="Helvetica Neue"/>
+                <a:cs typeface="Helvetica Neue"/>
+              </a:defRPr>
+            </a:pPr>
+            <a:r>
+              <a:t>One of 28 rows cleared the complete TRAIN conjunction</a:t>
+            </a:r>
+          </a:p>
+        </p:txBody>
+      </p:sp>
+      <p:sp>
+        <p:nvSpPr>
+          <p:cNvPr id="3" name="image-backing">
+            <a:extLst xmlns:a="http://schemas.openxmlformats.org/drawingml/2006/main">
+              <a:ext uri="{FF2B5EF4-FFF2-40B4-BE49-F238E27FC236}">
+                <a16:creationId xmlns:a16="http://schemas.microsoft.com/office/drawing/2014/main" id="{6220C938-B9AD-4B79-90E3-107E303A9D02}"/>
+              </a:ext>
+            </a:extLst>
+          </p:cNvPr>
+          <p:cNvSpPr>
+            <a:spLocks xmlns:a="http://schemas.openxmlformats.org/drawingml/2006/main" noGrp="1"/>
+          </p:cNvSpPr>
+          <p:nvPr/>
+        </p:nvSpPr>
+        <p:spPr>
+          <a:xfrm xmlns:a="http://schemas.openxmlformats.org/drawingml/2006/main">
+            <a:off x="6269069" y="396431"/>
+            <a:ext cx="5539740" cy="5602034"/>
+          </a:xfrm>
+          <a:prstGeom xmlns:a="http://schemas.openxmlformats.org/drawingml/2006/main" prst="roundRect">
+            <a:avLst>
+              <a:gd name="adj" fmla="val 1376"/>
+            </a:avLst>
+          </a:prstGeom>
+          <a:solidFill xmlns:a="http://schemas.openxmlformats.org/drawingml/2006/main">
+            <a:srgbClr val="EAF5FB"/>
+          </a:solidFill>
+          <a:ln xmlns:a="http://schemas.openxmlformats.org/drawingml/2006/main" w="9525">
+            <a:solidFill>
+              <a:srgbClr val="B8BCC4"/>
+            </a:solidFill>
+            <a:prstDash val="solid"/>
+          </a:ln>
+        </p:spPr>
+      </p:sp>
+      <p:sp>
+        <p:nvSpPr>
+          <p:cNvPr id="4" name="body">
+            <a:extLst xmlns:a="http://schemas.openxmlformats.org/drawingml/2006/main">
+              <a:ext uri="{FF2B5EF4-FFF2-40B4-BE49-F238E27FC236}">
+                <a16:creationId xmlns:a16="http://schemas.microsoft.com/office/drawing/2014/main" id="{3F760EC2-C6B5-4968-A4B1-EBAD286BA351}"/>
+              </a:ext>
+            </a:extLst>
+          </p:cNvPr>
+          <p:cNvSpPr>
+            <a:spLocks xmlns:a="http://schemas.openxmlformats.org/drawingml/2006/main" noGrp="1"/>
+          </p:cNvSpPr>
+          <p:nvPr/>
+        </p:nvSpPr>
+        <p:spPr>
+          <a:xfrm xmlns:a="http://schemas.openxmlformats.org/drawingml/2006/main">
+            <a:off x="393668" y="1695450"/>
+            <a:ext cx="5537168" cy="4238625"/>
+          </a:xfrm>
+          <a:prstGeom xmlns:a="http://schemas.openxmlformats.org/drawingml/2006/main" prst="rect">
+            <a:avLst/>
+          </a:prstGeom>
+        </p:spPr>
+        <p:txBody>
+          <a:bodyPr xmlns:a="http://schemas.openxmlformats.org/drawingml/2006/main" lIns="0" tIns="0" rIns="0" bIns="0" anchor="t">
+            <a:normAutofit fontScale="100000"/>
+          </a:bodyPr>
+          <a:lstStyle xmlns:a="http://schemas.openxmlformats.org/drawingml/2006/main"/>
+          <a:p xmlns:a="http://schemas.openxmlformats.org/drawingml/2006/main">
+            <a:pPr algn="l">
+              <a:buNone/>
+              <a:defRPr sz="1950">
+                <a:solidFill>
+                  <a:srgbClr val="000000"/>
+                </a:solidFill>
+                <a:latin typeface="Helvetica Neue"/>
+                <a:ea typeface="Helvetica Neue"/>
+                <a:cs typeface="Helvetica Neue"/>
+              </a:defRPr>
+            </a:pPr>
+            <a:r>
+              <a:t>All 28 passed integrity, I(1), and two-sided support.</a:t>
+            </a:r>
+          </a:p>
+          <a:p xmlns:a="http://schemas.openxmlformats.org/drawingml/2006/main">
+            <a:pPr algn="l">
+              <a:buNone/>
+              <a:defRPr sz="1950">
+                <a:solidFill>
+                  <a:srgbClr val="000000"/>
+                </a:solidFill>
+                <a:latin typeface="Helvetica Neue"/>
+                <a:ea typeface="Helvetica Neue"/>
+                <a:cs typeface="Helvetica Neue"/>
+              </a:defRPr>
+            </a:pPr>
+            <a:r>
+              <a:t/>
+            </a:r>
+          </a:p>
+          <a:p xmlns:a="http://schemas.openxmlformats.org/drawingml/2006/main">
+            <a:pPr algn="l">
+              <a:buNone/>
+              <a:defRPr sz="1950">
+                <a:solidFill>
+                  <a:srgbClr val="000000"/>
+                </a:solidFill>
+                <a:latin typeface="Helvetica Neue"/>
+                <a:ea typeface="Helvetica Neue"/>
+                <a:cs typeface="Helvetica Neue"/>
+              </a:defRPr>
+            </a:pPr>
+            <a:r>
+              <a:t>Ten passed exact rank one. Several produced positive means or robust convergence, but not the whole conjunction.</a:t>
+            </a:r>
+          </a:p>
+          <a:p xmlns:a="http://schemas.openxmlformats.org/drawingml/2006/main">
+            <a:pPr algn="l">
+              <a:buNone/>
+              <a:defRPr sz="1950">
+                <a:solidFill>
+                  <a:srgbClr val="000000"/>
+                </a:solidFill>
+                <a:latin typeface="Helvetica Neue"/>
+                <a:ea typeface="Helvetica Neue"/>
+                <a:cs typeface="Helvetica Neue"/>
+              </a:defRPr>
+            </a:pPr>
+            <a:r>
+              <a:t/>
+            </a:r>
+          </a:p>
+          <a:p xmlns:a="http://schemas.openxmlformats.org/drawingml/2006/main">
+            <a:pPr algn="l">
+              <a:buNone/>
+              <a:defRPr sz="1950">
+                <a:solidFill>
+                  <a:srgbClr val="000000"/>
+                </a:solidFill>
+                <a:latin typeface="Helvetica Neue"/>
+                <a:ea typeface="Helvetica Neue"/>
+                <a:cs typeface="Helvetica Neue"/>
+              </a:defRPr>
+            </a:pPr>
+            <a:r>
+              <a:t>A25 · EWA–EWC–EWZ alone passed G1–G8.</a:t>
+            </a:r>
+          </a:p>
+          <a:p xmlns:a="http://schemas.openxmlformats.org/drawingml/2006/main">
+            <a:pPr algn="l">
+              <a:buNone/>
+              <a:defRPr sz="1950">
+                <a:solidFill>
+                  <a:srgbClr val="000000"/>
+                </a:solidFill>
+                <a:latin typeface="Helvetica Neue"/>
+                <a:ea typeface="Helvetica Neue"/>
+                <a:cs typeface="Helvetica Neue"/>
+              </a:defRPr>
+            </a:pPr>
+            <a:r>
+              <a:t/>
+            </a:r>
+          </a:p>
+          <a:p xmlns:a="http://schemas.openxmlformats.org/drawingml/2006/main">
+            <a:pPr algn="l">
+              <a:buNone/>
+              <a:defRPr sz="1950">
+                <a:solidFill>
+                  <a:srgbClr val="000000"/>
+                </a:solidFill>
+                <a:latin typeface="Helvetica Neue"/>
+                <a:ea typeface="Helvetica Neue"/>
+                <a:cs typeface="Helvetica Neue"/>
+              </a:defRPr>
+            </a:pPr>
+            <a:r>
+              <a:t>Its identity and full-TRAIN vector were frozen before DEVELOPMENT was queried.</a:t>
+            </a:r>
+          </a:p>
+        </p:txBody>
+      </p:sp>
+      <p:pic>
+        <p:nvPicPr>
+          <p:cNvPr id="24" name=""/>
+          <p:cNvPicPr>
+            <a:picLocks xmlns:a="http://schemas.openxmlformats.org/drawingml/2006/main" noChangeAspect="1"/>
+          </p:cNvPicPr>
+          <p:nvPr/>
+        </p:nvPicPr>
+        <p:blipFill>
+          <a:blip xmlns:r="http://schemas.openxmlformats.org/officeDocument/2006/relationships" xmlns:a="http://schemas.openxmlformats.org/drawingml/2006/main" r:embed="R477fbb8143164b66"/>
+          <a:stretch xmlns:a="http://schemas.openxmlformats.org/drawingml/2006/main"/>
+        </p:blipFill>
+        <p:spPr>
+          <a:xfrm xmlns:a="http://schemas.openxmlformats.org/drawingml/2006/main">
+            <a:off x="7437111" y="1595005"/>
+            <a:ext cx="3204228" cy="3382241"/>
+          </a:xfrm>
+          <a:prstGeom xmlns:a="http://schemas.openxmlformats.org/drawingml/2006/main" prst="roundRect">
+            <a:avLst/>
+          </a:prstGeom>
+        </p:spPr>
+      </p:pic>
+      <p:sp>
+        <p:nvSpPr>
+          <p:cNvPr id="8" name="">
+            <a:extLst xmlns:a="http://schemas.openxmlformats.org/drawingml/2006/main">
+              <a:ext uri="{FF2B5EF4-FFF2-40B4-BE49-F238E27FC236}">
+                <a16:creationId xmlns:a16="http://schemas.microsoft.com/office/drawing/2014/main" id="{5F1B8A64-ACC9-4498-AEAE-0060DC180571}"/>
+              </a:ext>
+            </a:extLst>
+          </p:cNvPr>
+          <p:cNvSpPr>
+            <a:spLocks xmlns:a="http://schemas.openxmlformats.org/drawingml/2006/main" noGrp="1"/>
+          </p:cNvSpPr>
+          <p:nvPr/>
+        </p:nvSpPr>
+        <p:spPr>
+          <a:xfrm xmlns:a="http://schemas.openxmlformats.org/drawingml/2006/main">
+            <a:off x="6381750" y="1595005"/>
+            <a:ext cx="5314950" cy="3382241"/>
+          </a:xfrm>
+          <a:prstGeom xmlns:a="http://schemas.openxmlformats.org/drawingml/2006/main" prst="rect">
+            <a:avLst/>
+          </a:prstGeom>
+          <a:solidFill xmlns:a="http://schemas.openxmlformats.org/drawingml/2006/main">
+            <a:srgbClr val="FFFFFF"/>
+          </a:solidFill>
+          <a:ln xmlns:a="http://schemas.openxmlformats.org/drawingml/2006/main" w="0">
+            <a:solidFill>
+              <a:srgbClr val="FFFFFF"/>
+            </a:solidFill>
+            <a:prstDash val="solid"/>
+          </a:ln>
+        </p:spPr>
+      </p:sp>
+      <p:pic>
+        <p:nvPicPr>
+          <p:cNvPr id="26" name=""/>
+          <p:cNvPicPr>
+            <a:picLocks xmlns:a="http://schemas.openxmlformats.org/drawingml/2006/main" noChangeAspect="1"/>
+          </p:cNvPicPr>
+          <p:nvPr/>
+        </p:nvPicPr>
+        <p:blipFill>
+          <a:blip xmlns:r="http://schemas.openxmlformats.org/officeDocument/2006/relationships" xmlns:a="http://schemas.openxmlformats.org/drawingml/2006/main" r:embed="R58608b5e08634473"/>
+          <a:stretch xmlns:a="http://schemas.openxmlformats.org/drawingml/2006/main"/>
+        </p:blipFill>
+        <p:spPr>
+          <a:xfrm xmlns:a="http://schemas.openxmlformats.org/drawingml/2006/main">
+            <a:off x="7540649" y="1704295"/>
+            <a:ext cx="2997153" cy="3163661"/>
+          </a:xfrm>
+          <a:prstGeom xmlns:a="http://schemas.openxmlformats.org/drawingml/2006/main" prst="roundRect">
+            <a:avLst/>
+          </a:prstGeom>
+        </p:spPr>
+      </p:pic>
+      <p:sp>
+        <p:nvSpPr>
+          <p:cNvPr id="11" name="">
+            <a:extLst xmlns:a="http://schemas.openxmlformats.org/drawingml/2006/main">
+              <a:ext uri="{FF2B5EF4-FFF2-40B4-BE49-F238E27FC236}">
+                <a16:creationId xmlns:a16="http://schemas.microsoft.com/office/drawing/2014/main" id="{25209D2C-E63E-4C2B-9C87-FE274541976C}"/>
+              </a:ext>
+            </a:extLst>
+          </p:cNvPr>
+          <p:cNvSpPr>
+            <a:spLocks xmlns:a="http://schemas.openxmlformats.org/drawingml/2006/main" noGrp="1"/>
+          </p:cNvSpPr>
+          <p:nvPr/>
+        </p:nvSpPr>
+        <p:spPr>
+          <a:xfrm xmlns:a="http://schemas.openxmlformats.org/drawingml/2006/main">
+            <a:off x="6381750" y="1595005"/>
+            <a:ext cx="5314950" cy="3382241"/>
+          </a:xfrm>
+          <a:prstGeom xmlns:a="http://schemas.openxmlformats.org/drawingml/2006/main" prst="rect">
+            <a:avLst/>
+          </a:prstGeom>
+          <a:solidFill xmlns:a="http://schemas.openxmlformats.org/drawingml/2006/main">
+            <a:srgbClr val="FFFFFF"/>
+          </a:solidFill>
+          <a:ln xmlns:a="http://schemas.openxmlformats.org/drawingml/2006/main" w="0">
+            <a:solidFill>
+              <a:srgbClr val="FFFFFF"/>
+            </a:solidFill>
+            <a:prstDash val="solid"/>
+          </a:ln>
+        </p:spPr>
+      </p:sp>
+      <p:pic>
+        <p:nvPicPr>
+          <p:cNvPr id="28" name=""/>
+          <p:cNvPicPr>
+            <a:picLocks xmlns:a="http://schemas.openxmlformats.org/drawingml/2006/main" noChangeAspect="1"/>
+          </p:cNvPicPr>
+          <p:nvPr/>
+        </p:nvPicPr>
+        <p:blipFill>
+          <a:blip xmlns:r="http://schemas.openxmlformats.org/officeDocument/2006/relationships" xmlns:a="http://schemas.openxmlformats.org/drawingml/2006/main" r:embed="R2ca3ab4f592047bb"/>
+          <a:stretch xmlns:a="http://schemas.openxmlformats.org/drawingml/2006/main"/>
+        </p:blipFill>
+        <p:spPr>
+          <a:xfrm xmlns:a="http://schemas.openxmlformats.org/drawingml/2006/main">
+            <a:off x="7540649" y="1704295"/>
+            <a:ext cx="2997153" cy="3163661"/>
+          </a:xfrm>
+          <a:prstGeom xmlns:a="http://schemas.openxmlformats.org/drawingml/2006/main" prst="roundRect">
+            <a:avLst/>
+          </a:prstGeom>
+        </p:spPr>
+      </p:pic>
+      <p:sp>
+        <p:nvSpPr>
+          <p:cNvPr id="15" name="">
+            <a:extLst xmlns:a="http://schemas.openxmlformats.org/drawingml/2006/main">
+              <a:ext uri="{FF2B5EF4-FFF2-40B4-BE49-F238E27FC236}">
+                <a16:creationId xmlns:a16="http://schemas.microsoft.com/office/drawing/2014/main" id="{E253BAE9-E575-4270-B93E-0747E5B445A0}"/>
+              </a:ext>
+            </a:extLst>
+          </p:cNvPr>
+          <p:cNvSpPr>
+            <a:spLocks xmlns:a="http://schemas.openxmlformats.org/drawingml/2006/main" noGrp="1"/>
+          </p:cNvSpPr>
+          <p:nvPr/>
+        </p:nvSpPr>
+        <p:spPr>
+          <a:xfrm xmlns:a="http://schemas.openxmlformats.org/drawingml/2006/main">
+            <a:off x="6381750" y="1595005"/>
+            <a:ext cx="5314950" cy="3382241"/>
+          </a:xfrm>
+          <a:prstGeom xmlns:a="http://schemas.openxmlformats.org/drawingml/2006/main" prst="rect">
+            <a:avLst/>
+          </a:prstGeom>
+          <a:solidFill xmlns:a="http://schemas.openxmlformats.org/drawingml/2006/main">
+            <a:srgbClr val="FFFFFF"/>
+          </a:solidFill>
+          <a:ln xmlns:a="http://schemas.openxmlformats.org/drawingml/2006/main" w="0">
+            <a:solidFill>
+              <a:srgbClr val="FFFFFF"/>
+            </a:solidFill>
+            <a:prstDash val="solid"/>
+          </a:ln>
+        </p:spPr>
+      </p:sp>
+      <p:pic>
+        <p:nvPicPr>
+          <p:cNvPr id="30" name=""/>
+          <p:cNvPicPr>
+            <a:picLocks xmlns:a="http://schemas.openxmlformats.org/drawingml/2006/main" noChangeAspect="1"/>
+          </p:cNvPicPr>
+          <p:nvPr/>
+        </p:nvPicPr>
+        <p:blipFill>
+          <a:blip xmlns:r="http://schemas.openxmlformats.org/officeDocument/2006/relationships" xmlns:a="http://schemas.openxmlformats.org/drawingml/2006/main" r:embed="R66fef0b3f47c451a"/>
+          <a:stretch xmlns:a="http://schemas.openxmlformats.org/drawingml/2006/main"/>
+        </p:blipFill>
+        <p:spPr>
+          <a:xfrm xmlns:a="http://schemas.openxmlformats.org/drawingml/2006/main">
+            <a:off x="7570620" y="1735932"/>
+            <a:ext cx="2937210" cy="3100388"/>
+          </a:xfrm>
+          <a:prstGeom xmlns:a="http://schemas.openxmlformats.org/drawingml/2006/main" prst="roundRect">
+            <a:avLst/>
+          </a:prstGeom>
+        </p:spPr>
+      </p:pic>
+    </p:spTree>
+    <p:extLst>
+      <p:ext uri="{BB962C8B-B14F-4D97-AF65-F5344CB8AC3E}">
+        <p14:creationId xmlns:p14="http://schemas.microsoft.com/office/powerpoint/2010/main" val="463436756"/>
+      </p:ext>
+    </p:extLst>
+  </p:cSld>
+</p:sld>
+</file>
+
+<file path=ppt/slides/slide23.xml><?xml version="1.0" encoding="utf-8"?>
+<p:sld xmlns:p="http://schemas.openxmlformats.org/presentationml/2006/main">
+  <p:cSld>
+    <p:spTree>
+      <p:nvGrpSpPr>
+        <p:cNvPr id="1" name=""/>
+        <p:cNvGrpSpPr/>
+        <p:nvPr/>
+      </p:nvGrpSpPr>
+      <p:grpSpPr>
+        <a:xfrm xmlns:a="http://schemas.openxmlformats.org/drawingml/2006/main"/>
+      </p:grpSpPr>
+      <p:sp>
+        <p:nvSpPr>
+          <p:cNvPr id="13" name="stat-card-1">
+            <a:extLst xmlns:a="http://schemas.openxmlformats.org/drawingml/2006/main">
+              <a:ext uri="{FF2B5EF4-FFF2-40B4-BE49-F238E27FC236}">
+                <a16:creationId xmlns:a16="http://schemas.microsoft.com/office/drawing/2014/main" id="{8D249104-692F-481F-82EC-326C84E9007D}"/>
+              </a:ext>
+            </a:extLst>
+          </p:cNvPr>
+          <p:cNvSpPr>
+            <a:spLocks xmlns:a="http://schemas.openxmlformats.org/drawingml/2006/main" noGrp="1"/>
+          </p:cNvSpPr>
+          <p:nvPr/>
+        </p:nvSpPr>
+        <p:spPr>
+          <a:xfrm xmlns:a="http://schemas.openxmlformats.org/drawingml/2006/main">
+            <a:off x="393668" y="3022568"/>
+            <a:ext cx="3568732" cy="2971800"/>
+          </a:xfrm>
+          <a:prstGeom xmlns:a="http://schemas.openxmlformats.org/drawingml/2006/main" prst="roundRect">
+            <a:avLst>
+              <a:gd name="adj" fmla="val 2564"/>
+            </a:avLst>
+          </a:prstGeom>
+          <a:solidFill xmlns:a="http://schemas.openxmlformats.org/drawingml/2006/main">
+            <a:srgbClr val="F2F2F2"/>
+          </a:solidFill>
+        </p:spPr>
+      </p:sp>
+      <p:sp>
+        <p:nvSpPr>
+          <p:cNvPr id="2" name="stat-card-2">
+            <a:extLst xmlns:a="http://schemas.openxmlformats.org/drawingml/2006/main">
+              <a:ext uri="{FF2B5EF4-FFF2-40B4-BE49-F238E27FC236}">
+                <a16:creationId xmlns:a16="http://schemas.microsoft.com/office/drawing/2014/main" id="{02412AD9-1F13-493C-BF6C-FD8BDE750CD9}"/>
+              </a:ext>
+            </a:extLst>
+          </p:cNvPr>
+          <p:cNvSpPr>
+            <a:spLocks xmlns:a="http://schemas.openxmlformats.org/drawingml/2006/main" noGrp="1"/>
+          </p:cNvSpPr>
+          <p:nvPr/>
+        </p:nvSpPr>
+        <p:spPr>
+          <a:xfrm xmlns:a="http://schemas.openxmlformats.org/drawingml/2006/main">
+            <a:off x="4311682" y="3022568"/>
+            <a:ext cx="3568732" cy="2971800"/>
+          </a:xfrm>
+          <a:prstGeom xmlns:a="http://schemas.openxmlformats.org/drawingml/2006/main" prst="roundRect">
+            <a:avLst>
+              <a:gd name="adj" fmla="val 2564"/>
+            </a:avLst>
+          </a:prstGeom>
+          <a:solidFill xmlns:a="http://schemas.openxmlformats.org/drawingml/2006/main">
+            <a:srgbClr val="F2F2F2"/>
+          </a:solidFill>
+        </p:spPr>
+      </p:sp>
+      <p:sp>
+        <p:nvSpPr>
+          <p:cNvPr id="3" name="stat-card-3">
+            <a:extLst xmlns:a="http://schemas.openxmlformats.org/drawingml/2006/main">
+              <a:ext uri="{FF2B5EF4-FFF2-40B4-BE49-F238E27FC236}">
+                <a16:creationId xmlns:a16="http://schemas.microsoft.com/office/drawing/2014/main" id="{63597CCF-F233-4A0C-BCFA-192F852FDBEA}"/>
+              </a:ext>
+            </a:extLst>
+          </p:cNvPr>
+          <p:cNvSpPr>
+            <a:spLocks xmlns:a="http://schemas.openxmlformats.org/drawingml/2006/main" noGrp="1"/>
+          </p:cNvSpPr>
+          <p:nvPr/>
+        </p:nvSpPr>
+        <p:spPr>
+          <a:xfrm xmlns:a="http://schemas.openxmlformats.org/drawingml/2006/main">
+            <a:off x="8232267" y="3022568"/>
+            <a:ext cx="3568732" cy="2971800"/>
+          </a:xfrm>
+          <a:prstGeom xmlns:a="http://schemas.openxmlformats.org/drawingml/2006/main" prst="roundRect">
+            <a:avLst>
+              <a:gd name="adj" fmla="val 2564"/>
+            </a:avLst>
+          </a:prstGeom>
+          <a:solidFill xmlns:a="http://schemas.openxmlformats.org/drawingml/2006/main">
+            <a:srgbClr val="F2F2F2"/>
+          </a:solidFill>
+        </p:spPr>
+      </p:sp>
+      <p:sp>
+        <p:nvSpPr>
+          <p:cNvPr id="4" name="footer">
+            <a:extLst xmlns:a="http://schemas.openxmlformats.org/drawingml/2006/main">
+              <a:ext uri="{FF2B5EF4-FFF2-40B4-BE49-F238E27FC236}">
+                <a16:creationId xmlns:a16="http://schemas.microsoft.com/office/drawing/2014/main" id="{11E272E4-82E7-4287-91C5-21E6B629F553}"/>
+              </a:ext>
+            </a:extLst>
+          </p:cNvPr>
+          <p:cNvSpPr>
+            <a:spLocks xmlns:a="http://schemas.openxmlformats.org/drawingml/2006/main" noGrp="1"/>
+          </p:cNvSpPr>
+          <p:nvPr/>
+        </p:nvSpPr>
+        <p:spPr>
+          <a:xfrm xmlns:a="http://schemas.openxmlformats.org/drawingml/2006/main">
+            <a:off x="11279315" y="6279261"/>
+            <a:ext cx="518922" cy="241268"/>
+          </a:xfrm>
+          <a:prstGeom xmlns:a="http://schemas.openxmlformats.org/drawingml/2006/main" prst="rect">
+            <a:avLst/>
+          </a:prstGeom>
+        </p:spPr>
+        <p:txBody>
+          <a:bodyPr xmlns:a="http://schemas.openxmlformats.org/drawingml/2006/main" lIns="0" tIns="0" rIns="0" bIns="0" anchor="b"/>
+          <a:lstStyle xmlns:a="http://schemas.openxmlformats.org/drawingml/2006/main"/>
+          <a:p xmlns:a="http://schemas.openxmlformats.org/drawingml/2006/main">
+            <a:pPr algn="r">
+              <a:buNone/>
+              <a:defRPr sz="1000">
+                <a:solidFill>
+                  <a:srgbClr val="000000"/>
+                </a:solidFill>
+                <a:latin typeface="Helvetica Neue"/>
+                <a:ea typeface="Helvetica Neue"/>
+                <a:cs typeface="Helvetica Neue"/>
+              </a:defRPr>
+            </a:pPr>
+            <a:r>
+              <a:t>23</a:t>
+            </a:r>
+          </a:p>
+        </p:txBody>
+      </p:sp>
+      <p:sp>
+        <p:nvSpPr>
+          <p:cNvPr id="5" name="title">
+            <a:extLst xmlns:a="http://schemas.openxmlformats.org/drawingml/2006/main">
+              <a:ext uri="{FF2B5EF4-FFF2-40B4-BE49-F238E27FC236}">
+                <a16:creationId xmlns:a16="http://schemas.microsoft.com/office/drawing/2014/main" id="{A0ED332F-4F42-421E-99CF-097B6CBB5C19}"/>
+              </a:ext>
+            </a:extLst>
+          </p:cNvPr>
+          <p:cNvSpPr>
+            <a:spLocks xmlns:a="http://schemas.openxmlformats.org/drawingml/2006/main" noGrp="1"/>
+          </p:cNvSpPr>
+          <p:nvPr/>
+        </p:nvSpPr>
+        <p:spPr>
+          <a:xfrm xmlns:a="http://schemas.openxmlformats.org/drawingml/2006/main">
+            <a:off x="393668" y="344043"/>
+            <a:ext cx="11404568" cy="1047464"/>
+          </a:xfrm>
+          <a:prstGeom xmlns:a="http://schemas.openxmlformats.org/drawingml/2006/main" prst="rect">
+            <a:avLst/>
+          </a:prstGeom>
+        </p:spPr>
+        <p:txBody>
+          <a:bodyPr xmlns:a="http://schemas.openxmlformats.org/drawingml/2006/main" lIns="0" tIns="0" rIns="0" bIns="0" anchor="t">
+            <a:normAutofit fontScale="100000"/>
+          </a:bodyPr>
+          <a:lstStyle xmlns:a="http://schemas.openxmlformats.org/drawingml/2006/main"/>
+          <a:p xmlns:a="http://schemas.openxmlformats.org/drawingml/2006/main">
+            <a:pPr algn="l">
+              <a:buNone/>
+              <a:defRPr sz="2900">
+                <a:solidFill>
+                  <a:srgbClr val="000000"/>
+                </a:solidFill>
+                <a:latin typeface="Helvetica Neue"/>
+                <a:ea typeface="Helvetica Neue"/>
+                <a:cs typeface="Helvetica Neue"/>
+              </a:defRPr>
+            </a:pPr>
+            <a:r>
+              <a:t>EWA–EWC–EWZ earned the only TRAIN nomination</a:t>
+            </a:r>
+          </a:p>
+        </p:txBody>
+      </p:sp>
+      <p:sp>
+        <p:nvSpPr>
+          <p:cNvPr id="6" name="intro">
+            <a:extLst xmlns:a="http://schemas.openxmlformats.org/drawingml/2006/main">
+              <a:ext uri="{FF2B5EF4-FFF2-40B4-BE49-F238E27FC236}">
+                <a16:creationId xmlns:a16="http://schemas.microsoft.com/office/drawing/2014/main" id="{E3D1AF2D-950D-495D-BB07-182C768AD88F}"/>
+              </a:ext>
+            </a:extLst>
+          </p:cNvPr>
+          <p:cNvSpPr>
+            <a:spLocks xmlns:a="http://schemas.openxmlformats.org/drawingml/2006/main" noGrp="1"/>
+          </p:cNvSpPr>
+          <p:nvPr/>
+        </p:nvSpPr>
+        <p:spPr>
+          <a:xfrm xmlns:a="http://schemas.openxmlformats.org/drawingml/2006/main">
+            <a:off x="393668" y="1219200"/>
+            <a:ext cx="11404568" cy="1428750"/>
+          </a:xfrm>
+          <a:prstGeom xmlns:a="http://schemas.openxmlformats.org/drawingml/2006/main" prst="rect">
+            <a:avLst/>
+          </a:prstGeom>
+        </p:spPr>
+        <p:txBody>
+          <a:bodyPr xmlns:a="http://schemas.openxmlformats.org/drawingml/2006/main" lIns="0" tIns="0" rIns="0" bIns="0" anchor="t">
+            <a:normAutofit fontScale="100000"/>
+          </a:bodyPr>
+          <a:lstStyle xmlns:a="http://schemas.openxmlformats.org/drawingml/2006/main"/>
+          <a:p xmlns:a="http://schemas.openxmlformats.org/drawingml/2006/main">
+            <a:pPr algn="l">
+              <a:buNone/>
+              <a:defRPr sz="1650">
+                <a:solidFill>
+                  <a:srgbClr val="000000"/>
+                </a:solidFill>
+                <a:latin typeface="Helvetica Neue"/>
+                <a:ea typeface="Helvetica Neue"/>
+                <a:cs typeface="Helvetica Neue"/>
+              </a:defRPr>
+            </a:pPr>
+            <a:r>
+              <a:t>The unit portfolio was frozen as sₜ = EWAₜ − 0.6476·EWCₜ − 0.06286·EWZₜ. Price conversion then produced daily gross-normalized dollar weights without refitting β̂.</a:t>
+            </a:r>
+          </a:p>
+        </p:txBody>
+      </p:sp>
+      <p:sp>
+        <p:nvSpPr>
+          <p:cNvPr id="7" name="stat-1">
+            <a:extLst xmlns:a="http://schemas.openxmlformats.org/drawingml/2006/main">
+              <a:ext uri="{FF2B5EF4-FFF2-40B4-BE49-F238E27FC236}">
+                <a16:creationId xmlns:a16="http://schemas.microsoft.com/office/drawing/2014/main" id="{447A29C0-2600-4241-BF6B-6797417FC507}"/>
+              </a:ext>
+            </a:extLst>
+          </p:cNvPr>
+          <p:cNvSpPr>
+            <a:spLocks xmlns:a="http://schemas.openxmlformats.org/drawingml/2006/main" noGrp="1"/>
+          </p:cNvSpPr>
+          <p:nvPr/>
+        </p:nvSpPr>
+        <p:spPr>
+          <a:xfrm xmlns:a="http://schemas.openxmlformats.org/drawingml/2006/main">
+            <a:off x="702374" y="3429000"/>
+            <a:ext cx="2940082" cy="1359313"/>
+          </a:xfrm>
+          <a:prstGeom xmlns:a="http://schemas.openxmlformats.org/drawingml/2006/main" prst="rect">
+            <a:avLst/>
+          </a:prstGeom>
+        </p:spPr>
+        <p:txBody>
+          <a:bodyPr xmlns:a="http://schemas.openxmlformats.org/drawingml/2006/main" lIns="0" tIns="0" rIns="0" bIns="0" anchor="b">
+            <a:normAutofit fontScale="100000"/>
+          </a:bodyPr>
+          <a:lstStyle xmlns:a="http://schemas.openxmlformats.org/drawingml/2006/main"/>
+          <a:p xmlns:a="http://schemas.openxmlformats.org/drawingml/2006/main">
+            <a:pPr algn="l">
+              <a:buNone/>
+              <a:defRPr sz="3225">
+                <a:solidFill>
+                  <a:srgbClr val="3D8DFF"/>
+                </a:solidFill>
+                <a:latin typeface="Helvetica Neue"/>
+                <a:ea typeface="Helvetica Neue"/>
+                <a:cs typeface="Helvetica Neue"/>
+              </a:defRPr>
+            </a:pPr>
+            <a:r>
+              <a:t>8 / 8</a:t>
+            </a:r>
+          </a:p>
+        </p:txBody>
+      </p:sp>
+      <p:sp>
+        <p:nvSpPr>
+          <p:cNvPr id="8" name="stat-label-1">
+            <a:extLst xmlns:a="http://schemas.openxmlformats.org/drawingml/2006/main">
+              <a:ext uri="{FF2B5EF4-FFF2-40B4-BE49-F238E27FC236}">
+                <a16:creationId xmlns:a16="http://schemas.microsoft.com/office/drawing/2014/main" id="{1D2A853D-A304-477D-B8B8-F77F0101AC08}"/>
+              </a:ext>
+            </a:extLst>
+          </p:cNvPr>
+          <p:cNvSpPr>
+            <a:spLocks xmlns:a="http://schemas.openxmlformats.org/drawingml/2006/main" noGrp="1"/>
+          </p:cNvSpPr>
+          <p:nvPr/>
+        </p:nvSpPr>
+        <p:spPr>
+          <a:xfrm xmlns:a="http://schemas.openxmlformats.org/drawingml/2006/main">
+            <a:off x="702374" y="4900613"/>
+            <a:ext cx="2949607" cy="819150"/>
+          </a:xfrm>
+          <a:prstGeom xmlns:a="http://schemas.openxmlformats.org/drawingml/2006/main" prst="rect">
+            <a:avLst/>
+          </a:prstGeom>
+        </p:spPr>
+        <p:txBody>
+          <a:bodyPr xmlns:a="http://schemas.openxmlformats.org/drawingml/2006/main" lIns="0" tIns="45720" rIns="91440" bIns="45720" anchor="t">
+            <a:normAutofit fontScale="100000"/>
+          </a:bodyPr>
+          <a:lstStyle xmlns:a="http://schemas.openxmlformats.org/drawingml/2006/main"/>
+          <a:p xmlns:a="http://schemas.openxmlformats.org/drawingml/2006/main">
+            <a:pPr algn="l">
+              <a:buNone/>
+              <a:defRPr sz="1575">
+                <a:solidFill>
+                  <a:srgbClr val="000000"/>
+                </a:solidFill>
+                <a:latin typeface="Helvetica Neue"/>
+                <a:ea typeface="Helvetica Neue"/>
+                <a:cs typeface="Helvetica Neue"/>
+              </a:defRPr>
+            </a:pPr>
+            <a:r>
+              <a:t>Exact rank one · cosine .9986</a:t>
+            </a:r>
+          </a:p>
+          <a:p xmlns:a="http://schemas.openxmlformats.org/drawingml/2006/main">
+            <a:pPr algn="l">
+              <a:buNone/>
+              <a:defRPr sz="1575">
+                <a:solidFill>
+                  <a:srgbClr val="000000"/>
+                </a:solidFill>
+                <a:latin typeface="Helvetica Neue"/>
+                <a:ea typeface="Helvetica Neue"/>
+                <a:cs typeface="Helvetica Neue"/>
+              </a:defRPr>
+            </a:pPr>
+            <a:r>
+              <a:t>Half-life 8.33 sessions</a:t>
+            </a:r>
+          </a:p>
+        </p:txBody>
+      </p:sp>
+      <p:sp>
+        <p:nvSpPr>
+          <p:cNvPr id="9" name="stat-2">
+            <a:extLst xmlns:a="http://schemas.openxmlformats.org/drawingml/2006/main">
+              <a:ext uri="{FF2B5EF4-FFF2-40B4-BE49-F238E27FC236}">
+                <a16:creationId xmlns:a16="http://schemas.microsoft.com/office/drawing/2014/main" id="{342C60B8-5C35-4607-932D-DFD8E206B634}"/>
+              </a:ext>
+            </a:extLst>
+          </p:cNvPr>
+          <p:cNvSpPr>
+            <a:spLocks xmlns:a="http://schemas.openxmlformats.org/drawingml/2006/main" noGrp="1"/>
+          </p:cNvSpPr>
+          <p:nvPr/>
+        </p:nvSpPr>
+        <p:spPr>
+          <a:xfrm xmlns:a="http://schemas.openxmlformats.org/drawingml/2006/main">
+            <a:off x="4612958" y="3429000"/>
+            <a:ext cx="2940082" cy="1359313"/>
+          </a:xfrm>
+          <a:prstGeom xmlns:a="http://schemas.openxmlformats.org/drawingml/2006/main" prst="rect">
+            <a:avLst/>
+          </a:prstGeom>
+        </p:spPr>
+        <p:txBody>
+          <a:bodyPr xmlns:a="http://schemas.openxmlformats.org/drawingml/2006/main" lIns="0" tIns="0" rIns="0" bIns="0" anchor="b">
+            <a:normAutofit fontScale="100000"/>
+          </a:bodyPr>
+          <a:lstStyle xmlns:a="http://schemas.openxmlformats.org/drawingml/2006/main"/>
+          <a:p xmlns:a="http://schemas.openxmlformats.org/drawingml/2006/main">
+            <a:pPr algn="l">
+              <a:buNone/>
+              <a:defRPr sz="3225">
+                <a:solidFill>
+                  <a:srgbClr val="000000"/>
+                </a:solidFill>
+                <a:latin typeface="Helvetica Neue"/>
+                <a:ea typeface="Helvetica Neue"/>
+                <a:cs typeface="Helvetica Neue"/>
+              </a:defRPr>
+            </a:pPr>
+            <a:r>
+              <a:t>+17.7 bp</a:t>
+            </a:r>
+          </a:p>
+        </p:txBody>
+      </p:sp>
+      <p:sp>
+        <p:nvSpPr>
+          <p:cNvPr id="10" name="stat-label-2">
+            <a:extLst xmlns:a="http://schemas.openxmlformats.org/drawingml/2006/main">
+              <a:ext uri="{FF2B5EF4-FFF2-40B4-BE49-F238E27FC236}">
+                <a16:creationId xmlns:a16="http://schemas.microsoft.com/office/drawing/2014/main" id="{3123331A-6BB6-4FC3-B18C-EE98C6A8FF13}"/>
+              </a:ext>
+            </a:extLst>
+          </p:cNvPr>
+          <p:cNvSpPr>
+            <a:spLocks xmlns:a="http://schemas.openxmlformats.org/drawingml/2006/main" noGrp="1"/>
+          </p:cNvSpPr>
+          <p:nvPr/>
+        </p:nvSpPr>
+        <p:spPr>
+          <a:xfrm xmlns:a="http://schemas.openxmlformats.org/drawingml/2006/main">
+            <a:off x="4612958" y="4900613"/>
+            <a:ext cx="2949607" cy="819150"/>
+          </a:xfrm>
+          <a:prstGeom xmlns:a="http://schemas.openxmlformats.org/drawingml/2006/main" prst="rect">
+            <a:avLst/>
+          </a:prstGeom>
+        </p:spPr>
+        <p:txBody>
+          <a:bodyPr xmlns:a="http://schemas.openxmlformats.org/drawingml/2006/main" lIns="0" tIns="45720" rIns="91440" bIns="45720" anchor="t">
+            <a:normAutofit fontScale="100000"/>
+          </a:bodyPr>
+          <a:lstStyle xmlns:a="http://schemas.openxmlformats.org/drawingml/2006/main"/>
+          <a:p xmlns:a="http://schemas.openxmlformats.org/drawingml/2006/main">
+            <a:pPr algn="l">
+              <a:buNone/>
+              <a:defRPr sz="1575">
+                <a:solidFill>
+                  <a:srgbClr val="000000"/>
+                </a:solidFill>
+                <a:latin typeface="Helvetica Neue"/>
+                <a:ea typeface="Helvetica Neue"/>
+                <a:cs typeface="Helvetica Neue"/>
+              </a:defRPr>
+            </a:pPr>
+            <a:r>
+              <a:t>89 completed TRAIN trades</a:t>
+            </a:r>
+          </a:p>
+          <a:p xmlns:a="http://schemas.openxmlformats.org/drawingml/2006/main">
+            <a:pPr algn="l">
+              <a:buNone/>
+              <a:defRPr sz="1575">
+                <a:solidFill>
+                  <a:srgbClr val="000000"/>
+                </a:solidFill>
+                <a:latin typeface="Helvetica Neue"/>
+                <a:ea typeface="Helvetica Neue"/>
+                <a:cs typeface="Helvetica Neue"/>
+              </a:defRPr>
+            </a:pPr>
+            <a:r>
+              <a:t>Lower 95% bound +1.81 bp</a:t>
+            </a:r>
+          </a:p>
+        </p:txBody>
+      </p:sp>
+      <p:sp>
+        <p:nvSpPr>
+          <p:cNvPr id="11" name="stat-3">
+            <a:extLst xmlns:a="http://schemas.openxmlformats.org/drawingml/2006/main">
+              <a:ext uri="{FF2B5EF4-FFF2-40B4-BE49-F238E27FC236}">
+                <a16:creationId xmlns:a16="http://schemas.microsoft.com/office/drawing/2014/main" id="{A0AD0C21-BC31-4957-B0CB-525311D4386F}"/>
+              </a:ext>
+            </a:extLst>
+          </p:cNvPr>
+          <p:cNvSpPr>
+            <a:spLocks xmlns:a="http://schemas.openxmlformats.org/drawingml/2006/main" noGrp="1"/>
+          </p:cNvSpPr>
+          <p:nvPr/>
+        </p:nvSpPr>
+        <p:spPr>
+          <a:xfrm xmlns:a="http://schemas.openxmlformats.org/drawingml/2006/main">
+            <a:off x="8562404" y="3429000"/>
+            <a:ext cx="2940082" cy="1359313"/>
+          </a:xfrm>
+          <a:prstGeom xmlns:a="http://schemas.openxmlformats.org/drawingml/2006/main" prst="rect">
+            <a:avLst/>
+          </a:prstGeom>
+        </p:spPr>
+        <p:txBody>
+          <a:bodyPr xmlns:a="http://schemas.openxmlformats.org/drawingml/2006/main" lIns="0" tIns="0" rIns="0" bIns="0" anchor="b">
+            <a:normAutofit fontScale="100000"/>
+          </a:bodyPr>
+          <a:lstStyle xmlns:a="http://schemas.openxmlformats.org/drawingml/2006/main"/>
+          <a:p xmlns:a="http://schemas.openxmlformats.org/drawingml/2006/main">
+            <a:pPr algn="l">
+              <a:buNone/>
+              <a:defRPr sz="3225">
+                <a:solidFill>
+                  <a:srgbClr val="000000"/>
+                </a:solidFill>
+                <a:latin typeface="Helvetica Neue"/>
+                <a:ea typeface="Helvetica Neue"/>
+                <a:cs typeface="Helvetica Neue"/>
+              </a:defRPr>
+            </a:pPr>
+            <a:r>
+              <a:t>−0.127</a:t>
+            </a:r>
+          </a:p>
+        </p:txBody>
+      </p:sp>
+      <p:sp>
+        <p:nvSpPr>
+          <p:cNvPr id="12" name="stat-label-3">
+            <a:extLst xmlns:a="http://schemas.openxmlformats.org/drawingml/2006/main">
+              <a:ext uri="{FF2B5EF4-FFF2-40B4-BE49-F238E27FC236}">
+                <a16:creationId xmlns:a16="http://schemas.microsoft.com/office/drawing/2014/main" id="{86C9D445-5711-4319-B967-D72E959CA06D}"/>
+              </a:ext>
+            </a:extLst>
+          </p:cNvPr>
+          <p:cNvSpPr>
+            <a:spLocks xmlns:a="http://schemas.openxmlformats.org/drawingml/2006/main" noGrp="1"/>
+          </p:cNvSpPr>
+          <p:nvPr/>
+        </p:nvSpPr>
+        <p:spPr>
+          <a:xfrm xmlns:a="http://schemas.openxmlformats.org/drawingml/2006/main">
+            <a:off x="8562404" y="4900613"/>
+            <a:ext cx="2949607" cy="819150"/>
+          </a:xfrm>
+          <a:prstGeom xmlns:a="http://schemas.openxmlformats.org/drawingml/2006/main" prst="rect">
+            <a:avLst/>
+          </a:prstGeom>
+        </p:spPr>
+        <p:txBody>
+          <a:bodyPr xmlns:a="http://schemas.openxmlformats.org/drawingml/2006/main" lIns="0" tIns="45720" rIns="91440" bIns="45720" anchor="t">
+            <a:normAutofit fontScale="100000"/>
+          </a:bodyPr>
+          <a:lstStyle xmlns:a="http://schemas.openxmlformats.org/drawingml/2006/main"/>
+          <a:p xmlns:a="http://schemas.openxmlformats.org/drawingml/2006/main">
+            <a:pPr algn="l">
+              <a:buNone/>
+              <a:defRPr sz="1575">
+                <a:solidFill>
+                  <a:srgbClr val="000000"/>
+                </a:solidFill>
+                <a:latin typeface="Helvetica Neue"/>
+                <a:ea typeface="Helvetica Neue"/>
+                <a:cs typeface="Helvetica Neue"/>
+              </a:defRPr>
+            </a:pPr>
+            <a:r>
+              <a:t>Forward-five correlation</a:t>
+            </a:r>
+          </a:p>
+          <a:p xmlns:a="http://schemas.openxmlformats.org/drawingml/2006/main">
+            <a:pPr algn="l">
+              <a:buNone/>
+              <a:defRPr sz="1575">
+                <a:solidFill>
+                  <a:srgbClr val="000000"/>
+                </a:solidFill>
+                <a:latin typeface="Helvetica Neue"/>
+                <a:ea typeface="Helvetica Neue"/>
+                <a:cs typeface="Helvetica Neue"/>
+              </a:defRPr>
+            </a:pPr>
+            <a:r>
+              <a:t>Upper 95% bound −0.0249</a:t>
+            </a:r>
+          </a:p>
+        </p:txBody>
+      </p:sp>
+    </p:spTree>
+    <p:extLst>
+      <p:ext uri="{BB962C8B-B14F-4D97-AF65-F5344CB8AC3E}">
+        <p14:creationId xmlns:p14="http://schemas.microsoft.com/office/powerpoint/2010/main" val="2098249639"/>
+      </p:ext>
+    </p:extLst>
+  </p:cSld>
+</p:sld>
+</file>
+
+<file path=ppt/slides/slide24.xml><?xml version="1.0" encoding="utf-8"?>
+<p:sld xmlns:p="http://schemas.openxmlformats.org/presentationml/2006/main">
+  <p:cSld>
+    <p:spTree>
+      <p:nvGrpSpPr>
+        <p:cNvPr id="1" name=""/>
+        <p:cNvGrpSpPr/>
+        <p:nvPr/>
+      </p:nvGrpSpPr>
+      <p:grpSpPr>
+        <a:xfrm xmlns:a="http://schemas.openxmlformats.org/drawingml/2006/main"/>
+      </p:grpSpPr>
+      <p:sp>
+        <p:nvSpPr>
+          <p:cNvPr id="6" name="footer">
+            <a:extLst xmlns:a="http://schemas.openxmlformats.org/drawingml/2006/main">
+              <a:ext uri="{FF2B5EF4-FFF2-40B4-BE49-F238E27FC236}">
+                <a16:creationId xmlns:a16="http://schemas.microsoft.com/office/drawing/2014/main" id="{5D1F4916-B18D-4F3F-8812-75A699D9A639}"/>
+              </a:ext>
+            </a:extLst>
+          </p:cNvPr>
+          <p:cNvSpPr>
+            <a:spLocks xmlns:a="http://schemas.openxmlformats.org/drawingml/2006/main" noGrp="1"/>
+          </p:cNvSpPr>
+          <p:nvPr/>
+        </p:nvSpPr>
+        <p:spPr>
+          <a:xfrm xmlns:a="http://schemas.openxmlformats.org/drawingml/2006/main">
+            <a:off x="11279315" y="6279261"/>
+            <a:ext cx="518922" cy="241268"/>
+          </a:xfrm>
+          <a:prstGeom xmlns:a="http://schemas.openxmlformats.org/drawingml/2006/main" prst="rect">
+            <a:avLst/>
+          </a:prstGeom>
+        </p:spPr>
+        <p:txBody>
+          <a:bodyPr xmlns:a="http://schemas.openxmlformats.org/drawingml/2006/main" lIns="0" tIns="0" rIns="0" bIns="0" anchor="b"/>
+          <a:lstStyle xmlns:a="http://schemas.openxmlformats.org/drawingml/2006/main"/>
+          <a:p xmlns:a="http://schemas.openxmlformats.org/drawingml/2006/main">
+            <a:pPr algn="r">
+              <a:buNone/>
+              <a:defRPr sz="1000">
+                <a:solidFill>
+                  <a:srgbClr val="000000"/>
+                </a:solidFill>
+                <a:latin typeface="Helvetica Neue"/>
+                <a:ea typeface="Helvetica Neue"/>
+                <a:cs typeface="Helvetica Neue"/>
+              </a:defRPr>
+            </a:pPr>
+            <a:r>
+              <a:t>24</a:t>
+            </a:r>
+          </a:p>
+        </p:txBody>
+      </p:sp>
+      <p:sp>
+        <p:nvSpPr>
+          <p:cNvPr id="2" name="title">
+            <a:extLst xmlns:a="http://schemas.openxmlformats.org/drawingml/2006/main">
+              <a:ext uri="{FF2B5EF4-FFF2-40B4-BE49-F238E27FC236}">
+                <a16:creationId xmlns:a16="http://schemas.microsoft.com/office/drawing/2014/main" id="{ECB77D9D-0CB0-4878-9A4A-2687A311CD30}"/>
+              </a:ext>
+            </a:extLst>
+          </p:cNvPr>
+          <p:cNvSpPr>
+            <a:spLocks xmlns:a="http://schemas.openxmlformats.org/drawingml/2006/main" noGrp="1"/>
+          </p:cNvSpPr>
+          <p:nvPr/>
+        </p:nvSpPr>
+        <p:spPr>
+          <a:xfrm xmlns:a="http://schemas.openxmlformats.org/drawingml/2006/main">
+            <a:off x="393668" y="295275"/>
+            <a:ext cx="11404568" cy="876300"/>
+          </a:xfrm>
+          <a:prstGeom xmlns:a="http://schemas.openxmlformats.org/drawingml/2006/main" prst="rect">
+            <a:avLst/>
+          </a:prstGeom>
+        </p:spPr>
+        <p:txBody>
+          <a:bodyPr xmlns:a="http://schemas.openxmlformats.org/drawingml/2006/main" lIns="0" tIns="0" rIns="0" bIns="0" anchor="t">
+            <a:normAutofit fontScale="100000"/>
+          </a:bodyPr>
+          <a:lstStyle xmlns:a="http://schemas.openxmlformats.org/drawingml/2006/main"/>
+          <a:p xmlns:a="http://schemas.openxmlformats.org/drawingml/2006/main">
+            <a:pPr algn="l">
+              <a:buNone/>
+              <a:defRPr sz="2900">
+                <a:solidFill>
+                  <a:srgbClr val="000000"/>
+                </a:solidFill>
+                <a:latin typeface="Helvetica Neue"/>
+                <a:ea typeface="Helvetica Neue"/>
+                <a:cs typeface="Helvetica Neue"/>
+              </a:defRPr>
+            </a:pPr>
+            <a:r>
+              <a:t>The frozen vector stayed positive OOS—but the margin was thin</a:t>
+            </a:r>
+          </a:p>
+        </p:txBody>
+      </p:sp>
+      <p:pic>
+        <p:nvPicPr>
+          <p:cNvPr id="13" name=""/>
+          <p:cNvPicPr>
+            <a:picLocks xmlns:a="http://schemas.openxmlformats.org/drawingml/2006/main" noChangeAspect="1"/>
+          </p:cNvPicPr>
+          <p:nvPr/>
+        </p:nvPicPr>
+        <p:blipFill>
+          <a:blip xmlns:r="http://schemas.openxmlformats.org/officeDocument/2006/relationships" xmlns:a="http://schemas.openxmlformats.org/drawingml/2006/main" r:embed="Raa8482896da545e8"/>
+          <a:stretch xmlns:a="http://schemas.openxmlformats.org/drawingml/2006/main"/>
+        </p:blipFill>
+        <p:spPr>
+          <a:xfrm xmlns:a="http://schemas.openxmlformats.org/drawingml/2006/main">
+            <a:off x="2662238" y="1162050"/>
+            <a:ext cx="6867525" cy="4905375"/>
+          </a:xfrm>
+          <a:prstGeom xmlns:a="http://schemas.openxmlformats.org/drawingml/2006/main" prst="rect">
+            <a:avLst/>
+          </a:prstGeom>
+        </p:spPr>
+      </p:pic>
+      <p:sp>
+        <p:nvSpPr>
+          <p:cNvPr id="8" name="">
+            <a:extLst xmlns:a="http://schemas.openxmlformats.org/drawingml/2006/main">
+              <a:ext uri="{FF2B5EF4-FFF2-40B4-BE49-F238E27FC236}">
+                <a16:creationId xmlns:a16="http://schemas.microsoft.com/office/drawing/2014/main" id="{C58B68AB-291F-48F5-A4D0-74A8DF95C102}"/>
+              </a:ext>
+            </a:extLst>
+          </p:cNvPr>
+          <p:cNvSpPr>
+            <a:spLocks xmlns:a="http://schemas.openxmlformats.org/drawingml/2006/main" noGrp="1"/>
+          </p:cNvSpPr>
+          <p:nvPr/>
+        </p:nvSpPr>
+        <p:spPr>
+          <a:xfrm xmlns:a="http://schemas.openxmlformats.org/drawingml/2006/main">
+            <a:off x="1891393" y="1162050"/>
+            <a:ext cx="8409214" cy="4905375"/>
+          </a:xfrm>
+          <a:prstGeom xmlns:a="http://schemas.openxmlformats.org/drawingml/2006/main" prst="rect">
+            <a:avLst/>
+          </a:prstGeom>
+          <a:solidFill xmlns:a="http://schemas.openxmlformats.org/drawingml/2006/main">
+            <a:srgbClr val="FFFFFF"/>
+          </a:solidFill>
+          <a:ln xmlns:a="http://schemas.openxmlformats.org/drawingml/2006/main" w="0">
+            <a:solidFill>
+              <a:srgbClr val="FFFFFF"/>
+            </a:solidFill>
+            <a:prstDash val="solid"/>
+          </a:ln>
+        </p:spPr>
+      </p:sp>
+      <p:pic>
+        <p:nvPicPr>
+          <p:cNvPr id="15" name=""/>
+          <p:cNvPicPr>
+            <a:picLocks xmlns:a="http://schemas.openxmlformats.org/drawingml/2006/main" noChangeAspect="1"/>
+          </p:cNvPicPr>
+          <p:nvPr/>
+        </p:nvPicPr>
+        <p:blipFill>
+          <a:blip xmlns:r="http://schemas.openxmlformats.org/officeDocument/2006/relationships" xmlns:a="http://schemas.openxmlformats.org/drawingml/2006/main" r:embed="Rd80f336d6df9485a"/>
+          <a:stretch xmlns:a="http://schemas.openxmlformats.org/drawingml/2006/main"/>
+        </p:blipFill>
+        <p:spPr>
+          <a:xfrm xmlns:a="http://schemas.openxmlformats.org/drawingml/2006/main">
+            <a:off x="2723555" y="1205848"/>
+            <a:ext cx="6744891" cy="4817779"/>
+          </a:xfrm>
+          <a:prstGeom xmlns:a="http://schemas.openxmlformats.org/drawingml/2006/main" prst="rect">
+            <a:avLst/>
+          </a:prstGeom>
+        </p:spPr>
+      </p:pic>
+    </p:spTree>
+    <p:extLst>
+      <p:ext uri="{BB962C8B-B14F-4D97-AF65-F5344CB8AC3E}">
+        <p14:creationId xmlns:p14="http://schemas.microsoft.com/office/powerpoint/2010/main" val="463436756"/>
+      </p:ext>
+    </p:extLst>
+  </p:cSld>
+</p:sld>
+</file>
+
+<file path=ppt/slides/slide25.xml><?xml version="1.0" encoding="utf-8"?>
+<p:sld xmlns:p="http://schemas.openxmlformats.org/presentationml/2006/main">
+  <p:cSld>
+    <p:spTree>
+      <p:nvGrpSpPr>
+        <p:cNvPr id="1" name=""/>
+        <p:cNvGrpSpPr/>
+        <p:nvPr/>
+      </p:nvGrpSpPr>
+      <p:grpSpPr>
+        <a:xfrm xmlns:a="http://schemas.openxmlformats.org/drawingml/2006/main"/>
+      </p:grpSpPr>
+      <p:sp>
+        <p:nvSpPr>
+          <p:cNvPr id="4" name="cover-headline">
+            <a:extLst xmlns:a="http://schemas.openxmlformats.org/drawingml/2006/main">
+              <a:ext uri="{FF2B5EF4-FFF2-40B4-BE49-F238E27FC236}">
+                <a16:creationId xmlns:a16="http://schemas.microsoft.com/office/drawing/2014/main" id="{E9F43BB9-4202-4A42-9916-7A06678333BD}"/>
+              </a:ext>
+            </a:extLst>
+          </p:cNvPr>
+          <p:cNvSpPr>
+            <a:spLocks xmlns:a="http://schemas.openxmlformats.org/drawingml/2006/main" noGrp="1"/>
+          </p:cNvSpPr>
+          <p:nvPr/>
+        </p:nvSpPr>
+        <p:spPr>
+          <a:xfrm xmlns:a="http://schemas.openxmlformats.org/drawingml/2006/main">
+            <a:off x="393668" y="1738789"/>
+            <a:ext cx="10287000" cy="2491454"/>
+          </a:xfrm>
+          <a:prstGeom xmlns:a="http://schemas.openxmlformats.org/drawingml/2006/main" prst="rect">
+            <a:avLst/>
+          </a:prstGeom>
+        </p:spPr>
+        <p:txBody>
+          <a:bodyPr xmlns:a="http://schemas.openxmlformats.org/drawingml/2006/main" lIns="0" tIns="0" rIns="0" bIns="0" anchor="b">
+            <a:normAutofit fontScale="95603"/>
+          </a:bodyPr>
+          <a:lstStyle xmlns:a="http://schemas.openxmlformats.org/drawingml/2006/main"/>
+          <a:p xmlns:a="http://schemas.openxmlformats.org/drawingml/2006/main">
+            <a:pPr algn="l">
+              <a:buNone/>
+              <a:defRPr sz="5700">
+                <a:solidFill>
+                  <a:srgbClr val="000000"/>
+                </a:solidFill>
+                <a:latin typeface="Helvetica Neue"/>
+                <a:ea typeface="Helvetica Neue"/>
+                <a:cs typeface="Helvetica Neue"/>
+              </a:defRPr>
+            </a:pPr>
+            <a:r>
+              <a:t>A strict gate found a real OOS candidate.</a:t>
+            </a:r>
+          </a:p>
+          <a:p xmlns:a="http://schemas.openxmlformats.org/drawingml/2006/main">
+            <a:pPr algn="l">
+              <a:buNone/>
+              <a:defRPr sz="5700">
+                <a:solidFill>
+                  <a:srgbClr val="000000"/>
+                </a:solidFill>
+                <a:latin typeface="Helvetica Neue"/>
+                <a:ea typeface="Helvetica Neue"/>
+                <a:cs typeface="Helvetica Neue"/>
+              </a:defRPr>
+            </a:pPr>
+            <a:r>
+              <a:t>Costs still set the boundary.</a:t>
+            </a:r>
+          </a:p>
+        </p:txBody>
+      </p:sp>
+      <p:sp>
+        <p:nvSpPr>
+          <p:cNvPr id="2" name="cover-subtitle">
+            <a:extLst xmlns:a="http://schemas.openxmlformats.org/drawingml/2006/main">
+              <a:ext uri="{FF2B5EF4-FFF2-40B4-BE49-F238E27FC236}">
+                <a16:creationId xmlns:a16="http://schemas.microsoft.com/office/drawing/2014/main" id="{F6F90063-BA30-438B-9FD3-13AA22719785}"/>
+              </a:ext>
+            </a:extLst>
+          </p:cNvPr>
+          <p:cNvSpPr>
+            <a:spLocks xmlns:a="http://schemas.openxmlformats.org/drawingml/2006/main" noGrp="1"/>
+          </p:cNvSpPr>
+          <p:nvPr/>
+        </p:nvSpPr>
+        <p:spPr>
+          <a:xfrm xmlns:a="http://schemas.openxmlformats.org/drawingml/2006/main">
+            <a:off x="393668" y="4762500"/>
+            <a:ext cx="8001000" cy="1238250"/>
+          </a:xfrm>
+          <a:prstGeom xmlns:a="http://schemas.openxmlformats.org/drawingml/2006/main" prst="rect">
+            <a:avLst/>
+          </a:prstGeom>
+        </p:spPr>
+        <p:txBody>
+          <a:bodyPr xmlns:a="http://schemas.openxmlformats.org/drawingml/2006/main" lIns="0" tIns="0" rIns="0" bIns="0">
+            <a:normAutofit fontScale="95435"/>
+          </a:bodyPr>
+          <a:lstStyle xmlns:a="http://schemas.openxmlformats.org/drawingml/2006/main"/>
+          <a:p xmlns:a="http://schemas.openxmlformats.org/drawingml/2006/main">
+            <a:pPr algn="l">
+              <a:buNone/>
+              <a:defRPr sz="2250">
+                <a:solidFill>
+                  <a:srgbClr val="000000"/>
+                </a:solidFill>
+                <a:latin typeface="Helvetica Neue"/>
+                <a:ea typeface="Helvetica Neue"/>
+                <a:cs typeface="Helvetica Neue"/>
+              </a:defRPr>
+            </a:pPr>
+            <a:r>
+              <a:t>Preserve the modest +3.73% primary-cost OOS result and the −3.23% stress result together. Keep 2024+ sealed, and do not relax pair or triplet gates until a separately frozen discussion becomes a new contract.</a:t>
+            </a:r>
+          </a:p>
+        </p:txBody>
+      </p:sp>
+      <p:sp>
+        <p:nvSpPr>
+          <p:cNvPr id="3" name="cover-eyebrow">
+            <a:extLst xmlns:a="http://schemas.openxmlformats.org/drawingml/2006/main">
+              <a:ext uri="{FF2B5EF4-FFF2-40B4-BE49-F238E27FC236}">
+                <a16:creationId xmlns:a16="http://schemas.microsoft.com/office/drawing/2014/main" id="{45129715-75DE-4D50-B44D-3AFE3EBA3F0E}"/>
+              </a:ext>
+            </a:extLst>
+          </p:cNvPr>
+          <p:cNvSpPr>
+            <a:spLocks xmlns:a="http://schemas.openxmlformats.org/drawingml/2006/main" noGrp="1"/>
+          </p:cNvSpPr>
+          <p:nvPr/>
+        </p:nvSpPr>
+        <p:spPr>
+          <a:xfrm xmlns:a="http://schemas.openxmlformats.org/drawingml/2006/main">
+            <a:off x="393668" y="392240"/>
+            <a:ext cx="7239000" cy="649129"/>
+          </a:xfrm>
+          <a:prstGeom xmlns:a="http://schemas.openxmlformats.org/drawingml/2006/main" prst="rect">
+            <a:avLst/>
+          </a:prstGeom>
+        </p:spPr>
+        <p:txBody>
+          <a:bodyPr xmlns:a="http://schemas.openxmlformats.org/drawingml/2006/main" lIns="0" tIns="0" rIns="0" bIns="0">
+            <a:normAutofit fontScale="100000"/>
+          </a:bodyPr>
+          <a:lstStyle xmlns:a="http://schemas.openxmlformats.org/drawingml/2006/main"/>
+          <a:p xmlns:a="http://schemas.openxmlformats.org/drawingml/2006/main">
+            <a:pPr algn="l">
+              <a:buNone/>
+              <a:defRPr sz="2250">
+                <a:solidFill>
+                  <a:srgbClr val="000000"/>
+                </a:solidFill>
+                <a:latin typeface="Helvetica Neue"/>
+                <a:ea typeface="Helvetica Neue"/>
+                <a:cs typeface="Helvetica Neue"/>
+              </a:defRPr>
+            </a:pPr>
+            <a:r>
+              <a:t>LIT-MR-03.1 | OOS DEVELOPMENT COMPLETE</a:t>
+            </a:r>
+          </a:p>
+        </p:txBody>
+      </p:sp>
+    </p:spTree>
+    <p:extLst>
+      <p:ext uri="{BB962C8B-B14F-4D97-AF65-F5344CB8AC3E}">
+        <p14:creationId xmlns:p14="http://schemas.microsoft.com/office/powerpoint/2010/main" val="1664240194"/>
       </p:ext>
     </p:extLst>
   </p:cSld>
@@ -7758,14 +11464,14 @@
       </p:sp>
       <p:pic>
         <p:nvPicPr>
-          <p:cNvPr id="17" name=""/>
+          <p:cNvPr id="19" name=""/>
           <p:cNvPicPr>
             <a:picLocks xmlns:a="http://schemas.openxmlformats.org/drawingml/2006/main" noChangeAspect="1"/>
           </p:cNvPicPr>
           <p:nvPr/>
         </p:nvPicPr>
         <p:blipFill>
-          <a:blip xmlns:r="http://schemas.openxmlformats.org/officeDocument/2006/relationships" xmlns:a="http://schemas.openxmlformats.org/drawingml/2006/main" r:embed="Rde3cc0e97e7845ad"/>
+          <a:blip xmlns:r="http://schemas.openxmlformats.org/officeDocument/2006/relationships" xmlns:a="http://schemas.openxmlformats.org/drawingml/2006/main" r:embed="R2c8ac36563b141a2"/>
           <a:stretch xmlns:a="http://schemas.openxmlformats.org/drawingml/2006/main"/>
         </p:blipFill>
         <p:spPr>
@@ -7813,14 +11519,14 @@
       </p:sp>
       <p:pic>
         <p:nvPicPr>
-          <p:cNvPr id="19" name=""/>
+          <p:cNvPr id="21" name=""/>
           <p:cNvPicPr>
             <a:picLocks xmlns:a="http://schemas.openxmlformats.org/drawingml/2006/main" noChangeAspect="1"/>
           </p:cNvPicPr>
           <p:nvPr/>
         </p:nvPicPr>
         <p:blipFill>
-          <a:blip xmlns:r="http://schemas.openxmlformats.org/officeDocument/2006/relationships" xmlns:a="http://schemas.openxmlformats.org/drawingml/2006/main" r:embed="Rb926537c619a451e"/>
+          <a:blip xmlns:r="http://schemas.openxmlformats.org/officeDocument/2006/relationships" xmlns:a="http://schemas.openxmlformats.org/drawingml/2006/main" r:embed="R90f98dc3b0a34484"/>
           <a:stretch xmlns:a="http://schemas.openxmlformats.org/drawingml/2006/main"/>
         </p:blipFill>
         <p:spPr>
@@ -7868,14 +11574,14 @@
       </p:sp>
       <p:pic>
         <p:nvPicPr>
-          <p:cNvPr id="21" name=""/>
+          <p:cNvPr id="23" name=""/>
           <p:cNvPicPr>
             <a:picLocks xmlns:a="http://schemas.openxmlformats.org/drawingml/2006/main" noChangeAspect="1"/>
           </p:cNvPicPr>
           <p:nvPr/>
         </p:nvPicPr>
         <p:blipFill>
-          <a:blip xmlns:r="http://schemas.openxmlformats.org/officeDocument/2006/relationships" xmlns:a="http://schemas.openxmlformats.org/drawingml/2006/main" r:embed="R17b552f3cec64b0a"/>
+          <a:blip xmlns:r="http://schemas.openxmlformats.org/officeDocument/2006/relationships" xmlns:a="http://schemas.openxmlformats.org/drawingml/2006/main" r:embed="R56341cdfd38f4e34"/>
           <a:stretch xmlns:a="http://schemas.openxmlformats.org/drawingml/2006/main"/>
         </p:blipFill>
         <p:spPr>

</xml_diff>